<commit_message>
Rebuild deck: 16 slides, colour figures, corrected Focal Tversky numbers
The saved .pptx had been stuck at the 14-slide version since the build could
not write over an open file. Adds the cumulative-results slide and the
precision/recall appendix, picks up all seven recoloured figures, and carries
the +0.013 correction into the speaker notes.

Every figure and number regenerates from models/*/log.csv via make_figures.py
and make_pptx.py.
</commit_message>
<xml_diff>
--- a/UNeXt_presentation.pptx
+++ b/UNeXt_presentation.pptx
@@ -19,6 +19,8 @@
     <p:sldId id="267" r:id="rId19"/>
     <p:sldId id="268" r:id="rId20"/>
     <p:sldId id="269" r:id="rId21"/>
+    <p:sldId id="270" r:id="rId22"/>
+    <p:sldId id="271" r:id="rId23"/>
   </p:sldIdLst>
   <p:sldSz cx="12191695" cy="6858000" type="screen4x3"/>
   <p:notesSz cx="6858000" cy="9144000"/>
@@ -4012,7 +4014,7 @@
                           </a:solidFill>
                           <a:latin typeface="Calibri"/>
                         </a:rPr>
-                        <a:t>+0.006</a:t>
+                        <a:t>+0.006  (1 split)</a:t>
                       </a:r>
                     </a:p>
                   </a:txBody>
@@ -4035,7 +4037,7 @@
                           </a:solidFill>
                           <a:latin typeface="Calibri"/>
                         </a:rPr>
-                        <a:t>+0.017</a:t>
+                        <a:t>+0.013  (3 splits)</a:t>
                       </a:r>
                     </a:p>
                   </a:txBody>
@@ -4161,7 +4163,7 @@
                 </a:solidFill>
                 <a:latin typeface="Calibri"/>
               </a:rPr>
-              <a:t> — swapping Dice for Focal Tversky in the loss raised IoU by +0.017 for </a:t>
+              <a:t> — swapping Dice for Focal Tversky in the loss raised IoU by +0.013 across three splits, for </a:t>
             </a:r>
             <a:r>
               <a:rPr sz="1350" b="1" i="0">
@@ -4179,7 +4181,7 @@
                 </a:solidFill>
                 <a:latin typeface="Calibri"/>
               </a:rPr>
-              <a:t>.</a:t>
+              <a:t> (next slide).</a:t>
             </a:r>
           </a:p>
         </p:txBody>
@@ -4355,8 +4357,8 @@
           <p:nvPr/>
         </p:nvGraphicFramePr>
         <p:xfrm>
-          <a:off x="548640" y="2651760"/>
-          <a:ext cx="10241279" cy="2377440"/>
+          <a:off x="548640" y="2514600"/>
+          <a:ext cx="10607039" cy="2651760"/>
         </p:xfrm>
         <a:graphic>
           <a:graphicData uri="http://schemas.openxmlformats.org/drawingml/2006/table">
@@ -4365,11 +4367,11 @@
                 <a:tableStyleId>{5C22544A-7EE6-4342-B048-85BDC9FD1C3A}</a:tableStyleId>
               </a:tblPr>
               <a:tblGrid>
-                <a:gridCol w="4923692"/>
-                <a:gridCol w="2363372"/>
-                <a:gridCol w="2954215"/>
+                <a:gridCol w="4435671"/>
+                <a:gridCol w="2892829"/>
+                <a:gridCol w="3278539"/>
               </a:tblGrid>
-              <a:tr h="396240">
+              <a:tr h="378822">
                 <a:tc>
                   <a:txBody>
                     <a:bodyPr wrap="square"/>
@@ -4377,13 +4379,13 @@
                     <a:p>
                       <a:pPr algn="l"/>
                       <a:r>
-                        <a:rPr sz="1300" b="1" i="0">
-                          <a:solidFill>
-                            <a:srgbClr val="000000"/>
-                          </a:solidFill>
-                          <a:latin typeface="Calibri"/>
-                        </a:rPr>
-                        <a:t>Seed 43 (identical config, loss swapped)</a:t>
+                        <a:rPr sz="1200" b="1" i="0">
+                          <a:solidFill>
+                            <a:srgbClr val="000000"/>
+                          </a:solidFill>
+                          <a:latin typeface="Calibri"/>
+                        </a:rPr>
+                        <a:t>All 3 splits, on top of strong augmentation</a:t>
                       </a:r>
                     </a:p>
                   </a:txBody>
@@ -4400,7 +4402,7 @@
                     <a:p>
                       <a:pPr algn="ctr"/>
                       <a:r>
-                        <a:rPr sz="1300" b="1" i="0">
+                        <a:rPr sz="1200" b="1" i="0">
                           <a:solidFill>
                             <a:srgbClr val="000000"/>
                           </a:solidFill>
@@ -4423,7 +4425,7 @@
                     <a:p>
                       <a:pPr algn="ctr"/>
                       <a:r>
-                        <a:rPr sz="1300" b="1" i="0">
+                        <a:rPr sz="1200" b="1" i="0">
                           <a:solidFill>
                             <a:srgbClr val="000000"/>
                           </a:solidFill>
@@ -4440,7 +4442,7 @@
                   </a:tcPr>
                 </a:tc>
               </a:tr>
-              <a:tr h="396240">
+              <a:tr h="378822">
                 <a:tc>
                   <a:txBody>
                     <a:bodyPr wrap="square"/>
@@ -4448,13 +4450,13 @@
                     <a:p>
                       <a:pPr algn="l"/>
                       <a:r>
-                        <a:rPr sz="1300" b="0" i="0">
-                          <a:solidFill>
-                            <a:srgbClr val="000000"/>
-                          </a:solidFill>
-                          <a:latin typeface="Calibri"/>
-                        </a:rPr>
-                        <a:t>Best IoU</a:t>
+                        <a:rPr sz="1200" b="0" i="0">
+                          <a:solidFill>
+                            <a:srgbClr val="000000"/>
+                          </a:solidFill>
+                          <a:latin typeface="Calibri"/>
+                        </a:rPr>
+                        <a:t>seed 41 / 42 / 43 — best IoU</a:t>
                       </a:r>
                     </a:p>
                   </a:txBody>
@@ -4471,13 +4473,13 @@
                     <a:p>
                       <a:pPr algn="ctr"/>
                       <a:r>
-                        <a:rPr sz="1300" b="0" i="0">
-                          <a:solidFill>
-                            <a:srgbClr val="000000"/>
-                          </a:solidFill>
-                          <a:latin typeface="Calibri"/>
-                        </a:rPr>
-                        <a:t>0.6464</a:t>
+                        <a:rPr sz="1200" b="0" i="0">
+                          <a:solidFill>
+                            <a:srgbClr val="000000"/>
+                          </a:solidFill>
+                          <a:latin typeface="Calibri"/>
+                        </a:rPr>
+                        <a:t>0.6215 / 0.6306 / 0.6464</a:t>
                       </a:r>
                     </a:p>
                   </a:txBody>
@@ -4494,13 +4496,13 @@
                     <a:p>
                       <a:pPr algn="ctr"/>
                       <a:r>
-                        <a:rPr sz="1300" b="1" i="0">
-                          <a:solidFill>
-                            <a:srgbClr val="000000"/>
-                          </a:solidFill>
-                          <a:latin typeface="Calibri"/>
-                        </a:rPr>
-                        <a:t>0.6629  (+0.017)</a:t>
+                        <a:rPr sz="1200" b="0" i="0">
+                          <a:solidFill>
+                            <a:srgbClr val="000000"/>
+                          </a:solidFill>
+                          <a:latin typeface="Calibri"/>
+                        </a:rPr>
+                        <a:t>0.6397 / 0.6359 / 0.6629</a:t>
                       </a:r>
                     </a:p>
                   </a:txBody>
@@ -4511,7 +4513,7 @@
                   </a:tcPr>
                 </a:tc>
               </a:tr>
-              <a:tr h="396240">
+              <a:tr h="378822">
                 <a:tc>
                   <a:txBody>
                     <a:bodyPr wrap="square"/>
@@ -4519,13 +4521,13 @@
                     <a:p>
                       <a:pPr algn="l"/>
                       <a:r>
-                        <a:rPr sz="1300" b="0" i="0">
-                          <a:solidFill>
-                            <a:srgbClr val="000000"/>
-                          </a:solidFill>
-                          <a:latin typeface="Calibri"/>
-                        </a:rPr>
-                        <a:t>Dice (aggregate)</a:t>
+                        <a:rPr sz="1200" b="1" i="0">
+                          <a:solidFill>
+                            <a:srgbClr val="000000"/>
+                          </a:solidFill>
+                          <a:latin typeface="Calibri"/>
+                        </a:rPr>
+                        <a:t>Mean IoU</a:t>
                       </a:r>
                     </a:p>
                   </a:txBody>
@@ -4542,13 +4544,13 @@
                     <a:p>
                       <a:pPr algn="ctr"/>
                       <a:r>
-                        <a:rPr sz="1300" b="0" i="0">
-                          <a:solidFill>
-                            <a:srgbClr val="000000"/>
-                          </a:solidFill>
-                          <a:latin typeface="Calibri"/>
-                        </a:rPr>
-                        <a:t>0.7798</a:t>
+                        <a:rPr sz="1200" b="1" i="0">
+                          <a:solidFill>
+                            <a:srgbClr val="000000"/>
+                          </a:solidFill>
+                          <a:latin typeface="Calibri"/>
+                        </a:rPr>
+                        <a:t>0.6328 ± 0.0126</a:t>
                       </a:r>
                     </a:p>
                   </a:txBody>
@@ -4565,13 +4567,13 @@
                     <a:p>
                       <a:pPr algn="ctr"/>
                       <a:r>
-                        <a:rPr sz="1300" b="1" i="0">
-                          <a:solidFill>
-                            <a:srgbClr val="000000"/>
-                          </a:solidFill>
-                          <a:latin typeface="Calibri"/>
-                        </a:rPr>
-                        <a:t>0.7906</a:t>
+                        <a:rPr sz="1200" b="1" i="0">
+                          <a:solidFill>
+                            <a:srgbClr val="000000"/>
+                          </a:solidFill>
+                          <a:latin typeface="Calibri"/>
+                        </a:rPr>
+                        <a:t>0.6461 ± 0.0146  (+0.013)</a:t>
                       </a:r>
                     </a:p>
                   </a:txBody>
@@ -4582,7 +4584,7 @@
                   </a:tcPr>
                 </a:tc>
               </a:tr>
-              <a:tr h="396240">
+              <a:tr h="378822">
                 <a:tc>
                   <a:txBody>
                     <a:bodyPr wrap="square"/>
@@ -4590,13 +4592,13 @@
                     <a:p>
                       <a:pPr algn="l"/>
                       <a:r>
-                        <a:rPr sz="1300" b="0" i="0">
-                          <a:solidFill>
-                            <a:srgbClr val="000000"/>
-                          </a:solidFill>
-                          <a:latin typeface="Calibri"/>
-                        </a:rPr>
-                        <a:t>Recall — of true tumour pixels, fraction found</a:t>
+                        <a:rPr sz="1200" b="0" i="0">
+                          <a:solidFill>
+                            <a:srgbClr val="000000"/>
+                          </a:solidFill>
+                          <a:latin typeface="Calibri"/>
+                        </a:rPr>
+                        <a:t>Mean Dice</a:t>
                       </a:r>
                     </a:p>
                   </a:txBody>
@@ -4613,7 +4615,78 @@
                     <a:p>
                       <a:pPr algn="ctr"/>
                       <a:r>
-                        <a:rPr sz="1300" b="0" i="0">
+                        <a:rPr sz="1200" b="0" i="0">
+                          <a:solidFill>
+                            <a:srgbClr val="000000"/>
+                          </a:solidFill>
+                          <a:latin typeface="Calibri"/>
+                        </a:rPr>
+                        <a:t>0.7718 ± 0.0013</a:t>
+                      </a:r>
+                    </a:p>
+                  </a:txBody>
+                  <a:tcPr>
+                    <a:solidFill>
+                      <a:srgbClr val="FFFFFF"/>
+                    </a:solidFill>
+                  </a:tcPr>
+                </a:tc>
+                <a:tc>
+                  <a:txBody>
+                    <a:bodyPr wrap="square"/>
+                    <a:lstStyle/>
+                    <a:p>
+                      <a:pPr algn="ctr"/>
+                      <a:r>
+                        <a:rPr sz="1200" b="0" i="0">
+                          <a:solidFill>
+                            <a:srgbClr val="000000"/>
+                          </a:solidFill>
+                          <a:latin typeface="Calibri"/>
+                        </a:rPr>
+                        <a:t>0.7756 ± 0.0054  (+0.004)</a:t>
+                      </a:r>
+                    </a:p>
+                  </a:txBody>
+                  <a:tcPr>
+                    <a:solidFill>
+                      <a:srgbClr val="FFFFFF"/>
+                    </a:solidFill>
+                  </a:tcPr>
+                </a:tc>
+              </a:tr>
+              <a:tr h="378822">
+                <a:tc>
+                  <a:txBody>
+                    <a:bodyPr wrap="square"/>
+                    <a:lstStyle/>
+                    <a:p>
+                      <a:pPr algn="l"/>
+                      <a:r>
+                        <a:rPr sz="1200" b="0" i="0">
+                          <a:solidFill>
+                            <a:srgbClr val="000000"/>
+                          </a:solidFill>
+                          <a:latin typeface="Calibri"/>
+                        </a:rPr>
+                        <a:t>Recall (of true tumour pixels, fraction found)</a:t>
+                      </a:r>
+                    </a:p>
+                  </a:txBody>
+                  <a:tcPr>
+                    <a:solidFill>
+                      <a:srgbClr val="FFFFFF"/>
+                    </a:solidFill>
+                  </a:tcPr>
+                </a:tc>
+                <a:tc>
+                  <a:txBody>
+                    <a:bodyPr wrap="square"/>
+                    <a:lstStyle/>
+                    <a:p>
+                      <a:pPr algn="ctr"/>
+                      <a:r>
+                        <a:rPr sz="1200" b="0" i="0">
                           <a:solidFill>
                             <a:srgbClr val="000000"/>
                           </a:solidFill>
@@ -4636,7 +4709,7 @@
                     <a:p>
                       <a:pPr algn="ctr"/>
                       <a:r>
-                        <a:rPr sz="1300" b="1" i="0">
+                        <a:rPr sz="1200" b="1" i="0">
                           <a:solidFill>
                             <a:srgbClr val="000000"/>
                           </a:solidFill>
@@ -4653,7 +4726,7 @@
                   </a:tcPr>
                 </a:tc>
               </a:tr>
-              <a:tr h="396240">
+              <a:tr h="378822">
                 <a:tc>
                   <a:txBody>
                     <a:bodyPr wrap="square"/>
@@ -4661,13 +4734,13 @@
                     <a:p>
                       <a:pPr algn="l"/>
                       <a:r>
-                        <a:rPr sz="1300" b="0" i="0">
-                          <a:solidFill>
-                            <a:srgbClr val="000000"/>
-                          </a:solidFill>
-                          <a:latin typeface="Calibri"/>
-                        </a:rPr>
-                        <a:t>Precision — of predicted pixels, fraction correct</a:t>
+                        <a:rPr sz="1200" b="0" i="0">
+                          <a:solidFill>
+                            <a:srgbClr val="000000"/>
+                          </a:solidFill>
+                          <a:latin typeface="Calibri"/>
+                        </a:rPr>
+                        <a:t>Precision (of predicted pixels, fraction correct)</a:t>
                       </a:r>
                     </a:p>
                   </a:txBody>
@@ -4684,7 +4757,7 @@
                     <a:p>
                       <a:pPr algn="ctr"/>
                       <a:r>
-                        <a:rPr sz="1300" b="0" i="0">
+                        <a:rPr sz="1200" b="0" i="0">
                           <a:solidFill>
                             <a:srgbClr val="000000"/>
                           </a:solidFill>
@@ -4707,7 +4780,7 @@
                     <a:p>
                       <a:pPr algn="ctr"/>
                       <a:r>
-                        <a:rPr sz="1300" b="0" i="0">
+                        <a:rPr sz="1200" b="0" i="0">
                           <a:solidFill>
                             <a:srgbClr val="000000"/>
                           </a:solidFill>
@@ -4724,7 +4797,7 @@
                   </a:tcPr>
                 </a:tc>
               </a:tr>
-              <a:tr h="396240">
+              <a:tr h="378828">
                 <a:tc>
                   <a:txBody>
                     <a:bodyPr wrap="square"/>
@@ -4732,7 +4805,7 @@
                     <a:p>
                       <a:pPr algn="l"/>
                       <a:r>
-                        <a:rPr sz="1300" b="0" i="0">
+                        <a:rPr sz="1200" b="0" i="0">
                           <a:solidFill>
                             <a:srgbClr val="000000"/>
                           </a:solidFill>
@@ -4755,7 +4828,7 @@
                     <a:p>
                       <a:pPr algn="ctr"/>
                       <a:r>
-                        <a:rPr sz="1300" b="0" i="0">
+                        <a:rPr sz="1200" b="0" i="0">
                           <a:solidFill>
                             <a:srgbClr val="000000"/>
                           </a:solidFill>
@@ -4778,7 +4851,7 @@
                     <a:p>
                       <a:pPr algn="ctr"/>
                       <a:r>
-                        <a:rPr sz="1300" b="1" i="0">
+                        <a:rPr sz="1200" b="1" i="0">
                           <a:solidFill>
                             <a:srgbClr val="000000"/>
                           </a:solidFill>
@@ -4807,8 +4880,8 @@
         </p:nvSpPr>
         <p:spPr>
           <a:xfrm>
-            <a:off x="548640" y="5212080"/>
-            <a:ext cx="11094415" cy="1188720"/>
+            <a:off x="548640" y="5349240"/>
+            <a:ext cx="11094415" cy="1051560"/>
           </a:xfrm>
           <a:prstGeom prst="rect">
             <a:avLst/>
@@ -4823,42 +4896,42 @@
           <a:p>
             <a:pPr>
               <a:spcAft>
-                <a:spcPts val="600"/>
+                <a:spcPts val="500"/>
               </a:spcAft>
             </a:pPr>
             <a:r>
-              <a:rPr sz="1350" b="0" i="0">
-                <a:solidFill>
-                  <a:srgbClr val="000000"/>
-                </a:solidFill>
-                <a:latin typeface="Calibri"/>
-              </a:rPr>
-              <a:t>The mechanism worked as designed — a large recall gain for a smaller precision cost, which is the right trade when missing a tumour is worse than a false alarm.</a:t>
+              <a:rPr sz="1300" b="1" i="0">
+                <a:solidFill>
+                  <a:srgbClr val="000000"/>
+                </a:solidFill>
+                <a:latin typeface="Calibri"/>
+              </a:rPr>
+              <a:t>IoU improved on all three splits</a:t>
+            </a:r>
+            <a:r>
+              <a:rPr sz="1300" b="0" i="0">
+                <a:solidFill>
+                  <a:srgbClr val="000000"/>
+                </a:solidFill>
+                <a:latin typeface="Calibri"/>
+              </a:rPr>
+              <a:t> (+0.018, +0.005, +0.017), paired t-test p = 0.081. Consistent in direction, but the magnitude varies by split — and Dice barely moves.</a:t>
             </a:r>
           </a:p>
           <a:p>
             <a:pPr>
               <a:spcAft>
-                <a:spcPts val="600"/>
+                <a:spcPts val="500"/>
               </a:spcAft>
             </a:pPr>
             <a:r>
-              <a:rPr sz="1350" b="1" i="0">
-                <a:solidFill>
-                  <a:srgbClr val="000000"/>
-                </a:solidFill>
-                <a:latin typeface="Calibri"/>
-              </a:rPr>
-              <a:t>Caveat:</a:t>
-            </a:r>
-            <a:r>
-              <a:rPr sz="1350" b="0" i="0">
-                <a:solidFill>
-                  <a:srgbClr val="000000"/>
-                </a:solidFill>
-                <a:latin typeface="Calibri"/>
-              </a:rPr>
-              <a:t> replicated on 2 of 3 splits so far (+0.017, +0.018); the third is still running. Promising, not yet proven.</a:t>
+              <a:rPr sz="1300" b="0" i="0">
+                <a:solidFill>
+                  <a:srgbClr val="000000"/>
+                </a:solidFill>
+                <a:latin typeface="Calibri"/>
+              </a:rPr>
+              <a:t>The mechanism worked as designed: a large recall gain for a smaller precision cost — the right trade when missing a tumour is worse than a false alarm.</a:t>
             </a:r>
           </a:p>
         </p:txBody>
@@ -4918,21 +4991,56 @@
                 </a:solidFill>
                 <a:latin typeface="Calibri"/>
               </a:rPr>
-              <a:t>Challenges</a:t>
-            </a:r>
-          </a:p>
-        </p:txBody>
-      </p:sp>
-      <p:sp>
-        <p:nvSpPr>
-          <p:cNvPr id="3" name="TextBox 2"/>
+              <a:t>Both changes stack — and neither costs anything</a:t>
+            </a:r>
+          </a:p>
+          <a:p>
+            <a:r>
+              <a:rPr sz="1400" b="0" i="1">
+                <a:solidFill>
+                  <a:srgbClr val="555555"/>
+                </a:solidFill>
+                <a:latin typeface="Calibri"/>
+              </a:rPr>
+              <a:t>Paper recipe → + strong augmentation → + Focal Tversky loss, 3 splits</a:t>
+            </a:r>
+          </a:p>
+        </p:txBody>
+      </p:sp>
+      <p:pic>
+        <p:nvPicPr>
+          <p:cNvPr id="3" name="Picture 2" descr="fig6_cumulative.png"/>
+          <p:cNvPicPr>
+            <a:picLocks noChangeAspect="1"/>
+          </p:cNvPicPr>
+          <p:nvPr/>
+        </p:nvPicPr>
+        <p:blipFill>
+          <a:blip r:embed="rId2"/>
+          <a:stretch>
+            <a:fillRect/>
+          </a:stretch>
+        </p:blipFill>
+        <p:spPr>
+          <a:xfrm>
+            <a:off x="792327" y="1280160"/>
+            <a:ext cx="10607040" cy="4058346"/>
+          </a:xfrm>
+          <a:prstGeom prst="rect">
+            <a:avLst/>
+          </a:prstGeom>
+        </p:spPr>
+      </p:pic>
+      <p:sp>
+        <p:nvSpPr>
+          <p:cNvPr id="4" name="TextBox 3"/>
           <p:cNvSpPr txBox="1"/>
           <p:nvPr/>
         </p:nvSpPr>
         <p:spPr>
           <a:xfrm>
-            <a:off x="548640" y="1371600"/>
-            <a:ext cx="11094415" cy="5029200"/>
+            <a:off x="548640" y="5394960"/>
+            <a:ext cx="11094415" cy="1005840"/>
           </a:xfrm>
           <a:prstGeom prst="rect">
             <a:avLst/>
@@ -4947,119 +5055,44 @@
           <a:p>
             <a:pPr>
               <a:spcAft>
-                <a:spcPts val="1400"/>
+                <a:spcPts val="1000"/>
               </a:spcAft>
             </a:pPr>
             <a:r>
-              <a:rPr sz="1500" b="1" i="0">
-                <a:solidFill>
-                  <a:srgbClr val="000000"/>
-                </a:solidFill>
-                <a:latin typeface="Calibri"/>
-              </a:rPr>
-              <a:t>1. A real bug in the upstream code.</a:t>
-            </a:r>
-            <a:r>
-              <a:rPr sz="1500" b="0" i="0">
-                <a:solidFill>
-                  <a:srgbClr val="000000"/>
-                </a:solidFill>
-                <a:latin typeface="Calibri"/>
-              </a:rPr>
-              <a:t> dataset.py divides by 255 *after* Normalize() has already applied ImageNet statistics — squashing inputs from ±2.5 into </a:t>
-            </a:r>
-            <a:r>
-              <a:rPr sz="1500" b="1" i="0">
-                <a:solidFill>
-                  <a:srgbClr val="000000"/>
-                </a:solidFill>
-                <a:latin typeface="Calibri"/>
-              </a:rPr>
-              <a:t>±0.01</a:t>
-            </a:r>
-            <a:r>
-              <a:rPr sz="1500" b="0" i="0">
-                <a:solidFill>
-                  <a:srgbClr val="000000"/>
-                </a:solidFill>
-                <a:latin typeface="Calibri"/>
-              </a:rPr>
-              <a:t> and discarding most of the signal. Found by inspecting tensors, not from any error.</a:t>
-            </a:r>
-          </a:p>
-          <a:p>
-            <a:pPr>
-              <a:spcAft>
-                <a:spcPts val="1400"/>
-              </a:spcAft>
-            </a:pPr>
-            <a:r>
-              <a:rPr sz="1500" b="1" i="0">
-                <a:solidFill>
-                  <a:srgbClr val="000000"/>
-                </a:solidFill>
-                <a:latin typeface="Calibri"/>
-              </a:rPr>
-              <a:t>2. Frozen BatchNorm is not frozen.</a:t>
-            </a:r>
-            <a:r>
-              <a:rPr sz="1500" b="0" i="0">
-                <a:solidFill>
-                  <a:srgbClr val="000000"/>
-                </a:solidFill>
-                <a:latin typeface="Calibri"/>
-              </a:rPr>
-              <a:t> requires_grad=False stops gradients but not the running mean/variance buffers — our "frozen" backbone would have drifted silently, invalidating the attribution.</a:t>
-            </a:r>
-          </a:p>
-          <a:p>
-            <a:pPr>
-              <a:spcAft>
-                <a:spcPts val="1400"/>
-              </a:spcAft>
-            </a:pPr>
-            <a:r>
-              <a:rPr sz="1500" b="1" i="0">
-                <a:solidFill>
-                  <a:srgbClr val="000000"/>
-                </a:solidFill>
-                <a:latin typeface="Calibri"/>
-              </a:rPr>
-              <a:t>3. Identity-grafting is delicate.</a:t>
-            </a:r>
-            <a:r>
-              <a:rPr sz="1500" b="0" i="0">
-                <a:solidFill>
-                  <a:srgbClr val="000000"/>
-                </a:solidFill>
-                <a:latin typeface="Calibri"/>
-              </a:rPr>
-              <a:t> Inserting SE naively halves every activation; initialising too conservatively saturates the sigmoid so it cannot learn. Starting as an exact identity *and* staying trainable took several attempts.</a:t>
-            </a:r>
-          </a:p>
-          <a:p>
-            <a:pPr>
-              <a:spcAft>
-                <a:spcPts val="1400"/>
-              </a:spcAft>
-            </a:pPr>
-            <a:r>
-              <a:rPr sz="1500" b="1" i="0">
-                <a:solidFill>
-                  <a:srgbClr val="000000"/>
-                </a:solidFill>
-                <a:latin typeface="Calibri"/>
-              </a:rPr>
-              <a:t>4. A 2022 repo on a 2026 stack</a:t>
-            </a:r>
-            <a:r>
-              <a:rPr sz="1500" b="0" i="0">
-                <a:solidFill>
-                  <a:srgbClr val="000000"/>
-                </a:solidFill>
-                <a:latin typeface="Calibri"/>
-              </a:rPr>
-              <a:t> — dead dependencies, and no released weights to validate against.</a:t>
+              <a:rPr sz="1400" b="1" i="0">
+                <a:solidFill>
+                  <a:srgbClr val="000000"/>
+                </a:solidFill>
+                <a:latin typeface="Calibri"/>
+              </a:rPr>
+              <a:t>0.5931 → 0.6461 IoU (+0.053)</a:t>
+            </a:r>
+            <a:r>
+              <a:rPr sz="1400" b="0" i="0">
+                <a:solidFill>
+                  <a:srgbClr val="000000"/>
+                </a:solidFill>
+                <a:latin typeface="Calibri"/>
+              </a:rPr>
+              <a:t> — about </a:t>
+            </a:r>
+            <a:r>
+              <a:rPr sz="1400" b="1" i="0">
+                <a:solidFill>
+                  <a:srgbClr val="000000"/>
+                </a:solidFill>
+                <a:latin typeface="Calibri"/>
+              </a:rPr>
+              <a:t>70% of the original gap</a:t>
+            </a:r>
+            <a:r>
+              <a:rPr sz="1400" b="0" i="0">
+                <a:solidFill>
+                  <a:srgbClr val="000000"/>
+                </a:solidFill>
+                <a:latin typeface="Calibri"/>
+              </a:rPr>
+              <a:t> to the paper, with the model unchanged: still 1,471,921 parameters and 0.577 GFLOPs.</a:t>
             </a:r>
           </a:p>
         </p:txBody>
@@ -5119,7 +5152,7 @@
                 </a:solidFill>
                 <a:latin typeface="Calibri"/>
               </a:rPr>
-              <a:t>Conclusions</a:t>
+              <a:t>Challenges</a:t>
             </a:r>
           </a:p>
         </p:txBody>
@@ -5148,7 +5181,7 @@
           <a:p>
             <a:pPr>
               <a:spcAft>
-                <a:spcPts val="1100"/>
+                <a:spcPts val="1400"/>
               </a:spcAft>
             </a:pPr>
             <a:r>
@@ -5158,7 +5191,7 @@
                 </a:solidFill>
                 <a:latin typeface="Calibri"/>
               </a:rPr>
-              <a:t>What reproduced — the efficiency claims, exactly.</a:t>
+              <a:t>1. A real bug in the upstream code.</a:t>
             </a:r>
             <a:r>
               <a:rPr sz="1500" b="0" i="0">
@@ -5167,13 +5200,31 @@
                 </a:solidFill>
                 <a:latin typeface="Calibri"/>
               </a:rPr>
-              <a:t> 1,471,921 parameters (paper: 1.47 M), 0.577 GFLOPs (paper: 0.57), 12.5 ms on CPU. UNeXt really is 72× smaller than TransUNet.</a:t>
+              <a:t> dataset.py divides by 255 *after* Normalize() has already applied ImageNet statistics — squashing inputs from ±2.5 into </a:t>
+            </a:r>
+            <a:r>
+              <a:rPr sz="1500" b="1" i="0">
+                <a:solidFill>
+                  <a:srgbClr val="000000"/>
+                </a:solidFill>
+                <a:latin typeface="Calibri"/>
+              </a:rPr>
+              <a:t>±0.01</a:t>
+            </a:r>
+            <a:r>
+              <a:rPr sz="1500" b="0" i="0">
+                <a:solidFill>
+                  <a:srgbClr val="000000"/>
+                </a:solidFill>
+                <a:latin typeface="Calibri"/>
+              </a:rPr>
+              <a:t> and discarding most of the signal. Found by inspecting tensors, not from any error.</a:t>
             </a:r>
           </a:p>
           <a:p>
             <a:pPr>
               <a:spcAft>
-                <a:spcPts val="1100"/>
+                <a:spcPts val="1400"/>
               </a:spcAft>
             </a:pPr>
             <a:r>
@@ -5183,7 +5234,7 @@
                 </a:solidFill>
                 <a:latin typeface="Calibri"/>
               </a:rPr>
-              <a:t>What did not — the accuracy.</a:t>
+              <a:t>2. Frozen BatchNorm is not frozen.</a:t>
             </a:r>
             <a:r>
               <a:rPr sz="1500" b="0" i="0">
@@ -5192,20 +5243,38 @@
                 </a:solidFill>
                 <a:latin typeface="Calibri"/>
               </a:rPr>
-              <a:t> 0.593 vs 0.669 IoU, across six runs, with five explanations eliminated and no released weights to check against.</a:t>
+              <a:t> requires_grad=False stops gradients but not the running mean/variance buffers — our "frozen" backbone would have drifted silently, invalidating the attribution.</a:t>
             </a:r>
           </a:p>
           <a:p>
             <a:pPr>
               <a:spcAft>
-                <a:spcPts val="1100"/>
+                <a:spcPts val="1400"/>
               </a:spcAft>
             </a:pPr>
+            <a:r>
+              <a:rPr sz="1500" b="1" i="0">
+                <a:solidFill>
+                  <a:srgbClr val="000000"/>
+                </a:solidFill>
+                <a:latin typeface="Calibri"/>
+              </a:rPr>
+              <a:t>3. Identity-grafting is delicate.</a:t>
+            </a:r>
+            <a:r>
+              <a:rPr sz="1500" b="0" i="0">
+                <a:solidFill>
+                  <a:srgbClr val="000000"/>
+                </a:solidFill>
+                <a:latin typeface="Calibri"/>
+              </a:rPr>
+              <a:t> Inserting SE naively halves every activation; initialising too conservatively saturates the sigmoid so it cannot learn. Starting as an exact identity *and* staying trainable took several attempts.</a:t>
+            </a:r>
           </a:p>
           <a:p>
             <a:pPr>
               <a:spcAft>
-                <a:spcPts val="1100"/>
+                <a:spcPts val="1400"/>
               </a:spcAft>
             </a:pPr>
             <a:r>
@@ -5215,134 +5284,16 @@
                 </a:solidFill>
                 <a:latin typeface="Calibri"/>
               </a:rPr>
-              <a:t>What we learned:</a:t>
-            </a:r>
-          </a:p>
-          <a:p>
-            <a:pPr lvl="1">
-              <a:spcAft>
-                <a:spcPts val="1100"/>
-              </a:spcAft>
-            </a:pPr>
-            <a:r>
-              <a:rPr sz="1400" b="0" i="0">
-                <a:solidFill>
-                  <a:srgbClr val="555555"/>
-                </a:solidFill>
-                <a:latin typeface="Calibri"/>
-              </a:rPr>
-              <a:t>The likely cause is </a:t>
-            </a:r>
-            <a:r>
-              <a:rPr sz="1400" b="1" i="0">
-                <a:solidFill>
-                  <a:srgbClr val="555555"/>
-                </a:solidFill>
-                <a:latin typeface="Calibri"/>
-              </a:rPr>
-              <a:t>under-regularization</a:t>
-            </a:r>
-            <a:r>
-              <a:rPr sz="1400" b="0" i="0">
-                <a:solidFill>
-                  <a:srgbClr val="555555"/>
-                </a:solidFill>
-                <a:latin typeface="Calibri"/>
-              </a:rPr>
-              <a:t> — the paper's augmentation cannot support 518 training images, and every run overfits hard</a:t>
-            </a:r>
-          </a:p>
-          <a:p>
-            <a:pPr lvl="1">
-              <a:spcAft>
-                <a:spcPts val="1100"/>
-              </a:spcAft>
-            </a:pPr>
-            <a:r>
-              <a:rPr sz="1400" b="0" i="0">
-                <a:solidFill>
-                  <a:srgbClr val="555555"/>
-                </a:solidFill>
-                <a:latin typeface="Calibri"/>
-              </a:rPr>
-              <a:t>Fixing that recovers </a:t>
-            </a:r>
-            <a:r>
-              <a:rPr sz="1400" b="1" i="0">
-                <a:solidFill>
-                  <a:srgbClr val="555555"/>
-                </a:solidFill>
-                <a:latin typeface="Calibri"/>
-              </a:rPr>
-              <a:t>half the gap</a:t>
-            </a:r>
-            <a:r>
-              <a:rPr sz="1400" b="0" i="0">
-                <a:solidFill>
-                  <a:srgbClr val="555555"/>
-                </a:solidFill>
-                <a:latin typeface="Calibri"/>
-              </a:rPr>
-              <a:t> (+0.040 IoU, all three splits)</a:t>
-            </a:r>
-          </a:p>
-          <a:p>
-            <a:pPr lvl="1">
-              <a:spcAft>
-                <a:spcPts val="1100"/>
-              </a:spcAft>
-            </a:pPr>
-            <a:r>
-              <a:rPr sz="1400" b="0" i="0">
-                <a:solidFill>
-                  <a:srgbClr val="555555"/>
-                </a:solidFill>
-                <a:latin typeface="Calibri"/>
-              </a:rPr>
-              <a:t>The architectural modifications from follow-up papers recovered </a:t>
-            </a:r>
-            <a:r>
-              <a:rPr sz="1400" b="1" i="0">
-                <a:solidFill>
-                  <a:srgbClr val="555555"/>
-                </a:solidFill>
-                <a:latin typeface="Calibri"/>
-              </a:rPr>
-              <a:t>essentially nothing</a:t>
-            </a:r>
-          </a:p>
-        </p:txBody>
-      </p:sp>
-      <p:sp>
-        <p:nvSpPr>
-          <p:cNvPr id="4" name="TextBox 3"/>
-          <p:cNvSpPr txBox="1"/>
-          <p:nvPr/>
-        </p:nvSpPr>
-        <p:spPr>
-          <a:xfrm>
-            <a:off x="548640" y="5532120"/>
-            <a:ext cx="11094415" cy="731520"/>
-          </a:xfrm>
-          <a:prstGeom prst="rect">
-            <a:avLst/>
-          </a:prstGeom>
-          <a:noFill/>
-        </p:spPr>
-        <p:txBody>
-          <a:bodyPr wrap="square">
-            <a:spAutoFit/>
-          </a:bodyPr>
-          <a:lstStyle/>
-          <a:p>
-            <a:r>
-              <a:rPr sz="1700" b="1" i="0">
-                <a:solidFill>
-                  <a:srgbClr val="000000"/>
-                </a:solidFill>
-                <a:latin typeface="Calibri"/>
-              </a:rPr>
-              <a:t>Takeaway: for this network on this dataset, the training recipe mattered far more than the architecture.</a:t>
+              <a:t>4. A 2022 repo on a 2026 stack</a:t>
+            </a:r>
+            <a:r>
+              <a:rPr sz="1500" b="0" i="0">
+                <a:solidFill>
+                  <a:srgbClr val="000000"/>
+                </a:solidFill>
+                <a:latin typeface="Calibri"/>
+              </a:rPr>
+              <a:t> — dead dependencies, and no released weights to validate against.</a:t>
             </a:r>
           </a:p>
         </p:txBody>
@@ -5402,6 +5353,307 @@
                 </a:solidFill>
                 <a:latin typeface="Calibri"/>
               </a:rPr>
+              <a:t>Conclusions</a:t>
+            </a:r>
+          </a:p>
+        </p:txBody>
+      </p:sp>
+      <p:sp>
+        <p:nvSpPr>
+          <p:cNvPr id="3" name="TextBox 2"/>
+          <p:cNvSpPr txBox="1"/>
+          <p:nvPr/>
+        </p:nvSpPr>
+        <p:spPr>
+          <a:xfrm>
+            <a:off x="548640" y="1371600"/>
+            <a:ext cx="11094415" cy="5029200"/>
+          </a:xfrm>
+          <a:prstGeom prst="rect">
+            <a:avLst/>
+          </a:prstGeom>
+          <a:noFill/>
+        </p:spPr>
+        <p:txBody>
+          <a:bodyPr wrap="square">
+            <a:spAutoFit/>
+          </a:bodyPr>
+          <a:lstStyle/>
+          <a:p>
+            <a:pPr>
+              <a:spcAft>
+                <a:spcPts val="1100"/>
+              </a:spcAft>
+            </a:pPr>
+            <a:r>
+              <a:rPr sz="1500" b="1" i="0">
+                <a:solidFill>
+                  <a:srgbClr val="000000"/>
+                </a:solidFill>
+                <a:latin typeface="Calibri"/>
+              </a:rPr>
+              <a:t>What reproduced — the efficiency claims, exactly.</a:t>
+            </a:r>
+            <a:r>
+              <a:rPr sz="1500" b="0" i="0">
+                <a:solidFill>
+                  <a:srgbClr val="000000"/>
+                </a:solidFill>
+                <a:latin typeface="Calibri"/>
+              </a:rPr>
+              <a:t> 1,471,921 parameters (paper: 1.47 M), 0.577 GFLOPs (paper: 0.57), 12.5 ms on CPU. UNeXt really is 72× smaller than TransUNet.</a:t>
+            </a:r>
+          </a:p>
+          <a:p>
+            <a:pPr>
+              <a:spcAft>
+                <a:spcPts val="1100"/>
+              </a:spcAft>
+            </a:pPr>
+            <a:r>
+              <a:rPr sz="1500" b="1" i="0">
+                <a:solidFill>
+                  <a:srgbClr val="000000"/>
+                </a:solidFill>
+                <a:latin typeface="Calibri"/>
+              </a:rPr>
+              <a:t>What did not — the accuracy.</a:t>
+            </a:r>
+            <a:r>
+              <a:rPr sz="1500" b="0" i="0">
+                <a:solidFill>
+                  <a:srgbClr val="000000"/>
+                </a:solidFill>
+                <a:latin typeface="Calibri"/>
+              </a:rPr>
+              <a:t> 0.593 vs 0.669 IoU, across six runs, with five explanations eliminated and no released weights to check against.</a:t>
+            </a:r>
+          </a:p>
+          <a:p>
+            <a:pPr>
+              <a:spcAft>
+                <a:spcPts val="1100"/>
+              </a:spcAft>
+            </a:pPr>
+          </a:p>
+          <a:p>
+            <a:pPr>
+              <a:spcAft>
+                <a:spcPts val="1100"/>
+              </a:spcAft>
+            </a:pPr>
+            <a:r>
+              <a:rPr sz="1500" b="1" i="0">
+                <a:solidFill>
+                  <a:srgbClr val="000000"/>
+                </a:solidFill>
+                <a:latin typeface="Calibri"/>
+              </a:rPr>
+              <a:t>What we learned:</a:t>
+            </a:r>
+          </a:p>
+          <a:p>
+            <a:pPr lvl="1">
+              <a:spcAft>
+                <a:spcPts val="1100"/>
+              </a:spcAft>
+            </a:pPr>
+            <a:r>
+              <a:rPr sz="1400" b="0" i="0">
+                <a:solidFill>
+                  <a:srgbClr val="555555"/>
+                </a:solidFill>
+                <a:latin typeface="Calibri"/>
+              </a:rPr>
+              <a:t>The likely cause is </a:t>
+            </a:r>
+            <a:r>
+              <a:rPr sz="1400" b="1" i="0">
+                <a:solidFill>
+                  <a:srgbClr val="555555"/>
+                </a:solidFill>
+                <a:latin typeface="Calibri"/>
+              </a:rPr>
+              <a:t>under-regularization</a:t>
+            </a:r>
+            <a:r>
+              <a:rPr sz="1400" b="0" i="0">
+                <a:solidFill>
+                  <a:srgbClr val="555555"/>
+                </a:solidFill>
+                <a:latin typeface="Calibri"/>
+              </a:rPr>
+              <a:t> — the paper's augmentation cannot support 518 training images, and every run overfits hard</a:t>
+            </a:r>
+          </a:p>
+          <a:p>
+            <a:pPr lvl="1">
+              <a:spcAft>
+                <a:spcPts val="1100"/>
+              </a:spcAft>
+            </a:pPr>
+            <a:r>
+              <a:rPr sz="1400" b="0" i="0">
+                <a:solidFill>
+                  <a:srgbClr val="555555"/>
+                </a:solidFill>
+                <a:latin typeface="Calibri"/>
+              </a:rPr>
+              <a:t>Two </a:t>
+            </a:r>
+            <a:r>
+              <a:rPr sz="1400" b="1" i="0">
+                <a:solidFill>
+                  <a:srgbClr val="555555"/>
+                </a:solidFill>
+                <a:latin typeface="Calibri"/>
+              </a:rPr>
+              <a:t>training-recipe</a:t>
+            </a:r>
+            <a:r>
+              <a:rPr sz="1400" b="0" i="0">
+                <a:solidFill>
+                  <a:srgbClr val="555555"/>
+                </a:solidFill>
+                <a:latin typeface="Calibri"/>
+              </a:rPr>
+              <a:t> changes recover ~70% of the gap: augmentation (+0.040) then Focal Tversky loss (+0.013) — </a:t>
+            </a:r>
+            <a:r>
+              <a:rPr sz="1400" b="1" i="0">
+                <a:solidFill>
+                  <a:srgbClr val="555555"/>
+                </a:solidFill>
+                <a:latin typeface="Calibri"/>
+              </a:rPr>
+              <a:t>0.5931 → 0.6461</a:t>
+            </a:r>
+            <a:r>
+              <a:rPr sz="1400" b="0" i="0">
+                <a:solidFill>
+                  <a:srgbClr val="555555"/>
+                </a:solidFill>
+                <a:latin typeface="Calibri"/>
+              </a:rPr>
+              <a:t>, at zero added cost</a:t>
+            </a:r>
+          </a:p>
+          <a:p>
+            <a:pPr lvl="1">
+              <a:spcAft>
+                <a:spcPts val="1100"/>
+              </a:spcAft>
+            </a:pPr>
+            <a:r>
+              <a:rPr sz="1400" b="0" i="0">
+                <a:solidFill>
+                  <a:srgbClr val="555555"/>
+                </a:solidFill>
+                <a:latin typeface="Calibri"/>
+              </a:rPr>
+              <a:t>The architectural modifications from follow-up papers recovered </a:t>
+            </a:r>
+            <a:r>
+              <a:rPr sz="1400" b="1" i="0">
+                <a:solidFill>
+                  <a:srgbClr val="555555"/>
+                </a:solidFill>
+                <a:latin typeface="Calibri"/>
+              </a:rPr>
+              <a:t>essentially nothing</a:t>
+            </a:r>
+          </a:p>
+        </p:txBody>
+      </p:sp>
+      <p:sp>
+        <p:nvSpPr>
+          <p:cNvPr id="4" name="TextBox 3"/>
+          <p:cNvSpPr txBox="1"/>
+          <p:nvPr/>
+        </p:nvSpPr>
+        <p:spPr>
+          <a:xfrm>
+            <a:off x="548640" y="5532120"/>
+            <a:ext cx="11094415" cy="731520"/>
+          </a:xfrm>
+          <a:prstGeom prst="rect">
+            <a:avLst/>
+          </a:prstGeom>
+          <a:noFill/>
+        </p:spPr>
+        <p:txBody>
+          <a:bodyPr wrap="square">
+            <a:spAutoFit/>
+          </a:bodyPr>
+          <a:lstStyle/>
+          <a:p>
+            <a:r>
+              <a:rPr sz="1700" b="1" i="0">
+                <a:solidFill>
+                  <a:srgbClr val="000000"/>
+                </a:solidFill>
+                <a:latin typeface="Calibri"/>
+              </a:rPr>
+              <a:t>Takeaway: for this network on this dataset, the training recipe mattered far more than the architecture.</a:t>
+            </a:r>
+          </a:p>
+        </p:txBody>
+      </p:sp>
+    </p:spTree>
+  </p:cSld>
+  <p:clrMapOvr>
+    <a:masterClrMapping/>
+  </p:clrMapOvr>
+</p:sld>
+</file>
+
+<file path=ppt/slides/slide15.xml><?xml version="1.0" encoding="utf-8"?>
+<p:sld xmlns:a="http://schemas.openxmlformats.org/drawingml/2006/main" xmlns:p="http://schemas.openxmlformats.org/presentationml/2006/main" xmlns:r="http://schemas.openxmlformats.org/officeDocument/2006/relationships">
+  <p:cSld>
+    <p:bg>
+      <p:bgPr>
+        <a:solidFill>
+          <a:srgbClr val="FFFFFF"/>
+        </a:solidFill>
+        <a:effectLst/>
+      </p:bgPr>
+    </p:bg>
+    <p:spTree>
+      <p:nvGrpSpPr>
+        <p:cNvPr id="1" name=""/>
+        <p:cNvGrpSpPr/>
+        <p:nvPr/>
+      </p:nvGrpSpPr>
+      <p:grpSpPr/>
+      <p:sp>
+        <p:nvSpPr>
+          <p:cNvPr id="2" name="TextBox 1"/>
+          <p:cNvSpPr txBox="1"/>
+          <p:nvPr/>
+        </p:nvSpPr>
+        <p:spPr>
+          <a:xfrm>
+            <a:off x="548640" y="320040"/>
+            <a:ext cx="11094415" cy="822960"/>
+          </a:xfrm>
+          <a:prstGeom prst="rect">
+            <a:avLst/>
+          </a:prstGeom>
+          <a:noFill/>
+        </p:spPr>
+        <p:txBody>
+          <a:bodyPr wrap="square">
+            <a:spAutoFit/>
+          </a:bodyPr>
+          <a:lstStyle/>
+          <a:p>
+            <a:r>
+              <a:rPr sz="3000" b="1" i="0">
+                <a:solidFill>
+                  <a:srgbClr val="000000"/>
+                </a:solidFill>
+                <a:latin typeface="Calibri"/>
+              </a:rPr>
               <a:t>Appendix: qualitative results</a:t>
             </a:r>
           </a:p>
@@ -5434,8 +5686,8 @@
         </p:blipFill>
         <p:spPr>
           <a:xfrm>
-            <a:off x="3721924" y="1234440"/>
-            <a:ext cx="4747846" cy="4937760"/>
+            <a:off x="3717292" y="1234440"/>
+            <a:ext cx="4757110" cy="4937760"/>
           </a:xfrm>
           <a:prstGeom prst="rect">
             <a:avLst/>
@@ -5472,6 +5724,135 @@
                 <a:latin typeface="Calibri"/>
               </a:rPr>
               <a:t>The failure case (bottom): the model responds to hypoechoic regions at the top of the image while missing the small true lesion — small lesions on noisy scans remain hard.</a:t>
+            </a:r>
+          </a:p>
+        </p:txBody>
+      </p:sp>
+    </p:spTree>
+  </p:cSld>
+  <p:clrMapOvr>
+    <a:masterClrMapping/>
+  </p:clrMapOvr>
+</p:sld>
+</file>
+
+<file path=ppt/slides/slide16.xml><?xml version="1.0" encoding="utf-8"?>
+<p:sld xmlns:a="http://schemas.openxmlformats.org/drawingml/2006/main" xmlns:p="http://schemas.openxmlformats.org/presentationml/2006/main" xmlns:r="http://schemas.openxmlformats.org/officeDocument/2006/relationships">
+  <p:cSld>
+    <p:bg>
+      <p:bgPr>
+        <a:solidFill>
+          <a:srgbClr val="FFFFFF"/>
+        </a:solidFill>
+        <a:effectLst/>
+      </p:bgPr>
+    </p:bg>
+    <p:spTree>
+      <p:nvGrpSpPr>
+        <p:cNvPr id="1" name=""/>
+        <p:cNvGrpSpPr/>
+        <p:nvPr/>
+      </p:nvGrpSpPr>
+      <p:grpSpPr/>
+      <p:sp>
+        <p:nvSpPr>
+          <p:cNvPr id="2" name="TextBox 1"/>
+          <p:cNvSpPr txBox="1"/>
+          <p:nvPr/>
+        </p:nvSpPr>
+        <p:spPr>
+          <a:xfrm>
+            <a:off x="548640" y="320040"/>
+            <a:ext cx="11094415" cy="822960"/>
+          </a:xfrm>
+          <a:prstGeom prst="rect">
+            <a:avLst/>
+          </a:prstGeom>
+          <a:noFill/>
+        </p:spPr>
+        <p:txBody>
+          <a:bodyPr wrap="square">
+            <a:spAutoFit/>
+          </a:bodyPr>
+          <a:lstStyle/>
+          <a:p>
+            <a:r>
+              <a:rPr sz="3000" b="1" i="0">
+                <a:solidFill>
+                  <a:srgbClr val="000000"/>
+                </a:solidFill>
+                <a:latin typeface="Calibri"/>
+              </a:rPr>
+              <a:t>Appendix: what Focal Tversky actually changed</a:t>
+            </a:r>
+          </a:p>
+          <a:p>
+            <a:r>
+              <a:rPr sz="1400" b="0" i="1">
+                <a:solidFill>
+                  <a:srgbClr val="555555"/>
+                </a:solidFill>
+                <a:latin typeface="Calibri"/>
+              </a:rPr>
+              <a:t>The loss shifts the model toward finding tumour, at some cost in false alarms</a:t>
+            </a:r>
+          </a:p>
+        </p:txBody>
+      </p:sp>
+      <p:pic>
+        <p:nvPicPr>
+          <p:cNvPr id="3" name="Picture 2" descr="fig7_precision_recall.png"/>
+          <p:cNvPicPr>
+            <a:picLocks noChangeAspect="1"/>
+          </p:cNvPicPr>
+          <p:nvPr/>
+        </p:nvPicPr>
+        <p:blipFill>
+          <a:blip r:embed="rId2"/>
+          <a:stretch>
+            <a:fillRect/>
+          </a:stretch>
+        </p:blipFill>
+        <p:spPr>
+          <a:xfrm>
+            <a:off x="2804007" y="1371600"/>
+            <a:ext cx="6583680" cy="3931920"/>
+          </a:xfrm>
+          <a:prstGeom prst="rect">
+            <a:avLst/>
+          </a:prstGeom>
+        </p:spPr>
+      </p:pic>
+      <p:sp>
+        <p:nvSpPr>
+          <p:cNvPr id="4" name="TextBox 3"/>
+          <p:cNvSpPr txBox="1"/>
+          <p:nvPr/>
+        </p:nvSpPr>
+        <p:spPr>
+          <a:xfrm>
+            <a:off x="548640" y="6199632"/>
+            <a:ext cx="11094415" cy="457200"/>
+          </a:xfrm>
+          <a:prstGeom prst="rect">
+            <a:avLst/>
+          </a:prstGeom>
+          <a:noFill/>
+        </p:spPr>
+        <p:txBody>
+          <a:bodyPr wrap="square">
+            <a:spAutoFit/>
+          </a:bodyPr>
+          <a:lstStyle/>
+          <a:p>
+            <a:r>
+              <a:rPr sz="1200" b="0" i="1">
+                <a:solidFill>
+                  <a:srgbClr val="555555"/>
+                </a:solidFill>
+                <a:latin typeface="Calibri"/>
+              </a:rPr>
+              <a:t>Recall +0.065, precision −0.042 — the asymmetry the Tversky β&gt;α weighting was chosen to produce. Clinically the right direction: a missed tumour costs more than a second look.</a:t>
             </a:r>
           </a:p>
         </p:txBody>

</xml_diff>

<commit_message>
Add group members; keep ID numbers out of the public repo
The deck now carries the members' names and the architecture figure on the
solution slide. ID numbers are blanked in the committed copy: the course
requires them on the submitted presentation, but this repository is public and
national ID numbers would be permanent in git history once pushed.

UNeXt_presentation_SUBMIT.pptx (gitignored) holds the version with IDs for
submission to the course.
</commit_message>
<xml_diff>
--- a/UNeXt_presentation.pptx
+++ b/UNeXt_presentation.pptx
@@ -4,25 +4,28 @@
   <p:sldMasterIdLst>
     <p:sldMasterId id="2147483648" r:id="rId1"/>
   </p:sldMasterIdLst>
+  <p:notesMasterIdLst>
+    <p:notesMasterId r:id="rId18"/>
+  </p:notesMasterIdLst>
   <p:sldIdLst>
-    <p:sldId id="256" r:id="rId7"/>
-    <p:sldId id="257" r:id="rId9"/>
-    <p:sldId id="258" r:id="rId10"/>
-    <p:sldId id="259" r:id="rId11"/>
-    <p:sldId id="260" r:id="rId12"/>
-    <p:sldId id="261" r:id="rId13"/>
-    <p:sldId id="262" r:id="rId14"/>
-    <p:sldId id="263" r:id="rId15"/>
-    <p:sldId id="264" r:id="rId16"/>
-    <p:sldId id="265" r:id="rId17"/>
-    <p:sldId id="266" r:id="rId18"/>
-    <p:sldId id="267" r:id="rId19"/>
-    <p:sldId id="268" r:id="rId20"/>
-    <p:sldId id="269" r:id="rId21"/>
-    <p:sldId id="270" r:id="rId22"/>
-    <p:sldId id="271" r:id="rId23"/>
+    <p:sldId id="256" r:id="rId2"/>
+    <p:sldId id="257" r:id="rId3"/>
+    <p:sldId id="258" r:id="rId4"/>
+    <p:sldId id="259" r:id="rId5"/>
+    <p:sldId id="260" r:id="rId6"/>
+    <p:sldId id="261" r:id="rId7"/>
+    <p:sldId id="262" r:id="rId8"/>
+    <p:sldId id="263" r:id="rId9"/>
+    <p:sldId id="264" r:id="rId10"/>
+    <p:sldId id="265" r:id="rId11"/>
+    <p:sldId id="266" r:id="rId12"/>
+    <p:sldId id="267" r:id="rId13"/>
+    <p:sldId id="268" r:id="rId14"/>
+    <p:sldId id="269" r:id="rId15"/>
+    <p:sldId id="270" r:id="rId16"/>
+    <p:sldId id="271" r:id="rId17"/>
   </p:sldIdLst>
-  <p:sldSz cx="12191695" cy="6858000" type="screen4x3"/>
+  <p:sldSz cx="12192000" cy="6858000"/>
   <p:notesSz cx="6858000" cy="9144000"/>
   <p:defaultTextStyle>
     <a:defPPr>
@@ -119,6 +122,22 @@
       </a:defRPr>
     </a:lvl9pPr>
   </p:defaultTextStyle>
+  <p:extLst>
+    <p:ext uri="{EFAFB233-063F-42B5-8137-9DF3F51BA10A}">
+      <p15:sldGuideLst xmlns:p15="http://schemas.microsoft.com/office/powerpoint/2012/main">
+        <p15:guide id="1" orient="horz" pos="2160">
+          <p15:clr>
+            <a:srgbClr val="A4A3A4"/>
+          </p15:clr>
+        </p15:guide>
+        <p15:guide id="2" pos="2880">
+          <p15:clr>
+            <a:srgbClr val="A4A3A4"/>
+          </p15:clr>
+        </p15:guide>
+      </p15:sldGuideLst>
+    </p:ext>
+  </p:extLst>
 </p:presentation>
 </file>
 
@@ -160,10 +179,9 @@
           <a:lstStyle/>
           <a:p>
             <a:r>
-              <a:rPr lang="en-US" smtClean="0"/>
+              <a:rPr lang="en-US"/>
               <a:t>Click to edit Master title style</a:t>
             </a:r>
-            <a:endParaRPr lang="en-US"/>
           </a:p>
         </p:txBody>
       </p:sp>
@@ -279,10 +297,9 @@
           </a:lstStyle>
           <a:p>
             <a:r>
-              <a:rPr lang="en-US" smtClean="0"/>
+              <a:rPr lang="en-US"/>
               <a:t>Click to edit Master subtitle style</a:t>
             </a:r>
-            <a:endParaRPr lang="en-US"/>
           </a:p>
         </p:txBody>
       </p:sp>
@@ -303,7 +320,7 @@
           <a:p>
             <a:fld id="{5BCAD085-E8A6-8845-BD4E-CB4CCA059FC4}" type="datetimeFigureOut">
               <a:rPr lang="en-US" smtClean="0"/>
-              <a:t>1/27/13</a:t>
+              <a:t>8/19/2026</a:t>
             </a:fld>
             <a:endParaRPr lang="en-US"/>
           </a:p>
@@ -397,10 +414,9 @@
           <a:lstStyle/>
           <a:p>
             <a:r>
-              <a:rPr lang="en-US" smtClean="0"/>
+              <a:rPr lang="en-US"/>
               <a:t>Click to edit Master title style</a:t>
             </a:r>
-            <a:endParaRPr lang="en-US"/>
           </a:p>
         </p:txBody>
       </p:sp>
@@ -421,38 +437,37 @@
           <a:p>
             <a:pPr lvl="0"/>
             <a:r>
-              <a:rPr lang="en-US" smtClean="0"/>
+              <a:rPr lang="en-US"/>
               <a:t>Click to edit Master text styles</a:t>
             </a:r>
           </a:p>
           <a:p>
             <a:pPr lvl="1"/>
             <a:r>
-              <a:rPr lang="en-US" smtClean="0"/>
+              <a:rPr lang="en-US"/>
               <a:t>Second level</a:t>
             </a:r>
           </a:p>
           <a:p>
             <a:pPr lvl="2"/>
             <a:r>
-              <a:rPr lang="en-US" smtClean="0"/>
+              <a:rPr lang="en-US"/>
               <a:t>Third level</a:t>
             </a:r>
           </a:p>
           <a:p>
             <a:pPr lvl="3"/>
             <a:r>
-              <a:rPr lang="en-US" smtClean="0"/>
+              <a:rPr lang="en-US"/>
               <a:t>Fourth level</a:t>
             </a:r>
           </a:p>
           <a:p>
             <a:pPr lvl="4"/>
             <a:r>
-              <a:rPr lang="en-US" smtClean="0"/>
+              <a:rPr lang="en-US"/>
               <a:t>Fifth level</a:t>
             </a:r>
-            <a:endParaRPr lang="en-US"/>
           </a:p>
         </p:txBody>
       </p:sp>
@@ -473,7 +488,7 @@
           <a:p>
             <a:fld id="{5BCAD085-E8A6-8845-BD4E-CB4CCA059FC4}" type="datetimeFigureOut">
               <a:rPr lang="en-US" smtClean="0"/>
-              <a:t>1/27/13</a:t>
+              <a:t>8/19/2026</a:t>
             </a:fld>
             <a:endParaRPr lang="en-US"/>
           </a:p>
@@ -572,10 +587,9 @@
           <a:lstStyle/>
           <a:p>
             <a:r>
-              <a:rPr lang="en-US" smtClean="0"/>
+              <a:rPr lang="en-US"/>
               <a:t>Click to edit Master title style</a:t>
             </a:r>
-            <a:endParaRPr lang="en-US"/>
           </a:p>
         </p:txBody>
       </p:sp>
@@ -601,38 +615,37 @@
           <a:p>
             <a:pPr lvl="0"/>
             <a:r>
-              <a:rPr lang="en-US" smtClean="0"/>
+              <a:rPr lang="en-US"/>
               <a:t>Click to edit Master text styles</a:t>
             </a:r>
           </a:p>
           <a:p>
             <a:pPr lvl="1"/>
             <a:r>
-              <a:rPr lang="en-US" smtClean="0"/>
+              <a:rPr lang="en-US"/>
               <a:t>Second level</a:t>
             </a:r>
           </a:p>
           <a:p>
             <a:pPr lvl="2"/>
             <a:r>
-              <a:rPr lang="en-US" smtClean="0"/>
+              <a:rPr lang="en-US"/>
               <a:t>Third level</a:t>
             </a:r>
           </a:p>
           <a:p>
             <a:pPr lvl="3"/>
             <a:r>
-              <a:rPr lang="en-US" smtClean="0"/>
+              <a:rPr lang="en-US"/>
               <a:t>Fourth level</a:t>
             </a:r>
           </a:p>
           <a:p>
             <a:pPr lvl="4"/>
             <a:r>
-              <a:rPr lang="en-US" smtClean="0"/>
+              <a:rPr lang="en-US"/>
               <a:t>Fifth level</a:t>
             </a:r>
-            <a:endParaRPr lang="en-US"/>
           </a:p>
         </p:txBody>
       </p:sp>
@@ -653,7 +666,7 @@
           <a:p>
             <a:fld id="{5BCAD085-E8A6-8845-BD4E-CB4CCA059FC4}" type="datetimeFigureOut">
               <a:rPr lang="en-US" smtClean="0"/>
-              <a:t>1/27/13</a:t>
+              <a:t>8/19/2026</a:t>
             </a:fld>
             <a:endParaRPr lang="en-US"/>
           </a:p>
@@ -747,10 +760,9 @@
           <a:lstStyle/>
           <a:p>
             <a:r>
-              <a:rPr lang="en-US" smtClean="0"/>
+              <a:rPr lang="en-US"/>
               <a:t>Click to edit Master title style</a:t>
             </a:r>
-            <a:endParaRPr lang="en-US"/>
           </a:p>
         </p:txBody>
       </p:sp>
@@ -771,38 +783,37 @@
           <a:p>
             <a:pPr lvl="0"/>
             <a:r>
-              <a:rPr lang="en-US" smtClean="0"/>
+              <a:rPr lang="en-US"/>
               <a:t>Click to edit Master text styles</a:t>
             </a:r>
           </a:p>
           <a:p>
             <a:pPr lvl="1"/>
             <a:r>
-              <a:rPr lang="en-US" smtClean="0"/>
+              <a:rPr lang="en-US"/>
               <a:t>Second level</a:t>
             </a:r>
           </a:p>
           <a:p>
             <a:pPr lvl="2"/>
             <a:r>
-              <a:rPr lang="en-US" smtClean="0"/>
+              <a:rPr lang="en-US"/>
               <a:t>Third level</a:t>
             </a:r>
           </a:p>
           <a:p>
             <a:pPr lvl="3"/>
             <a:r>
-              <a:rPr lang="en-US" smtClean="0"/>
+              <a:rPr lang="en-US"/>
               <a:t>Fourth level</a:t>
             </a:r>
           </a:p>
           <a:p>
             <a:pPr lvl="4"/>
             <a:r>
-              <a:rPr lang="en-US" smtClean="0"/>
+              <a:rPr lang="en-US"/>
               <a:t>Fifth level</a:t>
             </a:r>
-            <a:endParaRPr lang="en-US"/>
           </a:p>
         </p:txBody>
       </p:sp>
@@ -823,7 +834,7 @@
           <a:p>
             <a:fld id="{5BCAD085-E8A6-8845-BD4E-CB4CCA059FC4}" type="datetimeFigureOut">
               <a:rPr lang="en-US" smtClean="0"/>
-              <a:t>1/27/13</a:t>
+              <a:t>8/19/2026</a:t>
             </a:fld>
             <a:endParaRPr lang="en-US"/>
           </a:p>
@@ -926,10 +937,9 @@
           </a:lstStyle>
           <a:p>
             <a:r>
-              <a:rPr lang="en-US" smtClean="0"/>
+              <a:rPr lang="en-US"/>
               <a:t>Click to edit Master title style</a:t>
             </a:r>
-            <a:endParaRPr lang="en-US"/>
           </a:p>
         </p:txBody>
       </p:sp>
@@ -1046,7 +1056,7 @@
           <a:p>
             <a:pPr lvl="0"/>
             <a:r>
-              <a:rPr lang="en-US" smtClean="0"/>
+              <a:rPr lang="en-US"/>
               <a:t>Click to edit Master text styles</a:t>
             </a:r>
           </a:p>
@@ -1069,7 +1079,7 @@
           <a:p>
             <a:fld id="{5BCAD085-E8A6-8845-BD4E-CB4CCA059FC4}" type="datetimeFigureOut">
               <a:rPr lang="en-US" smtClean="0"/>
-              <a:t>1/27/13</a:t>
+              <a:t>8/19/2026</a:t>
             </a:fld>
             <a:endParaRPr lang="en-US"/>
           </a:p>
@@ -1163,10 +1173,9 @@
           <a:lstStyle/>
           <a:p>
             <a:r>
-              <a:rPr lang="en-US" smtClean="0"/>
+              <a:rPr lang="en-US"/>
               <a:t>Click to edit Master title style</a:t>
             </a:r>
-            <a:endParaRPr lang="en-US"/>
           </a:p>
         </p:txBody>
       </p:sp>
@@ -1220,38 +1229,37 @@
           <a:p>
             <a:pPr lvl="0"/>
             <a:r>
-              <a:rPr lang="en-US" smtClean="0"/>
+              <a:rPr lang="en-US"/>
               <a:t>Click to edit Master text styles</a:t>
             </a:r>
           </a:p>
           <a:p>
             <a:pPr lvl="1"/>
             <a:r>
-              <a:rPr lang="en-US" smtClean="0"/>
+              <a:rPr lang="en-US"/>
               <a:t>Second level</a:t>
             </a:r>
           </a:p>
           <a:p>
             <a:pPr lvl="2"/>
             <a:r>
-              <a:rPr lang="en-US" smtClean="0"/>
+              <a:rPr lang="en-US"/>
               <a:t>Third level</a:t>
             </a:r>
           </a:p>
           <a:p>
             <a:pPr lvl="3"/>
             <a:r>
-              <a:rPr lang="en-US" smtClean="0"/>
+              <a:rPr lang="en-US"/>
               <a:t>Fourth level</a:t>
             </a:r>
           </a:p>
           <a:p>
             <a:pPr lvl="4"/>
             <a:r>
-              <a:rPr lang="en-US" smtClean="0"/>
+              <a:rPr lang="en-US"/>
               <a:t>Fifth level</a:t>
             </a:r>
-            <a:endParaRPr lang="en-US"/>
           </a:p>
         </p:txBody>
       </p:sp>
@@ -1305,38 +1313,37 @@
           <a:p>
             <a:pPr lvl="0"/>
             <a:r>
-              <a:rPr lang="en-US" smtClean="0"/>
+              <a:rPr lang="en-US"/>
               <a:t>Click to edit Master text styles</a:t>
             </a:r>
           </a:p>
           <a:p>
             <a:pPr lvl="1"/>
             <a:r>
-              <a:rPr lang="en-US" smtClean="0"/>
+              <a:rPr lang="en-US"/>
               <a:t>Second level</a:t>
             </a:r>
           </a:p>
           <a:p>
             <a:pPr lvl="2"/>
             <a:r>
-              <a:rPr lang="en-US" smtClean="0"/>
+              <a:rPr lang="en-US"/>
               <a:t>Third level</a:t>
             </a:r>
           </a:p>
           <a:p>
             <a:pPr lvl="3"/>
             <a:r>
-              <a:rPr lang="en-US" smtClean="0"/>
+              <a:rPr lang="en-US"/>
               <a:t>Fourth level</a:t>
             </a:r>
           </a:p>
           <a:p>
             <a:pPr lvl="4"/>
             <a:r>
-              <a:rPr lang="en-US" smtClean="0"/>
+              <a:rPr lang="en-US"/>
               <a:t>Fifth level</a:t>
             </a:r>
-            <a:endParaRPr lang="en-US"/>
           </a:p>
         </p:txBody>
       </p:sp>
@@ -1357,7 +1364,7 @@
           <a:p>
             <a:fld id="{5BCAD085-E8A6-8845-BD4E-CB4CCA059FC4}" type="datetimeFigureOut">
               <a:rPr lang="en-US" smtClean="0"/>
-              <a:t>1/27/13</a:t>
+              <a:t>8/19/2026</a:t>
             </a:fld>
             <a:endParaRPr lang="en-US"/>
           </a:p>
@@ -1455,10 +1462,9 @@
           </a:lstStyle>
           <a:p>
             <a:r>
-              <a:rPr lang="en-US" smtClean="0"/>
+              <a:rPr lang="en-US"/>
               <a:t>Click to edit Master title style</a:t>
             </a:r>
-            <a:endParaRPr lang="en-US"/>
           </a:p>
         </p:txBody>
       </p:sp>
@@ -1521,7 +1527,7 @@
           <a:p>
             <a:pPr lvl="0"/>
             <a:r>
-              <a:rPr lang="en-US" smtClean="0"/>
+              <a:rPr lang="en-US"/>
               <a:t>Click to edit Master text styles</a:t>
             </a:r>
           </a:p>
@@ -1577,38 +1583,37 @@
           <a:p>
             <a:pPr lvl="0"/>
             <a:r>
-              <a:rPr lang="en-US" smtClean="0"/>
+              <a:rPr lang="en-US"/>
               <a:t>Click to edit Master text styles</a:t>
             </a:r>
           </a:p>
           <a:p>
             <a:pPr lvl="1"/>
             <a:r>
-              <a:rPr lang="en-US" smtClean="0"/>
+              <a:rPr lang="en-US"/>
               <a:t>Second level</a:t>
             </a:r>
           </a:p>
           <a:p>
             <a:pPr lvl="2"/>
             <a:r>
-              <a:rPr lang="en-US" smtClean="0"/>
+              <a:rPr lang="en-US"/>
               <a:t>Third level</a:t>
             </a:r>
           </a:p>
           <a:p>
             <a:pPr lvl="3"/>
             <a:r>
-              <a:rPr lang="en-US" smtClean="0"/>
+              <a:rPr lang="en-US"/>
               <a:t>Fourth level</a:t>
             </a:r>
           </a:p>
           <a:p>
             <a:pPr lvl="4"/>
             <a:r>
-              <a:rPr lang="en-US" smtClean="0"/>
+              <a:rPr lang="en-US"/>
               <a:t>Fifth level</a:t>
             </a:r>
-            <a:endParaRPr lang="en-US"/>
           </a:p>
         </p:txBody>
       </p:sp>
@@ -1671,7 +1676,7 @@
           <a:p>
             <a:pPr lvl="0"/>
             <a:r>
-              <a:rPr lang="en-US" smtClean="0"/>
+              <a:rPr lang="en-US"/>
               <a:t>Click to edit Master text styles</a:t>
             </a:r>
           </a:p>
@@ -1727,38 +1732,37 @@
           <a:p>
             <a:pPr lvl="0"/>
             <a:r>
-              <a:rPr lang="en-US" smtClean="0"/>
+              <a:rPr lang="en-US"/>
               <a:t>Click to edit Master text styles</a:t>
             </a:r>
           </a:p>
           <a:p>
             <a:pPr lvl="1"/>
             <a:r>
-              <a:rPr lang="en-US" smtClean="0"/>
+              <a:rPr lang="en-US"/>
               <a:t>Second level</a:t>
             </a:r>
           </a:p>
           <a:p>
             <a:pPr lvl="2"/>
             <a:r>
-              <a:rPr lang="en-US" smtClean="0"/>
+              <a:rPr lang="en-US"/>
               <a:t>Third level</a:t>
             </a:r>
           </a:p>
           <a:p>
             <a:pPr lvl="3"/>
             <a:r>
-              <a:rPr lang="en-US" smtClean="0"/>
+              <a:rPr lang="en-US"/>
               <a:t>Fourth level</a:t>
             </a:r>
           </a:p>
           <a:p>
             <a:pPr lvl="4"/>
             <a:r>
-              <a:rPr lang="en-US" smtClean="0"/>
+              <a:rPr lang="en-US"/>
               <a:t>Fifth level</a:t>
             </a:r>
-            <a:endParaRPr lang="en-US"/>
           </a:p>
         </p:txBody>
       </p:sp>
@@ -1779,7 +1783,7 @@
           <a:p>
             <a:fld id="{5BCAD085-E8A6-8845-BD4E-CB4CCA059FC4}" type="datetimeFigureOut">
               <a:rPr lang="en-US" smtClean="0"/>
-              <a:t>1/27/13</a:t>
+              <a:t>8/19/2026</a:t>
             </a:fld>
             <a:endParaRPr lang="en-US"/>
           </a:p>
@@ -1873,10 +1877,9 @@
           <a:lstStyle/>
           <a:p>
             <a:r>
-              <a:rPr lang="en-US" smtClean="0"/>
+              <a:rPr lang="en-US"/>
               <a:t>Click to edit Master title style</a:t>
             </a:r>
-            <a:endParaRPr lang="en-US"/>
           </a:p>
         </p:txBody>
       </p:sp>
@@ -1897,7 +1900,7 @@
           <a:p>
             <a:fld id="{5BCAD085-E8A6-8845-BD4E-CB4CCA059FC4}" type="datetimeFigureOut">
               <a:rPr lang="en-US" smtClean="0"/>
-              <a:t>1/27/13</a:t>
+              <a:t>8/19/2026</a:t>
             </a:fld>
             <a:endParaRPr lang="en-US"/>
           </a:p>
@@ -1992,7 +1995,7 @@
           <a:p>
             <a:fld id="{5BCAD085-E8A6-8845-BD4E-CB4CCA059FC4}" type="datetimeFigureOut">
               <a:rPr lang="en-US" smtClean="0"/>
-              <a:t>1/27/13</a:t>
+              <a:t>8/19/2026</a:t>
             </a:fld>
             <a:endParaRPr lang="en-US"/>
           </a:p>
@@ -2095,10 +2098,9 @@
           </a:lstStyle>
           <a:p>
             <a:r>
-              <a:rPr lang="en-US" smtClean="0"/>
+              <a:rPr lang="en-US"/>
               <a:t>Click to edit Master title style</a:t>
             </a:r>
-            <a:endParaRPr lang="en-US"/>
           </a:p>
         </p:txBody>
       </p:sp>
@@ -2152,38 +2154,37 @@
           <a:p>
             <a:pPr lvl="0"/>
             <a:r>
-              <a:rPr lang="en-US" smtClean="0"/>
+              <a:rPr lang="en-US"/>
               <a:t>Click to edit Master text styles</a:t>
             </a:r>
           </a:p>
           <a:p>
             <a:pPr lvl="1"/>
             <a:r>
-              <a:rPr lang="en-US" smtClean="0"/>
+              <a:rPr lang="en-US"/>
               <a:t>Second level</a:t>
             </a:r>
           </a:p>
           <a:p>
             <a:pPr lvl="2"/>
             <a:r>
-              <a:rPr lang="en-US" smtClean="0"/>
+              <a:rPr lang="en-US"/>
               <a:t>Third level</a:t>
             </a:r>
           </a:p>
           <a:p>
             <a:pPr lvl="3"/>
             <a:r>
-              <a:rPr lang="en-US" smtClean="0"/>
+              <a:rPr lang="en-US"/>
               <a:t>Fourth level</a:t>
             </a:r>
           </a:p>
           <a:p>
             <a:pPr lvl="4"/>
             <a:r>
-              <a:rPr lang="en-US" smtClean="0"/>
+              <a:rPr lang="en-US"/>
               <a:t>Fifth level</a:t>
             </a:r>
-            <a:endParaRPr lang="en-US"/>
           </a:p>
         </p:txBody>
       </p:sp>
@@ -2246,7 +2247,7 @@
           <a:p>
             <a:pPr lvl="0"/>
             <a:r>
-              <a:rPr lang="en-US" smtClean="0"/>
+              <a:rPr lang="en-US"/>
               <a:t>Click to edit Master text styles</a:t>
             </a:r>
           </a:p>
@@ -2269,7 +2270,7 @@
           <a:p>
             <a:fld id="{5BCAD085-E8A6-8845-BD4E-CB4CCA059FC4}" type="datetimeFigureOut">
               <a:rPr lang="en-US" smtClean="0"/>
-              <a:t>1/27/13</a:t>
+              <a:t>8/19/2026</a:t>
             </a:fld>
             <a:endParaRPr lang="en-US"/>
           </a:p>
@@ -2372,10 +2373,9 @@
           </a:lstStyle>
           <a:p>
             <a:r>
-              <a:rPr lang="en-US" smtClean="0"/>
+              <a:rPr lang="en-US"/>
               <a:t>Click to edit Master title style</a:t>
             </a:r>
-            <a:endParaRPr lang="en-US"/>
           </a:p>
         </p:txBody>
       </p:sp>
@@ -2499,7 +2499,7 @@
           <a:p>
             <a:pPr lvl="0"/>
             <a:r>
-              <a:rPr lang="en-US" smtClean="0"/>
+              <a:rPr lang="en-US"/>
               <a:t>Click to edit Master text styles</a:t>
             </a:r>
           </a:p>
@@ -2522,7 +2522,7 @@
           <a:p>
             <a:fld id="{5BCAD085-E8A6-8845-BD4E-CB4CCA059FC4}" type="datetimeFigureOut">
               <a:rPr lang="en-US" smtClean="0"/>
-              <a:t>1/27/13</a:t>
+              <a:t>8/19/2026</a:t>
             </a:fld>
             <a:endParaRPr lang="en-US"/>
           </a:p>
@@ -2631,10 +2631,9 @@
           <a:lstStyle/>
           <a:p>
             <a:r>
-              <a:rPr lang="en-US" smtClean="0"/>
+              <a:rPr lang="en-US"/>
               <a:t>Click to edit Master title style</a:t>
             </a:r>
-            <a:endParaRPr lang="en-US"/>
           </a:p>
         </p:txBody>
       </p:sp>
@@ -2665,38 +2664,37 @@
           <a:p>
             <a:pPr lvl="0"/>
             <a:r>
-              <a:rPr lang="en-US" smtClean="0"/>
+              <a:rPr lang="en-US"/>
               <a:t>Click to edit Master text styles</a:t>
             </a:r>
           </a:p>
           <a:p>
             <a:pPr lvl="1"/>
             <a:r>
-              <a:rPr lang="en-US" smtClean="0"/>
+              <a:rPr lang="en-US"/>
               <a:t>Second level</a:t>
             </a:r>
           </a:p>
           <a:p>
             <a:pPr lvl="2"/>
             <a:r>
-              <a:rPr lang="en-US" smtClean="0"/>
+              <a:rPr lang="en-US"/>
               <a:t>Third level</a:t>
             </a:r>
           </a:p>
           <a:p>
             <a:pPr lvl="3"/>
             <a:r>
-              <a:rPr lang="en-US" smtClean="0"/>
+              <a:rPr lang="en-US"/>
               <a:t>Fourth level</a:t>
             </a:r>
           </a:p>
           <a:p>
             <a:pPr lvl="4"/>
             <a:r>
-              <a:rPr lang="en-US" smtClean="0"/>
+              <a:rPr lang="en-US"/>
               <a:t>Fifth level</a:t>
             </a:r>
-            <a:endParaRPr lang="en-US"/>
           </a:p>
         </p:txBody>
       </p:sp>
@@ -2735,7 +2733,7 @@
           <a:p>
             <a:fld id="{5BCAD085-E8A6-8845-BD4E-CB4CCA059FC4}" type="datetimeFigureOut">
               <a:rPr lang="en-US" smtClean="0"/>
-              <a:t>1/27/13</a:t>
+              <a:t>8/19/2026</a:t>
             </a:fld>
             <a:endParaRPr lang="en-US"/>
           </a:p>
@@ -3094,7 +3092,7 @@
 </file>
 
 <file path=ppt/slides/slide1.xml><?xml version="1.0" encoding="utf-8"?>
-<p:sld xmlns:a="http://schemas.openxmlformats.org/drawingml/2006/main" xmlns:p="http://schemas.openxmlformats.org/presentationml/2006/main" xmlns:r="http://schemas.openxmlformats.org/officeDocument/2006/relationships">
+<p:sld xmlns:a="http://schemas.openxmlformats.org/drawingml/2006/main" xmlns:r="http://schemas.openxmlformats.org/officeDocument/2006/relationships" xmlns:p="http://schemas.openxmlformats.org/presentationml/2006/main">
   <p:cSld>
     <p:bg>
       <p:bgPr>
@@ -3110,7 +3108,14 @@
         <p:cNvGrpSpPr/>
         <p:nvPr/>
       </p:nvGrpSpPr>
-      <p:grpSpPr/>
+      <p:grpSpPr>
+        <a:xfrm>
+          <a:off x="0" y="0"/>
+          <a:ext cx="0" cy="0"/>
+          <a:chOff x="0" y="0"/>
+          <a:chExt cx="0" cy="0"/>
+        </a:xfrm>
+      </p:grpSpPr>
       <p:sp>
         <p:nvSpPr>
           <p:cNvPr id="2" name="TextBox 1"/>
@@ -3163,7 +3168,13 @@
           <p:cNvGraphicFramePr>
             <a:graphicFrameLocks noGrp="1"/>
           </p:cNvGraphicFramePr>
-          <p:nvPr/>
+          <p:nvPr>
+            <p:extLst>
+              <p:ext uri="{D42A27DB-BD31-4B8C-83A1-F6EECF244321}">
+                <p14:modId xmlns:p14="http://schemas.microsoft.com/office/powerpoint/2010/main" val="2557416190"/>
+              </p:ext>
+            </p:extLst>
+          </p:nvPr>
         </p:nvGraphicFramePr>
         <p:xfrm>
           <a:off x="548640" y="2834640"/>
@@ -3176,13 +3187,25 @@
                 <a:tableStyleId>{5C22544A-7EE6-4342-B048-85BDC9FD1C3A}</a:tableStyleId>
               </a:tblPr>
               <a:tblGrid>
-                <a:gridCol w="3401568"/>
-                <a:gridCol w="2267712"/>
+                <a:gridCol w="3401568">
+                  <a:extLst>
+                    <a:ext uri="{9D8B030D-6E8A-4147-A177-3AD203B41FA5}">
+                      <a16:colId xmlns:a16="http://schemas.microsoft.com/office/drawing/2014/main" val="20000"/>
+                    </a:ext>
+                  </a:extLst>
+                </a:gridCol>
+                <a:gridCol w="2267712">
+                  <a:extLst>
+                    <a:ext uri="{9D8B030D-6E8A-4147-A177-3AD203B41FA5}">
+                      <a16:colId xmlns:a16="http://schemas.microsoft.com/office/drawing/2014/main" val="20001"/>
+                    </a:ext>
+                  </a:extLst>
+                </a:gridCol>
               </a:tblGrid>
               <a:tr h="434340">
                 <a:tc>
                   <a:txBody>
-                    <a:bodyPr wrap="square"/>
+                    <a:bodyPr/>
                     <a:lstStyle/>
                     <a:p>
                       <a:pPr algn="l"/>
@@ -3205,7 +3228,7 @@
                 </a:tc>
                 <a:tc>
                   <a:txBody>
-                    <a:bodyPr wrap="square"/>
+                    <a:bodyPr/>
                     <a:lstStyle/>
                     <a:p>
                       <a:pPr algn="ctr"/>
@@ -3226,150 +3249,180 @@
                     </a:solidFill>
                   </a:tcPr>
                 </a:tc>
+                <a:extLst>
+                  <a:ext uri="{0D108BD9-81ED-4DB2-BD59-A6C34878D82A}">
+                    <a16:rowId xmlns:a16="http://schemas.microsoft.com/office/drawing/2014/main" val="10000"/>
+                  </a:ext>
+                </a:extLst>
               </a:tr>
               <a:tr h="434340">
                 <a:tc>
                   <a:txBody>
-                    <a:bodyPr wrap="square"/>
+                    <a:bodyPr/>
                     <a:lstStyle/>
                     <a:p>
                       <a:pPr algn="l"/>
                       <a:r>
-                        <a:rPr sz="1400" b="0" i="0">
-                          <a:solidFill>
-                            <a:srgbClr val="000000"/>
-                          </a:solidFill>
-                          <a:latin typeface="Calibri"/>
-                        </a:rPr>
-                        <a:t>&lt;NAME 1&gt;</a:t>
-                      </a:r>
-                    </a:p>
-                  </a:txBody>
-                  <a:tcPr>
-                    <a:solidFill>
-                      <a:srgbClr val="FFFFFF"/>
-                    </a:solidFill>
-                  </a:tcPr>
-                </a:tc>
-                <a:tc>
-                  <a:txBody>
-                    <a:bodyPr wrap="square"/>
+                        <a:rPr lang="en-US" sz="1400" dirty="0"/>
+                        <a:t>Ze'ev </a:t>
+                      </a:r>
+                      <a:r>
+                        <a:rPr lang="en-US" sz="1400" dirty="0" err="1"/>
+                        <a:t>Gastevert</a:t>
+                      </a:r>
+                      <a:endParaRPr sz="1400" b="0" i="0" dirty="0">
+                        <a:solidFill>
+                          <a:srgbClr val="000000"/>
+                        </a:solidFill>
+                        <a:latin typeface="Calibri"/>
+                      </a:endParaRPr>
+                    </a:p>
+                  </a:txBody>
+                  <a:tcPr>
+                    <a:solidFill>
+                      <a:srgbClr val="FFFFFF"/>
+                    </a:solidFill>
+                  </a:tcPr>
+                </a:tc>
+                <a:tc>
+                  <a:txBody>
+                    <a:bodyPr/>
                     <a:lstStyle/>
                     <a:p>
                       <a:pPr algn="ctr"/>
                       <a:r>
-                        <a:rPr sz="1400" b="0" i="0">
-                          <a:solidFill>
-                            <a:srgbClr val="000000"/>
-                          </a:solidFill>
-                          <a:latin typeface="Calibri"/>
-                        </a:rPr>
-                        <a:t>&lt;ID 1&gt;</a:t>
-                      </a:r>
-                    </a:p>
-                  </a:txBody>
-                  <a:tcPr>
-                    <a:solidFill>
-                      <a:srgbClr val="FFFFFF"/>
-                    </a:solidFill>
-                  </a:tcPr>
-                </a:tc>
+                        <a:rPr lang="en-US" sz="1400" dirty="0"/>
+                        <a:t>—</a:t>
+                      </a:r>
+                      <a:endParaRPr sz="1400" b="0" i="0" dirty="0">
+                        <a:solidFill>
+                          <a:srgbClr val="000000"/>
+                        </a:solidFill>
+                        <a:latin typeface="Calibri"/>
+                      </a:endParaRPr>
+                    </a:p>
+                  </a:txBody>
+                  <a:tcPr>
+                    <a:solidFill>
+                      <a:srgbClr val="FFFFFF"/>
+                    </a:solidFill>
+                  </a:tcPr>
+                </a:tc>
+                <a:extLst>
+                  <a:ext uri="{0D108BD9-81ED-4DB2-BD59-A6C34878D82A}">
+                    <a16:rowId xmlns:a16="http://schemas.microsoft.com/office/drawing/2014/main" val="10001"/>
+                  </a:ext>
+                </a:extLst>
               </a:tr>
               <a:tr h="434340">
                 <a:tc>
                   <a:txBody>
-                    <a:bodyPr wrap="square"/>
+                    <a:bodyPr/>
                     <a:lstStyle/>
                     <a:p>
                       <a:pPr algn="l"/>
                       <a:r>
-                        <a:rPr sz="1400" b="0" i="0">
-                          <a:solidFill>
-                            <a:srgbClr val="000000"/>
-                          </a:solidFill>
-                          <a:latin typeface="Calibri"/>
-                        </a:rPr>
-                        <a:t>&lt;NAME 2&gt;</a:t>
-                      </a:r>
-                    </a:p>
-                  </a:txBody>
-                  <a:tcPr>
-                    <a:solidFill>
-                      <a:srgbClr val="FFFFFF"/>
-                    </a:solidFill>
-                  </a:tcPr>
-                </a:tc>
-                <a:tc>
-                  <a:txBody>
-                    <a:bodyPr wrap="square"/>
+                        <a:rPr lang="en-US" sz="1400" dirty="0"/>
+                        <a:t>Ido Leibowitz</a:t>
+                      </a:r>
+                      <a:endParaRPr sz="1400" b="0" i="0" dirty="0">
+                        <a:solidFill>
+                          <a:srgbClr val="000000"/>
+                        </a:solidFill>
+                        <a:latin typeface="Calibri"/>
+                      </a:endParaRPr>
+                    </a:p>
+                  </a:txBody>
+                  <a:tcPr>
+                    <a:solidFill>
+                      <a:srgbClr val="FFFFFF"/>
+                    </a:solidFill>
+                  </a:tcPr>
+                </a:tc>
+                <a:tc>
+                  <a:txBody>
+                    <a:bodyPr/>
                     <a:lstStyle/>
                     <a:p>
                       <a:pPr algn="ctr"/>
                       <a:r>
-                        <a:rPr sz="1400" b="0" i="0">
-                          <a:solidFill>
-                            <a:srgbClr val="000000"/>
-                          </a:solidFill>
-                          <a:latin typeface="Calibri"/>
-                        </a:rPr>
-                        <a:t>&lt;ID 2&gt;</a:t>
-                      </a:r>
-                    </a:p>
-                  </a:txBody>
-                  <a:tcPr>
-                    <a:solidFill>
-                      <a:srgbClr val="FFFFFF"/>
-                    </a:solidFill>
-                  </a:tcPr>
-                </a:tc>
+                        <a:rPr lang="en-US" sz="1400" dirty="0"/>
+                        <a:t>—</a:t>
+                      </a:r>
+                      <a:endParaRPr sz="1400" b="0" i="0" dirty="0">
+                        <a:solidFill>
+                          <a:srgbClr val="000000"/>
+                        </a:solidFill>
+                        <a:latin typeface="Calibri"/>
+                      </a:endParaRPr>
+                    </a:p>
+                  </a:txBody>
+                  <a:tcPr>
+                    <a:solidFill>
+                      <a:srgbClr val="FFFFFF"/>
+                    </a:solidFill>
+                  </a:tcPr>
+                </a:tc>
+                <a:extLst>
+                  <a:ext uri="{0D108BD9-81ED-4DB2-BD59-A6C34878D82A}">
+                    <a16:rowId xmlns:a16="http://schemas.microsoft.com/office/drawing/2014/main" val="10002"/>
+                  </a:ext>
+                </a:extLst>
               </a:tr>
               <a:tr h="434340">
                 <a:tc>
                   <a:txBody>
-                    <a:bodyPr wrap="square"/>
+                    <a:bodyPr/>
                     <a:lstStyle/>
                     <a:p>
                       <a:pPr algn="l"/>
                       <a:r>
-                        <a:rPr sz="1400" b="0" i="0">
-                          <a:solidFill>
-                            <a:srgbClr val="000000"/>
-                          </a:solidFill>
-                          <a:latin typeface="Calibri"/>
-                        </a:rPr>
-                        <a:t>&lt;NAME 3&gt;</a:t>
-                      </a:r>
-                    </a:p>
-                  </a:txBody>
-                  <a:tcPr>
-                    <a:solidFill>
-                      <a:srgbClr val="FFFFFF"/>
-                    </a:solidFill>
-                  </a:tcPr>
-                </a:tc>
-                <a:tc>
-                  <a:txBody>
-                    <a:bodyPr wrap="square"/>
+                        <a:rPr lang="en-US" sz="1400" dirty="0"/>
+                        <a:t>David Sheinenzon</a:t>
+                      </a:r>
+                      <a:endParaRPr sz="1400" b="0" i="0" dirty="0">
+                        <a:solidFill>
+                          <a:srgbClr val="000000"/>
+                        </a:solidFill>
+                        <a:latin typeface="Calibri"/>
+                      </a:endParaRPr>
+                    </a:p>
+                  </a:txBody>
+                  <a:tcPr>
+                    <a:solidFill>
+                      <a:srgbClr val="FFFFFF"/>
+                    </a:solidFill>
+                  </a:tcPr>
+                </a:tc>
+                <a:tc>
+                  <a:txBody>
+                    <a:bodyPr/>
                     <a:lstStyle/>
                     <a:p>
                       <a:pPr algn="ctr"/>
                       <a:r>
-                        <a:rPr sz="1400" b="0" i="0">
-                          <a:solidFill>
-                            <a:srgbClr val="000000"/>
-                          </a:solidFill>
-                          <a:latin typeface="Calibri"/>
-                        </a:rPr>
-                        <a:t>&lt;ID 3&gt;</a:t>
-                      </a:r>
-                    </a:p>
-                  </a:txBody>
-                  <a:tcPr>
-                    <a:solidFill>
-                      <a:srgbClr val="FFFFFF"/>
-                    </a:solidFill>
-                  </a:tcPr>
-                </a:tc>
+                        <a:rPr lang="en-US" sz="1400" dirty="0"/>
+                        <a:t>—</a:t>
+                      </a:r>
+                      <a:endParaRPr sz="1400" b="0" i="0" dirty="0">
+                        <a:solidFill>
+                          <a:srgbClr val="000000"/>
+                        </a:solidFill>
+                        <a:latin typeface="Calibri"/>
+                      </a:endParaRPr>
+                    </a:p>
+                  </a:txBody>
+                  <a:tcPr>
+                    <a:solidFill>
+                      <a:srgbClr val="FFFFFF"/>
+                    </a:solidFill>
+                  </a:tcPr>
+                </a:tc>
+                <a:extLst>
+                  <a:ext uri="{0D108BD9-81ED-4DB2-BD59-A6C34878D82A}">
+                    <a16:rowId xmlns:a16="http://schemas.microsoft.com/office/drawing/2014/main" val="10003"/>
+                  </a:ext>
+                </a:extLst>
               </a:tr>
             </a:tbl>
           </a:graphicData>
@@ -3396,7 +3449,9 @@
             <a:spAutoFit/>
           </a:bodyPr>
           <a:lstStyle/>
-          <a:p/>
+          <a:p>
+            <a:endParaRPr/>
+          </a:p>
           <a:p>
             <a:pPr>
               <a:spcAft>
@@ -3478,7 +3533,25 @@
                 </a:solidFill>
                 <a:latin typeface="Calibri"/>
               </a:rPr>
-              <a:t>Fill in all placeholders before submitting — missing items are penalised. Paste the video link in this slide's comment section as well.</a:t>
+              <a:t>Fill in all placeholders before submitting — missing items are </a:t>
+            </a:r>
+            <a:r>
+              <a:rPr sz="1200" b="0" i="1" dirty="0" err="1">
+                <a:solidFill>
+                  <a:srgbClr val="555555"/>
+                </a:solidFill>
+                <a:latin typeface="Calibri"/>
+              </a:rPr>
+              <a:t>penalised</a:t>
+            </a:r>
+            <a:r>
+              <a:rPr sz="1200" b="0" i="1" dirty="0">
+                <a:solidFill>
+                  <a:srgbClr val="555555"/>
+                </a:solidFill>
+                <a:latin typeface="Calibri"/>
+              </a:rPr>
+              <a:t>. Paste the video link in this slide's comment section as well.</a:t>
             </a:r>
           </a:p>
         </p:txBody>
@@ -3492,7 +3565,7 @@
 </file>
 
 <file path=ppt/slides/slide10.xml><?xml version="1.0" encoding="utf-8"?>
-<p:sld xmlns:a="http://schemas.openxmlformats.org/drawingml/2006/main" xmlns:p="http://schemas.openxmlformats.org/presentationml/2006/main" xmlns:r="http://schemas.openxmlformats.org/officeDocument/2006/relationships">
+<p:sld xmlns:a="http://schemas.openxmlformats.org/drawingml/2006/main" xmlns:r="http://schemas.openxmlformats.org/officeDocument/2006/relationships" xmlns:p="http://schemas.openxmlformats.org/presentationml/2006/main">
   <p:cSld>
     <p:bg>
       <p:bgPr>
@@ -3508,7 +3581,14 @@
         <p:cNvGrpSpPr/>
         <p:nvPr/>
       </p:nvGrpSpPr>
-      <p:grpSpPr/>
+      <p:grpSpPr>
+        <a:xfrm>
+          <a:off x="0" y="0"/>
+          <a:ext cx="0" cy="0"/>
+          <a:chOff x="0" y="0"/>
+          <a:chExt cx="0" cy="0"/>
+        </a:xfrm>
+      </p:grpSpPr>
       <p:sp>
         <p:nvSpPr>
           <p:cNvPr id="2" name="TextBox 1"/>
@@ -3573,38 +3653,54 @@
                 <a:tableStyleId>{5C22544A-7EE6-4342-B048-85BDC9FD1C3A}</a:tableStyleId>
               </a:tblPr>
               <a:tblGrid>
-                <a:gridCol w="2677505"/>
-                <a:gridCol w="2368562"/>
-                <a:gridCol w="2883467"/>
-                <a:gridCol w="2677505"/>
+                <a:gridCol w="2677505">
+                  <a:extLst>
+                    <a:ext uri="{9D8B030D-6E8A-4147-A177-3AD203B41FA5}">
+                      <a16:colId xmlns:a16="http://schemas.microsoft.com/office/drawing/2014/main" val="20000"/>
+                    </a:ext>
+                  </a:extLst>
+                </a:gridCol>
+                <a:gridCol w="2368562">
+                  <a:extLst>
+                    <a:ext uri="{9D8B030D-6E8A-4147-A177-3AD203B41FA5}">
+                      <a16:colId xmlns:a16="http://schemas.microsoft.com/office/drawing/2014/main" val="20001"/>
+                    </a:ext>
+                  </a:extLst>
+                </a:gridCol>
+                <a:gridCol w="2883467">
+                  <a:extLst>
+                    <a:ext uri="{9D8B030D-6E8A-4147-A177-3AD203B41FA5}">
+                      <a16:colId xmlns:a16="http://schemas.microsoft.com/office/drawing/2014/main" val="20002"/>
+                    </a:ext>
+                  </a:extLst>
+                </a:gridCol>
+                <a:gridCol w="2677505">
+                  <a:extLst>
+                    <a:ext uri="{9D8B030D-6E8A-4147-A177-3AD203B41FA5}">
+                      <a16:colId xmlns:a16="http://schemas.microsoft.com/office/drawing/2014/main" val="20003"/>
+                    </a:ext>
+                  </a:extLst>
+                </a:gridCol>
               </a:tblGrid>
               <a:tr h="402336">
                 <a:tc>
                   <a:txBody>
-                    <a:bodyPr wrap="square"/>
+                    <a:bodyPr/>
                     <a:lstStyle/>
                     <a:p>
                       <a:pPr algn="l"/>
-                      <a:r>
-                        <a:rPr sz="1250" b="1" i="0">
-                          <a:solidFill>
-                            <a:srgbClr val="000000"/>
-                          </a:solidFill>
-                          <a:latin typeface="Calibri"/>
-                        </a:rPr>
-                        <a:t/>
-                      </a:r>
-                    </a:p>
-                  </a:txBody>
-                  <a:tcPr>
-                    <a:solidFill>
-                      <a:srgbClr val="FFFFFF"/>
-                    </a:solidFill>
-                  </a:tcPr>
-                </a:tc>
-                <a:tc>
-                  <a:txBody>
-                    <a:bodyPr wrap="square"/>
+                      <a:endParaRPr/>
+                    </a:p>
+                  </a:txBody>
+                  <a:tcPr>
+                    <a:solidFill>
+                      <a:srgbClr val="FFFFFF"/>
+                    </a:solidFill>
+                  </a:tcPr>
+                </a:tc>
+                <a:tc>
+                  <a:txBody>
+                    <a:bodyPr/>
                     <a:lstStyle/>
                     <a:p>
                       <a:pPr algn="ctr"/>
@@ -3627,7 +3723,7 @@
                 </a:tc>
                 <a:tc>
                   <a:txBody>
-                    <a:bodyPr wrap="square"/>
+                    <a:bodyPr/>
                     <a:lstStyle/>
                     <a:p>
                       <a:pPr algn="ctr"/>
@@ -3650,7 +3746,7 @@
                 </a:tc>
                 <a:tc>
                   <a:txBody>
-                    <a:bodyPr wrap="square"/>
+                    <a:bodyPr/>
                     <a:lstStyle/>
                     <a:p>
                       <a:pPr algn="ctr"/>
@@ -3671,11 +3767,16 @@
                     </a:solidFill>
                   </a:tcPr>
                 </a:tc>
+                <a:extLst>
+                  <a:ext uri="{0D108BD9-81ED-4DB2-BD59-A6C34878D82A}">
+                    <a16:rowId xmlns:a16="http://schemas.microsoft.com/office/drawing/2014/main" val="10000"/>
+                  </a:ext>
+                </a:extLst>
               </a:tr>
               <a:tr h="402336">
                 <a:tc>
                   <a:txBody>
-                    <a:bodyPr wrap="square"/>
+                    <a:bodyPr/>
                     <a:lstStyle/>
                     <a:p>
                       <a:pPr algn="l"/>
@@ -3698,7 +3799,7 @@
                 </a:tc>
                 <a:tc>
                   <a:txBody>
-                    <a:bodyPr wrap="square"/>
+                    <a:bodyPr/>
                     <a:lstStyle/>
                     <a:p>
                       <a:pPr algn="ctr"/>
@@ -3721,7 +3822,7 @@
                 </a:tc>
                 <a:tc>
                   <a:txBody>
-                    <a:bodyPr wrap="square"/>
+                    <a:bodyPr/>
                     <a:lstStyle/>
                     <a:p>
                       <a:pPr algn="ctr"/>
@@ -3744,7 +3845,7 @@
                 </a:tc>
                 <a:tc>
                   <a:txBody>
-                    <a:bodyPr wrap="square"/>
+                    <a:bodyPr/>
                     <a:lstStyle/>
                     <a:p>
                       <a:pPr algn="ctr"/>
@@ -3765,11 +3866,16 @@
                     </a:solidFill>
                   </a:tcPr>
                 </a:tc>
+                <a:extLst>
+                  <a:ext uri="{0D108BD9-81ED-4DB2-BD59-A6C34878D82A}">
+                    <a16:rowId xmlns:a16="http://schemas.microsoft.com/office/drawing/2014/main" val="10001"/>
+                  </a:ext>
+                </a:extLst>
               </a:tr>
               <a:tr h="402336">
                 <a:tc>
                   <a:txBody>
-                    <a:bodyPr wrap="square"/>
+                    <a:bodyPr/>
                     <a:lstStyle/>
                     <a:p>
                       <a:pPr algn="l"/>
@@ -3792,7 +3898,7 @@
                 </a:tc>
                 <a:tc>
                   <a:txBody>
-                    <a:bodyPr wrap="square"/>
+                    <a:bodyPr/>
                     <a:lstStyle/>
                     <a:p>
                       <a:pPr algn="ctr"/>
@@ -3815,7 +3921,7 @@
                 </a:tc>
                 <a:tc>
                   <a:txBody>
-                    <a:bodyPr wrap="square"/>
+                    <a:bodyPr/>
                     <a:lstStyle/>
                     <a:p>
                       <a:pPr algn="ctr"/>
@@ -3838,7 +3944,7 @@
                 </a:tc>
                 <a:tc>
                   <a:txBody>
-                    <a:bodyPr wrap="square"/>
+                    <a:bodyPr/>
                     <a:lstStyle/>
                     <a:p>
                       <a:pPr algn="ctr"/>
@@ -3859,11 +3965,16 @@
                     </a:solidFill>
                   </a:tcPr>
                 </a:tc>
+                <a:extLst>
+                  <a:ext uri="{0D108BD9-81ED-4DB2-BD59-A6C34878D82A}">
+                    <a16:rowId xmlns:a16="http://schemas.microsoft.com/office/drawing/2014/main" val="10002"/>
+                  </a:ext>
+                </a:extLst>
               </a:tr>
               <a:tr h="402336">
                 <a:tc>
                   <a:txBody>
-                    <a:bodyPr wrap="square"/>
+                    <a:bodyPr/>
                     <a:lstStyle/>
                     <a:p>
                       <a:pPr algn="l"/>
@@ -3886,7 +3997,7 @@
                 </a:tc>
                 <a:tc>
                   <a:txBody>
-                    <a:bodyPr wrap="square"/>
+                    <a:bodyPr/>
                     <a:lstStyle/>
                     <a:p>
                       <a:pPr algn="ctr"/>
@@ -3909,7 +4020,7 @@
                 </a:tc>
                 <a:tc>
                   <a:txBody>
-                    <a:bodyPr wrap="square"/>
+                    <a:bodyPr/>
                     <a:lstStyle/>
                     <a:p>
                       <a:pPr algn="ctr"/>
@@ -3932,7 +4043,7 @@
                 </a:tc>
                 <a:tc>
                   <a:txBody>
-                    <a:bodyPr wrap="square"/>
+                    <a:bodyPr/>
                     <a:lstStyle/>
                     <a:p>
                       <a:pPr algn="ctr"/>
@@ -3953,11 +4064,16 @@
                     </a:solidFill>
                   </a:tcPr>
                 </a:tc>
+                <a:extLst>
+                  <a:ext uri="{0D108BD9-81ED-4DB2-BD59-A6C34878D82A}">
+                    <a16:rowId xmlns:a16="http://schemas.microsoft.com/office/drawing/2014/main" val="10003"/>
+                  </a:ext>
+                </a:extLst>
               </a:tr>
               <a:tr h="402336">
                 <a:tc>
                   <a:txBody>
-                    <a:bodyPr wrap="square"/>
+                    <a:bodyPr/>
                     <a:lstStyle/>
                     <a:p>
                       <a:pPr algn="l"/>
@@ -3980,7 +4096,7 @@
                 </a:tc>
                 <a:tc>
                   <a:txBody>
-                    <a:bodyPr wrap="square"/>
+                    <a:bodyPr/>
                     <a:lstStyle/>
                     <a:p>
                       <a:pPr algn="ctr"/>
@@ -4003,7 +4119,7 @@
                 </a:tc>
                 <a:tc>
                   <a:txBody>
-                    <a:bodyPr wrap="square"/>
+                    <a:bodyPr/>
                     <a:lstStyle/>
                     <a:p>
                       <a:pPr algn="ctr"/>
@@ -4026,7 +4142,7 @@
                 </a:tc>
                 <a:tc>
                   <a:txBody>
-                    <a:bodyPr wrap="square"/>
+                    <a:bodyPr/>
                     <a:lstStyle/>
                     <a:p>
                       <a:pPr algn="ctr"/>
@@ -4047,6 +4163,11 @@
                     </a:solidFill>
                   </a:tcPr>
                 </a:tc>
+                <a:extLst>
+                  <a:ext uri="{0D108BD9-81ED-4DB2-BD59-A6C34878D82A}">
+                    <a16:rowId xmlns:a16="http://schemas.microsoft.com/office/drawing/2014/main" val="10004"/>
+                  </a:ext>
+                </a:extLst>
               </a:tr>
             </a:tbl>
           </a:graphicData>
@@ -4195,7 +4316,7 @@
 </file>
 
 <file path=ppt/slides/slide11.xml><?xml version="1.0" encoding="utf-8"?>
-<p:sld xmlns:a="http://schemas.openxmlformats.org/drawingml/2006/main" xmlns:p="http://schemas.openxmlformats.org/presentationml/2006/main" xmlns:r="http://schemas.openxmlformats.org/officeDocument/2006/relationships">
+<p:sld xmlns:a="http://schemas.openxmlformats.org/drawingml/2006/main" xmlns:r="http://schemas.openxmlformats.org/officeDocument/2006/relationships" xmlns:p="http://schemas.openxmlformats.org/presentationml/2006/main">
   <p:cSld>
     <p:bg>
       <p:bgPr>
@@ -4211,7 +4332,14 @@
         <p:cNvGrpSpPr/>
         <p:nvPr/>
       </p:nvGrpSpPr>
-      <p:grpSpPr/>
+      <p:grpSpPr>
+        <a:xfrm>
+          <a:off x="0" y="0"/>
+          <a:ext cx="0" cy="0"/>
+          <a:chOff x="0" y="0"/>
+          <a:chExt cx="0" cy="0"/>
+        </a:xfrm>
+      </p:grpSpPr>
       <p:sp>
         <p:nvSpPr>
           <p:cNvPr id="2" name="TextBox 1"/>
@@ -4367,14 +4495,32 @@
                 <a:tableStyleId>{5C22544A-7EE6-4342-B048-85BDC9FD1C3A}</a:tableStyleId>
               </a:tblPr>
               <a:tblGrid>
-                <a:gridCol w="4435671"/>
-                <a:gridCol w="2892829"/>
-                <a:gridCol w="3278539"/>
+                <a:gridCol w="4435671">
+                  <a:extLst>
+                    <a:ext uri="{9D8B030D-6E8A-4147-A177-3AD203B41FA5}">
+                      <a16:colId xmlns:a16="http://schemas.microsoft.com/office/drawing/2014/main" val="20000"/>
+                    </a:ext>
+                  </a:extLst>
+                </a:gridCol>
+                <a:gridCol w="2892829">
+                  <a:extLst>
+                    <a:ext uri="{9D8B030D-6E8A-4147-A177-3AD203B41FA5}">
+                      <a16:colId xmlns:a16="http://schemas.microsoft.com/office/drawing/2014/main" val="20001"/>
+                    </a:ext>
+                  </a:extLst>
+                </a:gridCol>
+                <a:gridCol w="3278539">
+                  <a:extLst>
+                    <a:ext uri="{9D8B030D-6E8A-4147-A177-3AD203B41FA5}">
+                      <a16:colId xmlns:a16="http://schemas.microsoft.com/office/drawing/2014/main" val="20002"/>
+                    </a:ext>
+                  </a:extLst>
+                </a:gridCol>
               </a:tblGrid>
               <a:tr h="378822">
                 <a:tc>
                   <a:txBody>
-                    <a:bodyPr wrap="square"/>
+                    <a:bodyPr/>
                     <a:lstStyle/>
                     <a:p>
                       <a:pPr algn="l"/>
@@ -4397,7 +4543,7 @@
                 </a:tc>
                 <a:tc>
                   <a:txBody>
-                    <a:bodyPr wrap="square"/>
+                    <a:bodyPr/>
                     <a:lstStyle/>
                     <a:p>
                       <a:pPr algn="ctr"/>
@@ -4420,7 +4566,7 @@
                 </a:tc>
                 <a:tc>
                   <a:txBody>
-                    <a:bodyPr wrap="square"/>
+                    <a:bodyPr/>
                     <a:lstStyle/>
                     <a:p>
                       <a:pPr algn="ctr"/>
@@ -4441,11 +4587,16 @@
                     </a:solidFill>
                   </a:tcPr>
                 </a:tc>
+                <a:extLst>
+                  <a:ext uri="{0D108BD9-81ED-4DB2-BD59-A6C34878D82A}">
+                    <a16:rowId xmlns:a16="http://schemas.microsoft.com/office/drawing/2014/main" val="10000"/>
+                  </a:ext>
+                </a:extLst>
               </a:tr>
               <a:tr h="378822">
                 <a:tc>
                   <a:txBody>
-                    <a:bodyPr wrap="square"/>
+                    <a:bodyPr/>
                     <a:lstStyle/>
                     <a:p>
                       <a:pPr algn="l"/>
@@ -4468,7 +4619,7 @@
                 </a:tc>
                 <a:tc>
                   <a:txBody>
-                    <a:bodyPr wrap="square"/>
+                    <a:bodyPr/>
                     <a:lstStyle/>
                     <a:p>
                       <a:pPr algn="ctr"/>
@@ -4491,7 +4642,7 @@
                 </a:tc>
                 <a:tc>
                   <a:txBody>
-                    <a:bodyPr wrap="square"/>
+                    <a:bodyPr/>
                     <a:lstStyle/>
                     <a:p>
                       <a:pPr algn="ctr"/>
@@ -4512,11 +4663,16 @@
                     </a:solidFill>
                   </a:tcPr>
                 </a:tc>
+                <a:extLst>
+                  <a:ext uri="{0D108BD9-81ED-4DB2-BD59-A6C34878D82A}">
+                    <a16:rowId xmlns:a16="http://schemas.microsoft.com/office/drawing/2014/main" val="10001"/>
+                  </a:ext>
+                </a:extLst>
               </a:tr>
               <a:tr h="378822">
                 <a:tc>
                   <a:txBody>
-                    <a:bodyPr wrap="square"/>
+                    <a:bodyPr/>
                     <a:lstStyle/>
                     <a:p>
                       <a:pPr algn="l"/>
@@ -4539,7 +4695,7 @@
                 </a:tc>
                 <a:tc>
                   <a:txBody>
-                    <a:bodyPr wrap="square"/>
+                    <a:bodyPr/>
                     <a:lstStyle/>
                     <a:p>
                       <a:pPr algn="ctr"/>
@@ -4562,7 +4718,7 @@
                 </a:tc>
                 <a:tc>
                   <a:txBody>
-                    <a:bodyPr wrap="square"/>
+                    <a:bodyPr/>
                     <a:lstStyle/>
                     <a:p>
                       <a:pPr algn="ctr"/>
@@ -4583,11 +4739,16 @@
                     </a:solidFill>
                   </a:tcPr>
                 </a:tc>
+                <a:extLst>
+                  <a:ext uri="{0D108BD9-81ED-4DB2-BD59-A6C34878D82A}">
+                    <a16:rowId xmlns:a16="http://schemas.microsoft.com/office/drawing/2014/main" val="10002"/>
+                  </a:ext>
+                </a:extLst>
               </a:tr>
               <a:tr h="378822">
                 <a:tc>
                   <a:txBody>
-                    <a:bodyPr wrap="square"/>
+                    <a:bodyPr/>
                     <a:lstStyle/>
                     <a:p>
                       <a:pPr algn="l"/>
@@ -4610,7 +4771,7 @@
                 </a:tc>
                 <a:tc>
                   <a:txBody>
-                    <a:bodyPr wrap="square"/>
+                    <a:bodyPr/>
                     <a:lstStyle/>
                     <a:p>
                       <a:pPr algn="ctr"/>
@@ -4633,7 +4794,7 @@
                 </a:tc>
                 <a:tc>
                   <a:txBody>
-                    <a:bodyPr wrap="square"/>
+                    <a:bodyPr/>
                     <a:lstStyle/>
                     <a:p>
                       <a:pPr algn="ctr"/>
@@ -4654,11 +4815,16 @@
                     </a:solidFill>
                   </a:tcPr>
                 </a:tc>
+                <a:extLst>
+                  <a:ext uri="{0D108BD9-81ED-4DB2-BD59-A6C34878D82A}">
+                    <a16:rowId xmlns:a16="http://schemas.microsoft.com/office/drawing/2014/main" val="10003"/>
+                  </a:ext>
+                </a:extLst>
               </a:tr>
               <a:tr h="378822">
                 <a:tc>
                   <a:txBody>
-                    <a:bodyPr wrap="square"/>
+                    <a:bodyPr/>
                     <a:lstStyle/>
                     <a:p>
                       <a:pPr algn="l"/>
@@ -4681,7 +4847,7 @@
                 </a:tc>
                 <a:tc>
                   <a:txBody>
-                    <a:bodyPr wrap="square"/>
+                    <a:bodyPr/>
                     <a:lstStyle/>
                     <a:p>
                       <a:pPr algn="ctr"/>
@@ -4704,7 +4870,7 @@
                 </a:tc>
                 <a:tc>
                   <a:txBody>
-                    <a:bodyPr wrap="square"/>
+                    <a:bodyPr/>
                     <a:lstStyle/>
                     <a:p>
                       <a:pPr algn="ctr"/>
@@ -4725,11 +4891,16 @@
                     </a:solidFill>
                   </a:tcPr>
                 </a:tc>
+                <a:extLst>
+                  <a:ext uri="{0D108BD9-81ED-4DB2-BD59-A6C34878D82A}">
+                    <a16:rowId xmlns:a16="http://schemas.microsoft.com/office/drawing/2014/main" val="10004"/>
+                  </a:ext>
+                </a:extLst>
               </a:tr>
               <a:tr h="378822">
                 <a:tc>
                   <a:txBody>
-                    <a:bodyPr wrap="square"/>
+                    <a:bodyPr/>
                     <a:lstStyle/>
                     <a:p>
                       <a:pPr algn="l"/>
@@ -4752,7 +4923,7 @@
                 </a:tc>
                 <a:tc>
                   <a:txBody>
-                    <a:bodyPr wrap="square"/>
+                    <a:bodyPr/>
                     <a:lstStyle/>
                     <a:p>
                       <a:pPr algn="ctr"/>
@@ -4775,7 +4946,7 @@
                 </a:tc>
                 <a:tc>
                   <a:txBody>
-                    <a:bodyPr wrap="square"/>
+                    <a:bodyPr/>
                     <a:lstStyle/>
                     <a:p>
                       <a:pPr algn="ctr"/>
@@ -4796,11 +4967,16 @@
                     </a:solidFill>
                   </a:tcPr>
                 </a:tc>
+                <a:extLst>
+                  <a:ext uri="{0D108BD9-81ED-4DB2-BD59-A6C34878D82A}">
+                    <a16:rowId xmlns:a16="http://schemas.microsoft.com/office/drawing/2014/main" val="10005"/>
+                  </a:ext>
+                </a:extLst>
               </a:tr>
               <a:tr h="378828">
                 <a:tc>
                   <a:txBody>
-                    <a:bodyPr wrap="square"/>
+                    <a:bodyPr/>
                     <a:lstStyle/>
                     <a:p>
                       <a:pPr algn="l"/>
@@ -4823,7 +4999,7 @@
                 </a:tc>
                 <a:tc>
                   <a:txBody>
-                    <a:bodyPr wrap="square"/>
+                    <a:bodyPr/>
                     <a:lstStyle/>
                     <a:p>
                       <a:pPr algn="ctr"/>
@@ -4846,7 +5022,7 @@
                 </a:tc>
                 <a:tc>
                   <a:txBody>
-                    <a:bodyPr wrap="square"/>
+                    <a:bodyPr/>
                     <a:lstStyle/>
                     <a:p>
                       <a:pPr algn="ctr"/>
@@ -4867,6 +5043,11 @@
                     </a:solidFill>
                   </a:tcPr>
                 </a:tc>
+                <a:extLst>
+                  <a:ext uri="{0D108BD9-81ED-4DB2-BD59-A6C34878D82A}">
+                    <a16:rowId xmlns:a16="http://schemas.microsoft.com/office/drawing/2014/main" val="10006"/>
+                  </a:ext>
+                </a:extLst>
               </a:tr>
             </a:tbl>
           </a:graphicData>
@@ -4945,7 +5126,7 @@
 </file>
 
 <file path=ppt/slides/slide12.xml><?xml version="1.0" encoding="utf-8"?>
-<p:sld xmlns:a="http://schemas.openxmlformats.org/drawingml/2006/main" xmlns:p="http://schemas.openxmlformats.org/presentationml/2006/main" xmlns:r="http://schemas.openxmlformats.org/officeDocument/2006/relationships">
+<p:sld xmlns:a="http://schemas.openxmlformats.org/drawingml/2006/main" xmlns:r="http://schemas.openxmlformats.org/officeDocument/2006/relationships" xmlns:p="http://schemas.openxmlformats.org/presentationml/2006/main">
   <p:cSld>
     <p:bg>
       <p:bgPr>
@@ -4961,7 +5142,14 @@
         <p:cNvGrpSpPr/>
         <p:nvPr/>
       </p:nvGrpSpPr>
-      <p:grpSpPr/>
+      <p:grpSpPr>
+        <a:xfrm>
+          <a:off x="0" y="0"/>
+          <a:ext cx="0" cy="0"/>
+          <a:chOff x="0" y="0"/>
+          <a:chExt cx="0" cy="0"/>
+        </a:xfrm>
+      </p:grpSpPr>
       <p:sp>
         <p:nvSpPr>
           <p:cNvPr id="2" name="TextBox 1"/>
@@ -5016,7 +5204,7 @@
           <p:nvPr/>
         </p:nvPicPr>
         <p:blipFill>
-          <a:blip r:embed="rId2"/>
+          <a:blip r:embed="rId3"/>
           <a:stretch>
             <a:fillRect/>
           </a:stretch>
@@ -5106,7 +5294,7 @@
 </file>
 
 <file path=ppt/slides/slide13.xml><?xml version="1.0" encoding="utf-8"?>
-<p:sld xmlns:a="http://schemas.openxmlformats.org/drawingml/2006/main" xmlns:p="http://schemas.openxmlformats.org/presentationml/2006/main" xmlns:r="http://schemas.openxmlformats.org/officeDocument/2006/relationships">
+<p:sld xmlns:a="http://schemas.openxmlformats.org/drawingml/2006/main" xmlns:r="http://schemas.openxmlformats.org/officeDocument/2006/relationships" xmlns:p="http://schemas.openxmlformats.org/presentationml/2006/main">
   <p:cSld>
     <p:bg>
       <p:bgPr>
@@ -5122,7 +5310,14 @@
         <p:cNvGrpSpPr/>
         <p:nvPr/>
       </p:nvGrpSpPr>
-      <p:grpSpPr/>
+      <p:grpSpPr>
+        <a:xfrm>
+          <a:off x="0" y="0"/>
+          <a:ext cx="0" cy="0"/>
+          <a:chOff x="0" y="0"/>
+          <a:chExt cx="0" cy="0"/>
+        </a:xfrm>
+      </p:grpSpPr>
       <p:sp>
         <p:nvSpPr>
           <p:cNvPr id="2" name="TextBox 1"/>
@@ -5307,7 +5502,7 @@
 </file>
 
 <file path=ppt/slides/slide14.xml><?xml version="1.0" encoding="utf-8"?>
-<p:sld xmlns:a="http://schemas.openxmlformats.org/drawingml/2006/main" xmlns:p="http://schemas.openxmlformats.org/presentationml/2006/main" xmlns:r="http://schemas.openxmlformats.org/officeDocument/2006/relationships">
+<p:sld xmlns:a="http://schemas.openxmlformats.org/drawingml/2006/main" xmlns:r="http://schemas.openxmlformats.org/officeDocument/2006/relationships" xmlns:p="http://schemas.openxmlformats.org/presentationml/2006/main">
   <p:cSld>
     <p:bg>
       <p:bgPr>
@@ -5323,7 +5518,14 @@
         <p:cNvGrpSpPr/>
         <p:nvPr/>
       </p:nvGrpSpPr>
-      <p:grpSpPr/>
+      <p:grpSpPr>
+        <a:xfrm>
+          <a:off x="0" y="0"/>
+          <a:ext cx="0" cy="0"/>
+          <a:chOff x="0" y="0"/>
+          <a:chExt cx="0" cy="0"/>
+        </a:xfrm>
+      </p:grpSpPr>
       <p:sp>
         <p:nvSpPr>
           <p:cNvPr id="2" name="TextBox 1"/>
@@ -5435,6 +5637,12 @@
                 <a:spcPts val="1100"/>
               </a:spcAft>
             </a:pPr>
+            <a:endParaRPr sz="1500" b="0" i="0">
+              <a:solidFill>
+                <a:srgbClr val="000000"/>
+              </a:solidFill>
+              <a:latin typeface="Calibri"/>
+            </a:endParaRPr>
           </a:p>
           <a:p>
             <a:pPr>
@@ -5608,7 +5816,7 @@
 </file>
 
 <file path=ppt/slides/slide15.xml><?xml version="1.0" encoding="utf-8"?>
-<p:sld xmlns:a="http://schemas.openxmlformats.org/drawingml/2006/main" xmlns:p="http://schemas.openxmlformats.org/presentationml/2006/main" xmlns:r="http://schemas.openxmlformats.org/officeDocument/2006/relationships">
+<p:sld xmlns:a="http://schemas.openxmlformats.org/drawingml/2006/main" xmlns:r="http://schemas.openxmlformats.org/officeDocument/2006/relationships" xmlns:p="http://schemas.openxmlformats.org/presentationml/2006/main">
   <p:cSld>
     <p:bg>
       <p:bgPr>
@@ -5624,7 +5832,14 @@
         <p:cNvGrpSpPr/>
         <p:nvPr/>
       </p:nvGrpSpPr>
-      <p:grpSpPr/>
+      <p:grpSpPr>
+        <a:xfrm>
+          <a:off x="0" y="0"/>
+          <a:ext cx="0" cy="0"/>
+          <a:chOff x="0" y="0"/>
+          <a:chExt cx="0" cy="0"/>
+        </a:xfrm>
+      </p:grpSpPr>
       <p:sp>
         <p:nvSpPr>
           <p:cNvPr id="2" name="TextBox 1"/>
@@ -5679,7 +5894,7 @@
           <p:nvPr/>
         </p:nvPicPr>
         <p:blipFill>
-          <a:blip r:embed="rId2"/>
+          <a:blip r:embed="rId3"/>
           <a:stretch>
             <a:fillRect/>
           </a:stretch>
@@ -5737,7 +5952,7 @@
 </file>
 
 <file path=ppt/slides/slide16.xml><?xml version="1.0" encoding="utf-8"?>
-<p:sld xmlns:a="http://schemas.openxmlformats.org/drawingml/2006/main" xmlns:p="http://schemas.openxmlformats.org/presentationml/2006/main" xmlns:r="http://schemas.openxmlformats.org/officeDocument/2006/relationships">
+<p:sld xmlns:a="http://schemas.openxmlformats.org/drawingml/2006/main" xmlns:r="http://schemas.openxmlformats.org/officeDocument/2006/relationships" xmlns:p="http://schemas.openxmlformats.org/presentationml/2006/main">
   <p:cSld>
     <p:bg>
       <p:bgPr>
@@ -5753,7 +5968,14 @@
         <p:cNvGrpSpPr/>
         <p:nvPr/>
       </p:nvGrpSpPr>
-      <p:grpSpPr/>
+      <p:grpSpPr>
+        <a:xfrm>
+          <a:off x="0" y="0"/>
+          <a:ext cx="0" cy="0"/>
+          <a:chOff x="0" y="0"/>
+          <a:chExt cx="0" cy="0"/>
+        </a:xfrm>
+      </p:grpSpPr>
       <p:sp>
         <p:nvSpPr>
           <p:cNvPr id="2" name="TextBox 1"/>
@@ -5808,7 +6030,7 @@
           <p:nvPr/>
         </p:nvPicPr>
         <p:blipFill>
-          <a:blip r:embed="rId2"/>
+          <a:blip r:embed="rId3"/>
           <a:stretch>
             <a:fillRect/>
           </a:stretch>
@@ -5866,7 +6088,7 @@
 </file>
 
 <file path=ppt/slides/slide2.xml><?xml version="1.0" encoding="utf-8"?>
-<p:sld xmlns:a="http://schemas.openxmlformats.org/drawingml/2006/main" xmlns:p="http://schemas.openxmlformats.org/presentationml/2006/main" xmlns:r="http://schemas.openxmlformats.org/officeDocument/2006/relationships">
+<p:sld xmlns:a="http://schemas.openxmlformats.org/drawingml/2006/main" xmlns:r="http://schemas.openxmlformats.org/officeDocument/2006/relationships" xmlns:p="http://schemas.openxmlformats.org/presentationml/2006/main">
   <p:cSld>
     <p:bg>
       <p:bgPr>
@@ -5882,7 +6104,14 @@
         <p:cNvGrpSpPr/>
         <p:nvPr/>
       </p:nvGrpSpPr>
-      <p:grpSpPr/>
+      <p:grpSpPr>
+        <a:xfrm>
+          <a:off x="0" y="0"/>
+          <a:ext cx="0" cy="0"/>
+          <a:chOff x="0" y="0"/>
+          <a:chExt cx="0" cy="0"/>
+        </a:xfrm>
+      </p:grpSpPr>
       <p:sp>
         <p:nvSpPr>
           <p:cNvPr id="2" name="TextBox 1"/>
@@ -6083,7 +6312,7 @@
           <p:nvPr/>
         </p:nvPicPr>
         <p:blipFill>
-          <a:blip r:embed="rId2"/>
+          <a:blip r:embed="rId3"/>
           <a:stretch>
             <a:fillRect/>
           </a:stretch>
@@ -6107,7 +6336,7 @@
 </file>
 
 <file path=ppt/slides/slide3.xml><?xml version="1.0" encoding="utf-8"?>
-<p:sld xmlns:a="http://schemas.openxmlformats.org/drawingml/2006/main" xmlns:p="http://schemas.openxmlformats.org/presentationml/2006/main" xmlns:r="http://schemas.openxmlformats.org/officeDocument/2006/relationships">
+<p:sld xmlns:a="http://schemas.openxmlformats.org/drawingml/2006/main" xmlns:r="http://schemas.openxmlformats.org/officeDocument/2006/relationships" xmlns:p="http://schemas.openxmlformats.org/presentationml/2006/main">
   <p:cSld>
     <p:bg>
       <p:bgPr>
@@ -6123,7 +6352,14 @@
         <p:cNvGrpSpPr/>
         <p:nvPr/>
       </p:nvGrpSpPr>
-      <p:grpSpPr/>
+      <p:grpSpPr>
+        <a:xfrm>
+          <a:off x="0" y="0"/>
+          <a:ext cx="0" cy="0"/>
+          <a:chOff x="0" y="0"/>
+          <a:chExt cx="0" cy="0"/>
+        </a:xfrm>
+      </p:grpSpPr>
       <p:sp>
         <p:nvSpPr>
           <p:cNvPr id="2" name="TextBox 1"/>
@@ -6165,6 +6401,294 @@
                 <a:latin typeface="Calibri"/>
               </a:rPr>
               <a:t>U-Net shape — but the deep layers use MLPs, not convolution or attention</a:t>
+            </a:r>
+          </a:p>
+        </p:txBody>
+      </p:sp>
+      <p:sp>
+        <p:nvSpPr>
+          <p:cNvPr id="3" name="TextBox 2"/>
+          <p:cNvSpPr txBox="1"/>
+          <p:nvPr/>
+        </p:nvSpPr>
+        <p:spPr>
+          <a:xfrm>
+            <a:off x="548641" y="1463040"/>
+            <a:ext cx="5079162" cy="3441968"/>
+          </a:xfrm>
+          <a:prstGeom prst="rect">
+            <a:avLst/>
+          </a:prstGeom>
+          <a:noFill/>
+        </p:spPr>
+        <p:txBody>
+          <a:bodyPr wrap="square">
+            <a:spAutoFit/>
+          </a:bodyPr>
+          <a:lstStyle/>
+          <a:p>
+            <a:pPr>
+              <a:spcAft>
+                <a:spcPts val="1000"/>
+              </a:spcAft>
+            </a:pPr>
+            <a:r>
+              <a:rPr sz="1600" b="1" i="0" dirty="0">
+                <a:solidFill>
+                  <a:srgbClr val="000000"/>
+                </a:solidFill>
+                <a:latin typeface="Calibri"/>
+              </a:rPr>
+              <a:t>Conv stage</a:t>
+            </a:r>
+            <a:r>
+              <a:rPr sz="1600" b="0" i="0" dirty="0">
+                <a:solidFill>
+                  <a:srgbClr val="000000"/>
+                </a:solidFill>
+                <a:latin typeface="Calibri"/>
+              </a:rPr>
+              <a:t> (3 shallow levels) — Conv3×3 → BN → </a:t>
+            </a:r>
+            <a:r>
+              <a:rPr sz="1600" b="0" i="0" dirty="0" err="1">
+                <a:solidFill>
+                  <a:srgbClr val="000000"/>
+                </a:solidFill>
+                <a:latin typeface="Calibri"/>
+              </a:rPr>
+              <a:t>ReLU</a:t>
+            </a:r>
+            <a:r>
+              <a:rPr sz="1600" b="0" i="0" dirty="0">
+                <a:solidFill>
+                  <a:srgbClr val="000000"/>
+                </a:solidFill>
+                <a:latin typeface="Calibri"/>
+              </a:rPr>
+              <a:t>, narrow channels (16/32/128)</a:t>
+            </a:r>
+          </a:p>
+          <a:p>
+            <a:pPr>
+              <a:spcAft>
+                <a:spcPts val="1000"/>
+              </a:spcAft>
+            </a:pPr>
+            <a:r>
+              <a:rPr sz="1600" b="1" i="0" dirty="0">
+                <a:solidFill>
+                  <a:srgbClr val="000000"/>
+                </a:solidFill>
+                <a:latin typeface="Calibri"/>
+              </a:rPr>
+              <a:t>Tokenized MLP stage</a:t>
+            </a:r>
+            <a:r>
+              <a:rPr sz="1600" b="0" i="0" dirty="0">
+                <a:solidFill>
+                  <a:srgbClr val="000000"/>
+                </a:solidFill>
+                <a:latin typeface="Calibri"/>
+              </a:rPr>
+              <a:t> (2 deep levels) — features are tokenized, then passed through shifted MLPs</a:t>
+            </a:r>
+          </a:p>
+          <a:p>
+            <a:pPr>
+              <a:spcAft>
+                <a:spcPts val="1000"/>
+              </a:spcAft>
+            </a:pPr>
+            <a:r>
+              <a:rPr sz="1600" b="1" i="0" dirty="0">
+                <a:solidFill>
+                  <a:srgbClr val="000000"/>
+                </a:solidFill>
+                <a:latin typeface="Calibri"/>
+              </a:rPr>
+              <a:t>Skip connections</a:t>
+            </a:r>
+            <a:r>
+              <a:rPr sz="1600" b="0" i="0" dirty="0">
+                <a:solidFill>
+                  <a:srgbClr val="000000"/>
+                </a:solidFill>
+                <a:latin typeface="Calibri"/>
+              </a:rPr>
+              <a:t> join matching encoder and decoder levels</a:t>
+            </a:r>
+          </a:p>
+          <a:p>
+            <a:pPr>
+              <a:spcAft>
+                <a:spcPts val="1000"/>
+              </a:spcAft>
+            </a:pPr>
+            <a:endParaRPr sz="1600" b="0" i="0" dirty="0">
+              <a:solidFill>
+                <a:srgbClr val="000000"/>
+              </a:solidFill>
+              <a:latin typeface="Calibri"/>
+            </a:endParaRPr>
+          </a:p>
+          <a:p>
+            <a:pPr>
+              <a:spcAft>
+                <a:spcPts val="1000"/>
+              </a:spcAft>
+            </a:pPr>
+            <a:r>
+              <a:rPr sz="1600" b="1" i="0" dirty="0">
+                <a:solidFill>
+                  <a:srgbClr val="000000"/>
+                </a:solidFill>
+                <a:latin typeface="Calibri"/>
+              </a:rPr>
+              <a:t>Why MLPs?</a:t>
+            </a:r>
+            <a:r>
+              <a:rPr sz="1600" b="0" i="0" dirty="0">
+                <a:solidFill>
+                  <a:srgbClr val="000000"/>
+                </a:solidFill>
+                <a:latin typeface="Calibri"/>
+              </a:rPr>
+              <a:t> Self-attention costs O(n²) in the number of tokens. MLPs are plain matrix multiplies — far cheaper.</a:t>
+            </a:r>
+          </a:p>
+          <a:p>
+            <a:pPr>
+              <a:spcAft>
+                <a:spcPts val="1000"/>
+              </a:spcAft>
+            </a:pPr>
+            <a:r>
+              <a:rPr sz="1600" b="1" i="0" dirty="0">
+                <a:solidFill>
+                  <a:srgbClr val="000000"/>
+                </a:solidFill>
+                <a:latin typeface="Calibri"/>
+              </a:rPr>
+              <a:t>The catch:</a:t>
+            </a:r>
+            <a:r>
+              <a:rPr sz="1600" b="0" i="0" dirty="0">
+                <a:solidFill>
+                  <a:srgbClr val="000000"/>
+                </a:solidFill>
+                <a:latin typeface="Calibri"/>
+              </a:rPr>
+              <a:t> an MLP is spatially blind. It has no notion of "adjacent pixel".</a:t>
+            </a:r>
+          </a:p>
+        </p:txBody>
+      </p:sp>
+      <p:pic>
+        <p:nvPicPr>
+          <p:cNvPr id="5" name="Picture 4">
+            <a:extLst>
+              <a:ext uri="{FF2B5EF4-FFF2-40B4-BE49-F238E27FC236}">
+                <a16:creationId xmlns:a16="http://schemas.microsoft.com/office/drawing/2014/main" id="{70128D3F-1A8A-BBDC-6EC2-1BB30C9B608E}"/>
+              </a:ext>
+            </a:extLst>
+          </p:cNvPr>
+          <p:cNvPicPr>
+            <a:picLocks noChangeAspect="1"/>
+          </p:cNvPicPr>
+          <p:nvPr/>
+        </p:nvPicPr>
+        <p:blipFill>
+          <a:blip r:embed="rId3"/>
+          <a:srcRect b="7143"/>
+          <a:stretch>
+            <a:fillRect/>
+          </a:stretch>
+        </p:blipFill>
+        <p:spPr>
+          <a:xfrm>
+            <a:off x="5760188" y="1039305"/>
+            <a:ext cx="6254273" cy="4355655"/>
+          </a:xfrm>
+          <a:prstGeom prst="rect">
+            <a:avLst/>
+          </a:prstGeom>
+        </p:spPr>
+      </p:pic>
+    </p:spTree>
+  </p:cSld>
+  <p:clrMapOvr>
+    <a:masterClrMapping/>
+  </p:clrMapOvr>
+</p:sld>
+</file>
+
+<file path=ppt/slides/slide4.xml><?xml version="1.0" encoding="utf-8"?>
+<p:sld xmlns:a="http://schemas.openxmlformats.org/drawingml/2006/main" xmlns:r="http://schemas.openxmlformats.org/officeDocument/2006/relationships" xmlns:p="http://schemas.openxmlformats.org/presentationml/2006/main">
+  <p:cSld>
+    <p:bg>
+      <p:bgPr>
+        <a:solidFill>
+          <a:srgbClr val="FFFFFF"/>
+        </a:solidFill>
+        <a:effectLst/>
+      </p:bgPr>
+    </p:bg>
+    <p:spTree>
+      <p:nvGrpSpPr>
+        <p:cNvPr id="1" name=""/>
+        <p:cNvGrpSpPr/>
+        <p:nvPr/>
+      </p:nvGrpSpPr>
+      <p:grpSpPr>
+        <a:xfrm>
+          <a:off x="0" y="0"/>
+          <a:ext cx="0" cy="0"/>
+          <a:chOff x="0" y="0"/>
+          <a:chExt cx="0" cy="0"/>
+        </a:xfrm>
+      </p:grpSpPr>
+      <p:sp>
+        <p:nvSpPr>
+          <p:cNvPr id="2" name="TextBox 1"/>
+          <p:cNvSpPr txBox="1"/>
+          <p:nvPr/>
+        </p:nvSpPr>
+        <p:spPr>
+          <a:xfrm>
+            <a:off x="548640" y="320040"/>
+            <a:ext cx="11094415" cy="822960"/>
+          </a:xfrm>
+          <a:prstGeom prst="rect">
+            <a:avLst/>
+          </a:prstGeom>
+          <a:noFill/>
+        </p:spPr>
+        <p:txBody>
+          <a:bodyPr wrap="square">
+            <a:spAutoFit/>
+          </a:bodyPr>
+          <a:lstStyle/>
+          <a:p>
+            <a:r>
+              <a:rPr sz="3000" b="1" i="0">
+                <a:solidFill>
+                  <a:srgbClr val="000000"/>
+                </a:solidFill>
+                <a:latin typeface="Calibri"/>
+              </a:rPr>
+              <a:t>The key trick: shifted MLPs</a:t>
+            </a:r>
+          </a:p>
+          <a:p>
+            <a:r>
+              <a:rPr sz="1400" b="0" i="1">
+                <a:solidFill>
+                  <a:srgbClr val="555555"/>
+                </a:solidFill>
+                <a:latin typeface="Calibri"/>
+              </a:rPr>
+              <a:t>How UNeXt gives an MLP a sense of locality — for free</a:t>
             </a:r>
           </a:p>
         </p:txBody>
@@ -6197,266 +6721,6 @@
               </a:spcAft>
             </a:pPr>
             <a:r>
-              <a:rPr sz="1600" b="1" i="0">
-                <a:solidFill>
-                  <a:srgbClr val="000000"/>
-                </a:solidFill>
-                <a:latin typeface="Calibri"/>
-              </a:rPr>
-              <a:t>Conv stage</a:t>
-            </a:r>
-            <a:r>
-              <a:rPr sz="1600" b="0" i="0">
-                <a:solidFill>
-                  <a:srgbClr val="000000"/>
-                </a:solidFill>
-                <a:latin typeface="Calibri"/>
-              </a:rPr>
-              <a:t> (3 shallow levels) — Conv3×3 → BN → ReLU, narrow channels (16/32/128)</a:t>
-            </a:r>
-          </a:p>
-          <a:p>
-            <a:pPr>
-              <a:spcAft>
-                <a:spcPts val="1000"/>
-              </a:spcAft>
-            </a:pPr>
-            <a:r>
-              <a:rPr sz="1600" b="1" i="0">
-                <a:solidFill>
-                  <a:srgbClr val="000000"/>
-                </a:solidFill>
-                <a:latin typeface="Calibri"/>
-              </a:rPr>
-              <a:t>Tokenized MLP stage</a:t>
-            </a:r>
-            <a:r>
-              <a:rPr sz="1600" b="0" i="0">
-                <a:solidFill>
-                  <a:srgbClr val="000000"/>
-                </a:solidFill>
-                <a:latin typeface="Calibri"/>
-              </a:rPr>
-              <a:t> (2 deep levels) — features are tokenized, then passed through shifted MLPs</a:t>
-            </a:r>
-          </a:p>
-          <a:p>
-            <a:pPr>
-              <a:spcAft>
-                <a:spcPts val="1000"/>
-              </a:spcAft>
-            </a:pPr>
-            <a:r>
-              <a:rPr sz="1600" b="1" i="0">
-                <a:solidFill>
-                  <a:srgbClr val="000000"/>
-                </a:solidFill>
-                <a:latin typeface="Calibri"/>
-              </a:rPr>
-              <a:t>Skip connections</a:t>
-            </a:r>
-            <a:r>
-              <a:rPr sz="1600" b="0" i="0">
-                <a:solidFill>
-                  <a:srgbClr val="000000"/>
-                </a:solidFill>
-                <a:latin typeface="Calibri"/>
-              </a:rPr>
-              <a:t> join matching encoder and decoder levels</a:t>
-            </a:r>
-          </a:p>
-          <a:p>
-            <a:pPr>
-              <a:spcAft>
-                <a:spcPts val="1000"/>
-              </a:spcAft>
-            </a:pPr>
-          </a:p>
-          <a:p>
-            <a:pPr>
-              <a:spcAft>
-                <a:spcPts val="1000"/>
-              </a:spcAft>
-            </a:pPr>
-            <a:r>
-              <a:rPr sz="1600" b="1" i="0">
-                <a:solidFill>
-                  <a:srgbClr val="000000"/>
-                </a:solidFill>
-                <a:latin typeface="Calibri"/>
-              </a:rPr>
-              <a:t>Why MLPs?</a:t>
-            </a:r>
-            <a:r>
-              <a:rPr sz="1600" b="0" i="0">
-                <a:solidFill>
-                  <a:srgbClr val="000000"/>
-                </a:solidFill>
-                <a:latin typeface="Calibri"/>
-              </a:rPr>
-              <a:t> Self-attention costs O(n²) in the number of tokens. MLPs are plain matrix multiplies — far cheaper.</a:t>
-            </a:r>
-          </a:p>
-          <a:p>
-            <a:pPr>
-              <a:spcAft>
-                <a:spcPts val="1000"/>
-              </a:spcAft>
-            </a:pPr>
-            <a:r>
-              <a:rPr sz="1600" b="1" i="0">
-                <a:solidFill>
-                  <a:srgbClr val="000000"/>
-                </a:solidFill>
-                <a:latin typeface="Calibri"/>
-              </a:rPr>
-              <a:t>The catch:</a:t>
-            </a:r>
-            <a:r>
-              <a:rPr sz="1600" b="0" i="0">
-                <a:solidFill>
-                  <a:srgbClr val="000000"/>
-                </a:solidFill>
-                <a:latin typeface="Calibri"/>
-              </a:rPr>
-              <a:t> an MLP is spatially blind. It has no notion of "adjacent pixel".</a:t>
-            </a:r>
-          </a:p>
-        </p:txBody>
-      </p:sp>
-      <p:sp>
-        <p:nvSpPr>
-          <p:cNvPr id="4" name="TextBox 3"/>
-          <p:cNvSpPr txBox="1"/>
-          <p:nvPr/>
-        </p:nvSpPr>
-        <p:spPr>
-          <a:xfrm>
-            <a:off x="548640" y="6199632"/>
-            <a:ext cx="11094415" cy="457200"/>
-          </a:xfrm>
-          <a:prstGeom prst="rect">
-            <a:avLst/>
-          </a:prstGeom>
-          <a:noFill/>
-        </p:spPr>
-        <p:txBody>
-          <a:bodyPr wrap="square">
-            <a:spAutoFit/>
-          </a:bodyPr>
-          <a:lstStyle/>
-          <a:p>
-            <a:r>
-              <a:rPr sz="1200" b="0" i="1">
-                <a:solidFill>
-                  <a:srgbClr val="555555"/>
-                </a:solidFill>
-                <a:latin typeface="Calibri"/>
-              </a:rPr>
-              <a:t>Architecture figure: insert unext/imgs/unext.png from the official repository here.</a:t>
-            </a:r>
-          </a:p>
-        </p:txBody>
-      </p:sp>
-    </p:spTree>
-  </p:cSld>
-  <p:clrMapOvr>
-    <a:masterClrMapping/>
-  </p:clrMapOvr>
-</p:sld>
-</file>
-
-<file path=ppt/slides/slide4.xml><?xml version="1.0" encoding="utf-8"?>
-<p:sld xmlns:a="http://schemas.openxmlformats.org/drawingml/2006/main" xmlns:p="http://schemas.openxmlformats.org/presentationml/2006/main" xmlns:r="http://schemas.openxmlformats.org/officeDocument/2006/relationships">
-  <p:cSld>
-    <p:bg>
-      <p:bgPr>
-        <a:solidFill>
-          <a:srgbClr val="FFFFFF"/>
-        </a:solidFill>
-        <a:effectLst/>
-      </p:bgPr>
-    </p:bg>
-    <p:spTree>
-      <p:nvGrpSpPr>
-        <p:cNvPr id="1" name=""/>
-        <p:cNvGrpSpPr/>
-        <p:nvPr/>
-      </p:nvGrpSpPr>
-      <p:grpSpPr/>
-      <p:sp>
-        <p:nvSpPr>
-          <p:cNvPr id="2" name="TextBox 1"/>
-          <p:cNvSpPr txBox="1"/>
-          <p:nvPr/>
-        </p:nvSpPr>
-        <p:spPr>
-          <a:xfrm>
-            <a:off x="548640" y="320040"/>
-            <a:ext cx="11094415" cy="822960"/>
-          </a:xfrm>
-          <a:prstGeom prst="rect">
-            <a:avLst/>
-          </a:prstGeom>
-          <a:noFill/>
-        </p:spPr>
-        <p:txBody>
-          <a:bodyPr wrap="square">
-            <a:spAutoFit/>
-          </a:bodyPr>
-          <a:lstStyle/>
-          <a:p>
-            <a:r>
-              <a:rPr sz="3000" b="1" i="0">
-                <a:solidFill>
-                  <a:srgbClr val="000000"/>
-                </a:solidFill>
-                <a:latin typeface="Calibri"/>
-              </a:rPr>
-              <a:t>The key trick: shifted MLPs</a:t>
-            </a:r>
-          </a:p>
-          <a:p>
-            <a:r>
-              <a:rPr sz="1400" b="0" i="1">
-                <a:solidFill>
-                  <a:srgbClr val="555555"/>
-                </a:solidFill>
-                <a:latin typeface="Calibri"/>
-              </a:rPr>
-              <a:t>How UNeXt gives an MLP a sense of locality — for free</a:t>
-            </a:r>
-          </a:p>
-        </p:txBody>
-      </p:sp>
-      <p:sp>
-        <p:nvSpPr>
-          <p:cNvPr id="3" name="TextBox 2"/>
-          <p:cNvSpPr txBox="1"/>
-          <p:nvPr/>
-        </p:nvSpPr>
-        <p:spPr>
-          <a:xfrm>
-            <a:off x="548640" y="1463040"/>
-            <a:ext cx="11094415" cy="4937760"/>
-          </a:xfrm>
-          <a:prstGeom prst="rect">
-            <a:avLst/>
-          </a:prstGeom>
-          <a:noFill/>
-        </p:spPr>
-        <p:txBody>
-          <a:bodyPr wrap="square">
-            <a:spAutoFit/>
-          </a:bodyPr>
-          <a:lstStyle/>
-          <a:p>
-            <a:pPr>
-              <a:spcAft>
-                <a:spcPts val="1000"/>
-              </a:spcAft>
-            </a:pPr>
-            <a:r>
               <a:rPr sz="1500" b="0" i="0">
                 <a:solidFill>
                   <a:srgbClr val="000000"/>
@@ -6571,15 +6835,39 @@
                 <a:tableStyleId>{5C22544A-7EE6-4342-B048-85BDC9FD1C3A}</a:tableStyleId>
               </a:tblPr>
               <a:tblGrid>
-                <a:gridCol w="3698138"/>
-                <a:gridCol w="2465425"/>
-                <a:gridCol w="2465425"/>
-                <a:gridCol w="2465425"/>
+                <a:gridCol w="3698138">
+                  <a:extLst>
+                    <a:ext uri="{9D8B030D-6E8A-4147-A177-3AD203B41FA5}">
+                      <a16:colId xmlns:a16="http://schemas.microsoft.com/office/drawing/2014/main" val="20000"/>
+                    </a:ext>
+                  </a:extLst>
+                </a:gridCol>
+                <a:gridCol w="2465425">
+                  <a:extLst>
+                    <a:ext uri="{9D8B030D-6E8A-4147-A177-3AD203B41FA5}">
+                      <a16:colId xmlns:a16="http://schemas.microsoft.com/office/drawing/2014/main" val="20001"/>
+                    </a:ext>
+                  </a:extLst>
+                </a:gridCol>
+                <a:gridCol w="2465425">
+                  <a:extLst>
+                    <a:ext uri="{9D8B030D-6E8A-4147-A177-3AD203B41FA5}">
+                      <a16:colId xmlns:a16="http://schemas.microsoft.com/office/drawing/2014/main" val="20002"/>
+                    </a:ext>
+                  </a:extLst>
+                </a:gridCol>
+                <a:gridCol w="2465425">
+                  <a:extLst>
+                    <a:ext uri="{9D8B030D-6E8A-4147-A177-3AD203B41FA5}">
+                      <a16:colId xmlns:a16="http://schemas.microsoft.com/office/drawing/2014/main" val="20003"/>
+                    </a:ext>
+                  </a:extLst>
+                </a:gridCol>
               </a:tblGrid>
               <a:tr h="438912">
                 <a:tc>
                   <a:txBody>
-                    <a:bodyPr wrap="square"/>
+                    <a:bodyPr/>
                     <a:lstStyle/>
                     <a:p>
                       <a:pPr algn="l"/>
@@ -6602,7 +6890,7 @@
                 </a:tc>
                 <a:tc>
                   <a:txBody>
-                    <a:bodyPr wrap="square"/>
+                    <a:bodyPr/>
                     <a:lstStyle/>
                     <a:p>
                       <a:pPr algn="ctr"/>
@@ -6625,7 +6913,7 @@
                 </a:tc>
                 <a:tc>
                   <a:txBody>
-                    <a:bodyPr wrap="square"/>
+                    <a:bodyPr/>
                     <a:lstStyle/>
                     <a:p>
                       <a:pPr algn="ctr"/>
@@ -6648,7 +6936,7 @@
                 </a:tc>
                 <a:tc>
                   <a:txBody>
-                    <a:bodyPr wrap="square"/>
+                    <a:bodyPr/>
                     <a:lstStyle/>
                     <a:p>
                       <a:pPr algn="ctr"/>
@@ -6669,11 +6957,16 @@
                     </a:solidFill>
                   </a:tcPr>
                 </a:tc>
+                <a:extLst>
+                  <a:ext uri="{0D108BD9-81ED-4DB2-BD59-A6C34878D82A}">
+                    <a16:rowId xmlns:a16="http://schemas.microsoft.com/office/drawing/2014/main" val="10000"/>
+                  </a:ext>
+                </a:extLst>
               </a:tr>
               <a:tr h="438912">
                 <a:tc>
                   <a:txBody>
-                    <a:bodyPr wrap="square"/>
+                    <a:bodyPr/>
                     <a:lstStyle/>
                     <a:p>
                       <a:pPr algn="l"/>
@@ -6696,7 +6989,7 @@
                 </a:tc>
                 <a:tc>
                   <a:txBody>
-                    <a:bodyPr wrap="square"/>
+                    <a:bodyPr/>
                     <a:lstStyle/>
                     <a:p>
                       <a:pPr algn="ctr"/>
@@ -6719,7 +7012,7 @@
                 </a:tc>
                 <a:tc>
                   <a:txBody>
-                    <a:bodyPr wrap="square"/>
+                    <a:bodyPr/>
                     <a:lstStyle/>
                     <a:p>
                       <a:pPr algn="ctr"/>
@@ -6742,7 +7035,7 @@
                 </a:tc>
                 <a:tc>
                   <a:txBody>
-                    <a:bodyPr wrap="square"/>
+                    <a:bodyPr/>
                     <a:lstStyle/>
                     <a:p>
                       <a:pPr algn="ctr"/>
@@ -6763,11 +7056,16 @@
                     </a:solidFill>
                   </a:tcPr>
                 </a:tc>
+                <a:extLst>
+                  <a:ext uri="{0D108BD9-81ED-4DB2-BD59-A6C34878D82A}">
+                    <a16:rowId xmlns:a16="http://schemas.microsoft.com/office/drawing/2014/main" val="10001"/>
+                  </a:ext>
+                </a:extLst>
               </a:tr>
               <a:tr h="438912">
                 <a:tc>
                   <a:txBody>
-                    <a:bodyPr wrap="square"/>
+                    <a:bodyPr/>
                     <a:lstStyle/>
                     <a:p>
                       <a:pPr algn="l"/>
@@ -6790,7 +7088,7 @@
                 </a:tc>
                 <a:tc>
                   <a:txBody>
-                    <a:bodyPr wrap="square"/>
+                    <a:bodyPr/>
                     <a:lstStyle/>
                     <a:p>
                       <a:pPr algn="ctr"/>
@@ -6813,7 +7111,7 @@
                 </a:tc>
                 <a:tc>
                   <a:txBody>
-                    <a:bodyPr wrap="square"/>
+                    <a:bodyPr/>
                     <a:lstStyle/>
                     <a:p>
                       <a:pPr algn="ctr"/>
@@ -6836,7 +7134,7 @@
                 </a:tc>
                 <a:tc>
                   <a:txBody>
-                    <a:bodyPr wrap="square"/>
+                    <a:bodyPr/>
                     <a:lstStyle/>
                     <a:p>
                       <a:pPr algn="ctr"/>
@@ -6857,11 +7155,16 @@
                     </a:solidFill>
                   </a:tcPr>
                 </a:tc>
+                <a:extLst>
+                  <a:ext uri="{0D108BD9-81ED-4DB2-BD59-A6C34878D82A}">
+                    <a16:rowId xmlns:a16="http://schemas.microsoft.com/office/drawing/2014/main" val="10002"/>
+                  </a:ext>
+                </a:extLst>
               </a:tr>
               <a:tr h="438912">
                 <a:tc>
                   <a:txBody>
-                    <a:bodyPr wrap="square"/>
+                    <a:bodyPr/>
                     <a:lstStyle/>
                     <a:p>
                       <a:pPr algn="l"/>
@@ -6884,7 +7187,7 @@
                 </a:tc>
                 <a:tc>
                   <a:txBody>
-                    <a:bodyPr wrap="square"/>
+                    <a:bodyPr/>
                     <a:lstStyle/>
                     <a:p>
                       <a:pPr algn="ctr"/>
@@ -6907,7 +7210,7 @@
                 </a:tc>
                 <a:tc>
                   <a:txBody>
-                    <a:bodyPr wrap="square"/>
+                    <a:bodyPr/>
                     <a:lstStyle/>
                     <a:p>
                       <a:pPr algn="ctr"/>
@@ -6930,7 +7233,7 @@
                 </a:tc>
                 <a:tc>
                   <a:txBody>
-                    <a:bodyPr wrap="square"/>
+                    <a:bodyPr/>
                     <a:lstStyle/>
                     <a:p>
                       <a:pPr algn="ctr"/>
@@ -6951,11 +7254,16 @@
                     </a:solidFill>
                   </a:tcPr>
                 </a:tc>
+                <a:extLst>
+                  <a:ext uri="{0D108BD9-81ED-4DB2-BD59-A6C34878D82A}">
+                    <a16:rowId xmlns:a16="http://schemas.microsoft.com/office/drawing/2014/main" val="10003"/>
+                  </a:ext>
+                </a:extLst>
               </a:tr>
               <a:tr h="438912">
                 <a:tc>
                   <a:txBody>
-                    <a:bodyPr wrap="square"/>
+                    <a:bodyPr/>
                     <a:lstStyle/>
                     <a:p>
                       <a:pPr algn="l"/>
@@ -6978,7 +7286,7 @@
                 </a:tc>
                 <a:tc>
                   <a:txBody>
-                    <a:bodyPr wrap="square"/>
+                    <a:bodyPr/>
                     <a:lstStyle/>
                     <a:p>
                       <a:pPr algn="ctr"/>
@@ -7001,7 +7309,7 @@
                 </a:tc>
                 <a:tc>
                   <a:txBody>
-                    <a:bodyPr wrap="square"/>
+                    <a:bodyPr/>
                     <a:lstStyle/>
                     <a:p>
                       <a:pPr algn="ctr"/>
@@ -7024,7 +7332,7 @@
                 </a:tc>
                 <a:tc>
                   <a:txBody>
-                    <a:bodyPr wrap="square"/>
+                    <a:bodyPr/>
                     <a:lstStyle/>
                     <a:p>
                       <a:pPr algn="ctr"/>
@@ -7045,6 +7353,11 @@
                     </a:solidFill>
                   </a:tcPr>
                 </a:tc>
+                <a:extLst>
+                  <a:ext uri="{0D108BD9-81ED-4DB2-BD59-A6C34878D82A}">
+                    <a16:rowId xmlns:a16="http://schemas.microsoft.com/office/drawing/2014/main" val="10004"/>
+                  </a:ext>
+                </a:extLst>
               </a:tr>
             </a:tbl>
           </a:graphicData>
@@ -7093,7 +7406,7 @@
 </file>
 
 <file path=ppt/slides/slide5.xml><?xml version="1.0" encoding="utf-8"?>
-<p:sld xmlns:a="http://schemas.openxmlformats.org/drawingml/2006/main" xmlns:p="http://schemas.openxmlformats.org/presentationml/2006/main" xmlns:r="http://schemas.openxmlformats.org/officeDocument/2006/relationships">
+<p:sld xmlns:a="http://schemas.openxmlformats.org/drawingml/2006/main" xmlns:r="http://schemas.openxmlformats.org/officeDocument/2006/relationships" xmlns:p="http://schemas.openxmlformats.org/presentationml/2006/main">
   <p:cSld>
     <p:bg>
       <p:bgPr>
@@ -7109,7 +7422,14 @@
         <p:cNvGrpSpPr/>
         <p:nvPr/>
       </p:nvGrpSpPr>
-      <p:grpSpPr/>
+      <p:grpSpPr>
+        <a:xfrm>
+          <a:off x="0" y="0"/>
+          <a:ext cx="0" cy="0"/>
+          <a:chOff x="0" y="0"/>
+          <a:chExt cx="0" cy="0"/>
+        </a:xfrm>
+      </p:grpSpPr>
       <p:sp>
         <p:nvSpPr>
           <p:cNvPr id="2" name="TextBox 1"/>
@@ -7290,14 +7610,32 @@
                 <a:tableStyleId>{5C22544A-7EE6-4342-B048-85BDC9FD1C3A}</a:tableStyleId>
               </a:tblPr>
               <a:tblGrid>
-                <a:gridCol w="3840480"/>
-                <a:gridCol w="1920240"/>
-                <a:gridCol w="1920240"/>
+                <a:gridCol w="3840480">
+                  <a:extLst>
+                    <a:ext uri="{9D8B030D-6E8A-4147-A177-3AD203B41FA5}">
+                      <a16:colId xmlns:a16="http://schemas.microsoft.com/office/drawing/2014/main" val="20000"/>
+                    </a:ext>
+                  </a:extLst>
+                </a:gridCol>
+                <a:gridCol w="1920240">
+                  <a:extLst>
+                    <a:ext uri="{9D8B030D-6E8A-4147-A177-3AD203B41FA5}">
+                      <a16:colId xmlns:a16="http://schemas.microsoft.com/office/drawing/2014/main" val="20001"/>
+                    </a:ext>
+                  </a:extLst>
+                </a:gridCol>
+                <a:gridCol w="1920240">
+                  <a:extLst>
+                    <a:ext uri="{9D8B030D-6E8A-4147-A177-3AD203B41FA5}">
+                      <a16:colId xmlns:a16="http://schemas.microsoft.com/office/drawing/2014/main" val="20002"/>
+                    </a:ext>
+                  </a:extLst>
+                </a:gridCol>
               </a:tblGrid>
               <a:tr h="457200">
                 <a:tc>
                   <a:txBody>
-                    <a:bodyPr wrap="square"/>
+                    <a:bodyPr/>
                     <a:lstStyle/>
                     <a:p>
                       <a:pPr algn="l"/>
@@ -7320,7 +7658,7 @@
                 </a:tc>
                 <a:tc>
                   <a:txBody>
-                    <a:bodyPr wrap="square"/>
+                    <a:bodyPr/>
                     <a:lstStyle/>
                     <a:p>
                       <a:pPr algn="ctr"/>
@@ -7343,7 +7681,7 @@
                 </a:tc>
                 <a:tc>
                   <a:txBody>
-                    <a:bodyPr wrap="square"/>
+                    <a:bodyPr/>
                     <a:lstStyle/>
                     <a:p>
                       <a:pPr algn="ctr"/>
@@ -7364,11 +7702,16 @@
                     </a:solidFill>
                   </a:tcPr>
                 </a:tc>
+                <a:extLst>
+                  <a:ext uri="{0D108BD9-81ED-4DB2-BD59-A6C34878D82A}">
+                    <a16:rowId xmlns:a16="http://schemas.microsoft.com/office/drawing/2014/main" val="10000"/>
+                  </a:ext>
+                </a:extLst>
               </a:tr>
               <a:tr h="457200">
                 <a:tc>
                   <a:txBody>
-                    <a:bodyPr wrap="square"/>
+                    <a:bodyPr/>
                     <a:lstStyle/>
                     <a:p>
                       <a:pPr algn="l"/>
@@ -7391,7 +7734,7 @@
                 </a:tc>
                 <a:tc>
                   <a:txBody>
-                    <a:bodyPr wrap="square"/>
+                    <a:bodyPr/>
                     <a:lstStyle/>
                     <a:p>
                       <a:pPr algn="ctr"/>
@@ -7414,7 +7757,7 @@
                 </a:tc>
                 <a:tc>
                   <a:txBody>
-                    <a:bodyPr wrap="square"/>
+                    <a:bodyPr/>
                     <a:lstStyle/>
                     <a:p>
                       <a:pPr algn="ctr"/>
@@ -7435,11 +7778,16 @@
                     </a:solidFill>
                   </a:tcPr>
                 </a:tc>
+                <a:extLst>
+                  <a:ext uri="{0D108BD9-81ED-4DB2-BD59-A6C34878D82A}">
+                    <a16:rowId xmlns:a16="http://schemas.microsoft.com/office/drawing/2014/main" val="10001"/>
+                  </a:ext>
+                </a:extLst>
               </a:tr>
               <a:tr h="457200">
                 <a:tc>
                   <a:txBody>
-                    <a:bodyPr wrap="square"/>
+                    <a:bodyPr/>
                     <a:lstStyle/>
                     <a:p>
                       <a:pPr algn="l"/>
@@ -7462,7 +7810,7 @@
                 </a:tc>
                 <a:tc>
                   <a:txBody>
-                    <a:bodyPr wrap="square"/>
+                    <a:bodyPr/>
                     <a:lstStyle/>
                     <a:p>
                       <a:pPr algn="ctr"/>
@@ -7485,7 +7833,7 @@
                 </a:tc>
                 <a:tc>
                   <a:txBody>
-                    <a:bodyPr wrap="square"/>
+                    <a:bodyPr/>
                     <a:lstStyle/>
                     <a:p>
                       <a:pPr algn="ctr"/>
@@ -7506,11 +7854,16 @@
                     </a:solidFill>
                   </a:tcPr>
                 </a:tc>
+                <a:extLst>
+                  <a:ext uri="{0D108BD9-81ED-4DB2-BD59-A6C34878D82A}">
+                    <a16:rowId xmlns:a16="http://schemas.microsoft.com/office/drawing/2014/main" val="10002"/>
+                  </a:ext>
+                </a:extLst>
               </a:tr>
               <a:tr h="457200">
                 <a:tc>
                   <a:txBody>
-                    <a:bodyPr wrap="square"/>
+                    <a:bodyPr/>
                     <a:lstStyle/>
                     <a:p>
                       <a:pPr algn="l"/>
@@ -7533,7 +7886,7 @@
                 </a:tc>
                 <a:tc>
                   <a:txBody>
-                    <a:bodyPr wrap="square"/>
+                    <a:bodyPr/>
                     <a:lstStyle/>
                     <a:p>
                       <a:pPr algn="ctr"/>
@@ -7556,7 +7909,7 @@
                 </a:tc>
                 <a:tc>
                   <a:txBody>
-                    <a:bodyPr wrap="square"/>
+                    <a:bodyPr/>
                     <a:lstStyle/>
                     <a:p>
                       <a:pPr algn="ctr"/>
@@ -7577,6 +7930,11 @@
                     </a:solidFill>
                   </a:tcPr>
                 </a:tc>
+                <a:extLst>
+                  <a:ext uri="{0D108BD9-81ED-4DB2-BD59-A6C34878D82A}">
+                    <a16:rowId xmlns:a16="http://schemas.microsoft.com/office/drawing/2014/main" val="10003"/>
+                  </a:ext>
+                </a:extLst>
               </a:tr>
             </a:tbl>
           </a:graphicData>
@@ -7625,7 +7983,7 @@
 </file>
 
 <file path=ppt/slides/slide6.xml><?xml version="1.0" encoding="utf-8"?>
-<p:sld xmlns:a="http://schemas.openxmlformats.org/drawingml/2006/main" xmlns:p="http://schemas.openxmlformats.org/presentationml/2006/main" xmlns:r="http://schemas.openxmlformats.org/officeDocument/2006/relationships">
+<p:sld xmlns:a="http://schemas.openxmlformats.org/drawingml/2006/main" xmlns:r="http://schemas.openxmlformats.org/officeDocument/2006/relationships" xmlns:p="http://schemas.openxmlformats.org/presentationml/2006/main">
   <p:cSld>
     <p:bg>
       <p:bgPr>
@@ -7641,7 +7999,14 @@
         <p:cNvGrpSpPr/>
         <p:nvPr/>
       </p:nvGrpSpPr>
-      <p:grpSpPr/>
+      <p:grpSpPr>
+        <a:xfrm>
+          <a:off x="0" y="0"/>
+          <a:ext cx="0" cy="0"/>
+          <a:chOff x="0" y="0"/>
+          <a:chExt cx="0" cy="0"/>
+        </a:xfrm>
+      </p:grpSpPr>
       <p:sp>
         <p:nvSpPr>
           <p:cNvPr id="2" name="TextBox 1"/>
@@ -7828,7 +8193,7 @@
           <p:nvPr/>
         </p:nvPicPr>
         <p:blipFill>
-          <a:blip r:embed="rId2"/>
+          <a:blip r:embed="rId3"/>
           <a:stretch>
             <a:fillRect/>
           </a:stretch>
@@ -7886,7 +8251,7 @@
 </file>
 
 <file path=ppt/slides/slide7.xml><?xml version="1.0" encoding="utf-8"?>
-<p:sld xmlns:a="http://schemas.openxmlformats.org/drawingml/2006/main" xmlns:p="http://schemas.openxmlformats.org/presentationml/2006/main" xmlns:r="http://schemas.openxmlformats.org/officeDocument/2006/relationships">
+<p:sld xmlns:a="http://schemas.openxmlformats.org/drawingml/2006/main" xmlns:r="http://schemas.openxmlformats.org/officeDocument/2006/relationships" xmlns:p="http://schemas.openxmlformats.org/presentationml/2006/main">
   <p:cSld>
     <p:bg>
       <p:bgPr>
@@ -7902,7 +8267,14 @@
         <p:cNvGrpSpPr/>
         <p:nvPr/>
       </p:nvGrpSpPr>
-      <p:grpSpPr/>
+      <p:grpSpPr>
+        <a:xfrm>
+          <a:off x="0" y="0"/>
+          <a:ext cx="0" cy="0"/>
+          <a:chOff x="0" y="0"/>
+          <a:chExt cx="0" cy="0"/>
+        </a:xfrm>
+      </p:grpSpPr>
       <p:sp>
         <p:nvSpPr>
           <p:cNvPr id="2" name="TextBox 1"/>
@@ -7956,15 +8328,39 @@
                 <a:tableStyleId>{5C22544A-7EE6-4342-B048-85BDC9FD1C3A}</a:tableStyleId>
               </a:tblPr>
               <a:tblGrid>
-                <a:gridCol w="560323"/>
-                <a:gridCol w="3586073"/>
-                <a:gridCol w="2465425"/>
-                <a:gridCol w="4482591"/>
+                <a:gridCol w="560323">
+                  <a:extLst>
+                    <a:ext uri="{9D8B030D-6E8A-4147-A177-3AD203B41FA5}">
+                      <a16:colId xmlns:a16="http://schemas.microsoft.com/office/drawing/2014/main" val="20000"/>
+                    </a:ext>
+                  </a:extLst>
+                </a:gridCol>
+                <a:gridCol w="3586073">
+                  <a:extLst>
+                    <a:ext uri="{9D8B030D-6E8A-4147-A177-3AD203B41FA5}">
+                      <a16:colId xmlns:a16="http://schemas.microsoft.com/office/drawing/2014/main" val="20001"/>
+                    </a:ext>
+                  </a:extLst>
+                </a:gridCol>
+                <a:gridCol w="2465425">
+                  <a:extLst>
+                    <a:ext uri="{9D8B030D-6E8A-4147-A177-3AD203B41FA5}">
+                      <a16:colId xmlns:a16="http://schemas.microsoft.com/office/drawing/2014/main" val="20002"/>
+                    </a:ext>
+                  </a:extLst>
+                </a:gridCol>
+                <a:gridCol w="4482591">
+                  <a:extLst>
+                    <a:ext uri="{9D8B030D-6E8A-4147-A177-3AD203B41FA5}">
+                      <a16:colId xmlns:a16="http://schemas.microsoft.com/office/drawing/2014/main" val="20003"/>
+                    </a:ext>
+                  </a:extLst>
+                </a:gridCol>
               </a:tblGrid>
               <a:tr h="487680">
                 <a:tc>
                   <a:txBody>
-                    <a:bodyPr wrap="square"/>
+                    <a:bodyPr/>
                     <a:lstStyle/>
                     <a:p>
                       <a:pPr algn="l"/>
@@ -7987,7 +8383,7 @@
                 </a:tc>
                 <a:tc>
                   <a:txBody>
-                    <a:bodyPr wrap="square"/>
+                    <a:bodyPr/>
                     <a:lstStyle/>
                     <a:p>
                       <a:pPr algn="ctr"/>
@@ -8010,7 +8406,7 @@
                 </a:tc>
                 <a:tc>
                   <a:txBody>
-                    <a:bodyPr wrap="square"/>
+                    <a:bodyPr/>
                     <a:lstStyle/>
                     <a:p>
                       <a:pPr algn="ctr"/>
@@ -8033,7 +8429,7 @@
                 </a:tc>
                 <a:tc>
                   <a:txBody>
-                    <a:bodyPr wrap="square"/>
+                    <a:bodyPr/>
                     <a:lstStyle/>
                     <a:p>
                       <a:pPr algn="ctr"/>
@@ -8054,11 +8450,16 @@
                     </a:solidFill>
                   </a:tcPr>
                 </a:tc>
+                <a:extLst>
+                  <a:ext uri="{0D108BD9-81ED-4DB2-BD59-A6C34878D82A}">
+                    <a16:rowId xmlns:a16="http://schemas.microsoft.com/office/drawing/2014/main" val="10000"/>
+                  </a:ext>
+                </a:extLst>
               </a:tr>
               <a:tr h="487680">
                 <a:tc>
                   <a:txBody>
-                    <a:bodyPr wrap="square"/>
+                    <a:bodyPr/>
                     <a:lstStyle/>
                     <a:p>
                       <a:pPr algn="l"/>
@@ -8081,7 +8482,7 @@
                 </a:tc>
                 <a:tc>
                   <a:txBody>
-                    <a:bodyPr wrap="square"/>
+                    <a:bodyPr/>
                     <a:lstStyle/>
                     <a:p>
                       <a:pPr algn="ctr"/>
@@ -8104,7 +8505,7 @@
                 </a:tc>
                 <a:tc>
                   <a:txBody>
-                    <a:bodyPr wrap="square"/>
+                    <a:bodyPr/>
                     <a:lstStyle/>
                     <a:p>
                       <a:pPr algn="ctr"/>
@@ -8127,7 +8528,7 @@
                 </a:tc>
                 <a:tc>
                   <a:txBody>
-                    <a:bodyPr wrap="square"/>
+                    <a:bodyPr/>
                     <a:lstStyle/>
                     <a:p>
                       <a:pPr algn="ctr"/>
@@ -8148,11 +8549,16 @@
                     </a:solidFill>
                   </a:tcPr>
                 </a:tc>
+                <a:extLst>
+                  <a:ext uri="{0D108BD9-81ED-4DB2-BD59-A6C34878D82A}">
+                    <a16:rowId xmlns:a16="http://schemas.microsoft.com/office/drawing/2014/main" val="10001"/>
+                  </a:ext>
+                </a:extLst>
               </a:tr>
               <a:tr h="487680">
                 <a:tc>
                   <a:txBody>
-                    <a:bodyPr wrap="square"/>
+                    <a:bodyPr/>
                     <a:lstStyle/>
                     <a:p>
                       <a:pPr algn="l"/>
@@ -8175,7 +8581,7 @@
                 </a:tc>
                 <a:tc>
                   <a:txBody>
-                    <a:bodyPr wrap="square"/>
+                    <a:bodyPr/>
                     <a:lstStyle/>
                     <a:p>
                       <a:pPr algn="ctr"/>
@@ -8198,7 +8604,7 @@
                 </a:tc>
                 <a:tc>
                   <a:txBody>
-                    <a:bodyPr wrap="square"/>
+                    <a:bodyPr/>
                     <a:lstStyle/>
                     <a:p>
                       <a:pPr algn="ctr"/>
@@ -8221,7 +8627,7 @@
                 </a:tc>
                 <a:tc>
                   <a:txBody>
-                    <a:bodyPr wrap="square"/>
+                    <a:bodyPr/>
                     <a:lstStyle/>
                     <a:p>
                       <a:pPr algn="ctr"/>
@@ -8242,11 +8648,16 @@
                     </a:solidFill>
                   </a:tcPr>
                 </a:tc>
+                <a:extLst>
+                  <a:ext uri="{0D108BD9-81ED-4DB2-BD59-A6C34878D82A}">
+                    <a16:rowId xmlns:a16="http://schemas.microsoft.com/office/drawing/2014/main" val="10002"/>
+                  </a:ext>
+                </a:extLst>
               </a:tr>
               <a:tr h="487680">
                 <a:tc>
                   <a:txBody>
-                    <a:bodyPr wrap="square"/>
+                    <a:bodyPr/>
                     <a:lstStyle/>
                     <a:p>
                       <a:pPr algn="l"/>
@@ -8269,7 +8680,7 @@
                 </a:tc>
                 <a:tc>
                   <a:txBody>
-                    <a:bodyPr wrap="square"/>
+                    <a:bodyPr/>
                     <a:lstStyle/>
                     <a:p>
                       <a:pPr algn="ctr"/>
@@ -8292,7 +8703,7 @@
                 </a:tc>
                 <a:tc>
                   <a:txBody>
-                    <a:bodyPr wrap="square"/>
+                    <a:bodyPr/>
                     <a:lstStyle/>
                     <a:p>
                       <a:pPr algn="ctr"/>
@@ -8315,7 +8726,7 @@
                 </a:tc>
                 <a:tc>
                   <a:txBody>
-                    <a:bodyPr wrap="square"/>
+                    <a:bodyPr/>
                     <a:lstStyle/>
                     <a:p>
                       <a:pPr algn="ctr"/>
@@ -8336,11 +8747,16 @@
                     </a:solidFill>
                   </a:tcPr>
                 </a:tc>
+                <a:extLst>
+                  <a:ext uri="{0D108BD9-81ED-4DB2-BD59-A6C34878D82A}">
+                    <a16:rowId xmlns:a16="http://schemas.microsoft.com/office/drawing/2014/main" val="10003"/>
+                  </a:ext>
+                </a:extLst>
               </a:tr>
               <a:tr h="487680">
                 <a:tc>
                   <a:txBody>
-                    <a:bodyPr wrap="square"/>
+                    <a:bodyPr/>
                     <a:lstStyle/>
                     <a:p>
                       <a:pPr algn="l"/>
@@ -8363,7 +8779,7 @@
                 </a:tc>
                 <a:tc>
                   <a:txBody>
-                    <a:bodyPr wrap="square"/>
+                    <a:bodyPr/>
                     <a:lstStyle/>
                     <a:p>
                       <a:pPr algn="ctr"/>
@@ -8386,7 +8802,7 @@
                 </a:tc>
                 <a:tc>
                   <a:txBody>
-                    <a:bodyPr wrap="square"/>
+                    <a:bodyPr/>
                     <a:lstStyle/>
                     <a:p>
                       <a:pPr algn="ctr"/>
@@ -8409,7 +8825,7 @@
                 </a:tc>
                 <a:tc>
                   <a:txBody>
-                    <a:bodyPr wrap="square"/>
+                    <a:bodyPr/>
                     <a:lstStyle/>
                     <a:p>
                       <a:pPr algn="ctr"/>
@@ -8430,11 +8846,16 @@
                     </a:solidFill>
                   </a:tcPr>
                 </a:tc>
+                <a:extLst>
+                  <a:ext uri="{0D108BD9-81ED-4DB2-BD59-A6C34878D82A}">
+                    <a16:rowId xmlns:a16="http://schemas.microsoft.com/office/drawing/2014/main" val="10004"/>
+                  </a:ext>
+                </a:extLst>
               </a:tr>
               <a:tr h="487680">
                 <a:tc>
                   <a:txBody>
-                    <a:bodyPr wrap="square"/>
+                    <a:bodyPr/>
                     <a:lstStyle/>
                     <a:p>
                       <a:pPr algn="l"/>
@@ -8457,7 +8878,7 @@
                 </a:tc>
                 <a:tc>
                   <a:txBody>
-                    <a:bodyPr wrap="square"/>
+                    <a:bodyPr/>
                     <a:lstStyle/>
                     <a:p>
                       <a:pPr algn="ctr"/>
@@ -8480,7 +8901,7 @@
                 </a:tc>
                 <a:tc>
                   <a:txBody>
-                    <a:bodyPr wrap="square"/>
+                    <a:bodyPr/>
                     <a:lstStyle/>
                     <a:p>
                       <a:pPr algn="ctr"/>
@@ -8503,7 +8924,7 @@
                 </a:tc>
                 <a:tc>
                   <a:txBody>
-                    <a:bodyPr wrap="square"/>
+                    <a:bodyPr/>
                     <a:lstStyle/>
                     <a:p>
                       <a:pPr algn="ctr"/>
@@ -8524,6 +8945,11 @@
                     </a:solidFill>
                   </a:tcPr>
                 </a:tc>
+                <a:extLst>
+                  <a:ext uri="{0D108BD9-81ED-4DB2-BD59-A6C34878D82A}">
+                    <a16:rowId xmlns:a16="http://schemas.microsoft.com/office/drawing/2014/main" val="10005"/>
+                  </a:ext>
+                </a:extLst>
               </a:tr>
             </a:tbl>
           </a:graphicData>
@@ -8611,7 +9037,7 @@
 </file>
 
 <file path=ppt/slides/slide8.xml><?xml version="1.0" encoding="utf-8"?>
-<p:sld xmlns:a="http://schemas.openxmlformats.org/drawingml/2006/main" xmlns:p="http://schemas.openxmlformats.org/presentationml/2006/main" xmlns:r="http://schemas.openxmlformats.org/officeDocument/2006/relationships">
+<p:sld xmlns:a="http://schemas.openxmlformats.org/drawingml/2006/main" xmlns:r="http://schemas.openxmlformats.org/officeDocument/2006/relationships" xmlns:p="http://schemas.openxmlformats.org/presentationml/2006/main">
   <p:cSld>
     <p:bg>
       <p:bgPr>
@@ -8627,7 +9053,14 @@
         <p:cNvGrpSpPr/>
         <p:nvPr/>
       </p:nvGrpSpPr>
-      <p:grpSpPr/>
+      <p:grpSpPr>
+        <a:xfrm>
+          <a:off x="0" y="0"/>
+          <a:ext cx="0" cy="0"/>
+          <a:chOff x="0" y="0"/>
+          <a:chExt cx="0" cy="0"/>
+        </a:xfrm>
+      </p:grpSpPr>
       <p:sp>
         <p:nvSpPr>
           <p:cNvPr id="2" name="TextBox 1"/>
@@ -8823,7 +9256,7 @@
           <p:nvPr/>
         </p:nvPicPr>
         <p:blipFill>
-          <a:blip r:embed="rId2"/>
+          <a:blip r:embed="rId3"/>
           <a:stretch>
             <a:fillRect/>
           </a:stretch>
@@ -8847,7 +9280,7 @@
 </file>
 
 <file path=ppt/slides/slide9.xml><?xml version="1.0" encoding="utf-8"?>
-<p:sld xmlns:a="http://schemas.openxmlformats.org/drawingml/2006/main" xmlns:p="http://schemas.openxmlformats.org/presentationml/2006/main" xmlns:r="http://schemas.openxmlformats.org/officeDocument/2006/relationships">
+<p:sld xmlns:a="http://schemas.openxmlformats.org/drawingml/2006/main" xmlns:r="http://schemas.openxmlformats.org/officeDocument/2006/relationships" xmlns:p="http://schemas.openxmlformats.org/presentationml/2006/main">
   <p:cSld>
     <p:bg>
       <p:bgPr>
@@ -8863,7 +9296,14 @@
         <p:cNvGrpSpPr/>
         <p:nvPr/>
       </p:nvGrpSpPr>
-      <p:grpSpPr/>
+      <p:grpSpPr>
+        <a:xfrm>
+          <a:off x="0" y="0"/>
+          <a:ext cx="0" cy="0"/>
+          <a:chOff x="0" y="0"/>
+          <a:chExt cx="0" cy="0"/>
+        </a:xfrm>
+      </p:grpSpPr>
       <p:sp>
         <p:nvSpPr>
           <p:cNvPr id="2" name="TextBox 1"/>
@@ -8918,7 +9358,7 @@
           <p:nvPr/>
         </p:nvPicPr>
         <p:blipFill>
-          <a:blip r:embed="rId2"/>
+          <a:blip r:embed="rId3"/>
           <a:stretch>
             <a:fillRect/>
           </a:stretch>
@@ -8941,12 +9381,93 @@
         </p:nvSpPr>
         <p:spPr>
           <a:xfrm>
-            <a:off x="548640" y="4114800"/>
-            <a:ext cx="11094415" cy="2286000"/>
+            <a:off x="548640" y="5257799"/>
+            <a:ext cx="11094415" cy="1428161"/>
           </a:xfrm>
-          <a:prstGeom prst="rect">
+          <a:custGeom>
             <a:avLst/>
-          </a:prstGeom>
+            <a:gdLst>
+              <a:gd name="csX0" fmla="*/ 0 w 11094415"/>
+              <a:gd name="csY0" fmla="*/ 0 h 2286000"/>
+              <a:gd name="csX1" fmla="*/ 11094415 w 11094415"/>
+              <a:gd name="csY1" fmla="*/ 0 h 2286000"/>
+              <a:gd name="csX2" fmla="*/ 11094415 w 11094415"/>
+              <a:gd name="csY2" fmla="*/ 2286000 h 2286000"/>
+              <a:gd name="csX3" fmla="*/ 0 w 11094415"/>
+              <a:gd name="csY3" fmla="*/ 2286000 h 2286000"/>
+              <a:gd name="csX4" fmla="*/ 0 w 11094415"/>
+              <a:gd name="csY4" fmla="*/ 0 h 2286000"/>
+              <a:gd name="csX0" fmla="*/ 0 w 11094415"/>
+              <a:gd name="csY0" fmla="*/ 0 h 2286000"/>
+              <a:gd name="csX1" fmla="*/ 11094415 w 11094415"/>
+              <a:gd name="csY1" fmla="*/ 0 h 2286000"/>
+              <a:gd name="csX2" fmla="*/ 11009573 w 11094415"/>
+              <a:gd name="csY2" fmla="*/ 1362173 h 2286000"/>
+              <a:gd name="csX3" fmla="*/ 0 w 11094415"/>
+              <a:gd name="csY3" fmla="*/ 2286000 h 2286000"/>
+              <a:gd name="csX4" fmla="*/ 0 w 11094415"/>
+              <a:gd name="csY4" fmla="*/ 0 h 2286000"/>
+              <a:gd name="csX0" fmla="*/ 0 w 11094415"/>
+              <a:gd name="csY0" fmla="*/ 0 h 2286000"/>
+              <a:gd name="csX1" fmla="*/ 11094415 w 11094415"/>
+              <a:gd name="csY1" fmla="*/ 0 h 2286000"/>
+              <a:gd name="csX2" fmla="*/ 11075560 w 11094415"/>
+              <a:gd name="csY2" fmla="*/ 1428161 h 2286000"/>
+              <a:gd name="csX3" fmla="*/ 0 w 11094415"/>
+              <a:gd name="csY3" fmla="*/ 2286000 h 2286000"/>
+              <a:gd name="csX4" fmla="*/ 0 w 11094415"/>
+              <a:gd name="csY4" fmla="*/ 0 h 2286000"/>
+              <a:gd name="csX0" fmla="*/ 0 w 11094415"/>
+              <a:gd name="csY0" fmla="*/ 0 h 1428161"/>
+              <a:gd name="csX1" fmla="*/ 11094415 w 11094415"/>
+              <a:gd name="csY1" fmla="*/ 0 h 1428161"/>
+              <a:gd name="csX2" fmla="*/ 11075560 w 11094415"/>
+              <a:gd name="csY2" fmla="*/ 1428161 h 1428161"/>
+              <a:gd name="csX3" fmla="*/ 0 w 11094415"/>
+              <a:gd name="csY3" fmla="*/ 1428160 h 1428161"/>
+              <a:gd name="csX4" fmla="*/ 0 w 11094415"/>
+              <a:gd name="csY4" fmla="*/ 0 h 1428161"/>
+            </a:gdLst>
+            <a:ahLst/>
+            <a:cxnLst>
+              <a:cxn ang="0">
+                <a:pos x="csX0" y="csY0"/>
+              </a:cxn>
+              <a:cxn ang="0">
+                <a:pos x="csX1" y="csY1"/>
+              </a:cxn>
+              <a:cxn ang="0">
+                <a:pos x="csX2" y="csY2"/>
+              </a:cxn>
+              <a:cxn ang="0">
+                <a:pos x="csX3" y="csY3"/>
+              </a:cxn>
+              <a:cxn ang="0">
+                <a:pos x="csX4" y="csY4"/>
+              </a:cxn>
+            </a:cxnLst>
+            <a:rect l="l" t="t" r="r" b="b"/>
+            <a:pathLst>
+              <a:path w="11094415" h="1428161">
+                <a:moveTo>
+                  <a:pt x="0" y="0"/>
+                </a:moveTo>
+                <a:lnTo>
+                  <a:pt x="11094415" y="0"/>
+                </a:lnTo>
+                <a:lnTo>
+                  <a:pt x="11075560" y="1428161"/>
+                </a:lnTo>
+                <a:lnTo>
+                  <a:pt x="0" y="1428160"/>
+                </a:lnTo>
+                <a:lnTo>
+                  <a:pt x="0" y="0"/>
+                </a:lnTo>
+                <a:close/>
+              </a:path>
+            </a:pathLst>
+          </a:custGeom>
           <a:noFill/>
         </p:spPr>
         <p:txBody>
@@ -8961,16 +9482,34 @@
               </a:spcAft>
             </a:pPr>
             <a:r>
-              <a:rPr sz="1400" b="1" i="0">
-                <a:solidFill>
-                  <a:srgbClr val="000000"/>
-                </a:solidFill>
-                <a:latin typeface="Calibri"/>
-              </a:rPr>
-              <a:t>Mean IoU 0.5931 → 0.6328 (+0.040).</a:t>
-            </a:r>
-            <a:r>
-              <a:rPr sz="1400" b="0" i="0">
+              <a:rPr sz="1400" b="1" i="0" dirty="0">
+                <a:solidFill>
+                  <a:srgbClr val="000000"/>
+                </a:solidFill>
+                <a:latin typeface="Calibri"/>
+              </a:rPr>
+              <a:t>Mean </a:t>
+            </a:r>
+            <a:r>
+              <a:rPr sz="1400" b="1" i="0" dirty="0" err="1">
+                <a:solidFill>
+                  <a:srgbClr val="000000"/>
+                </a:solidFill>
+                <a:latin typeface="Calibri"/>
+              </a:rPr>
+              <a:t>IoU</a:t>
+            </a:r>
+            <a:r>
+              <a:rPr sz="1400" b="1" i="0" dirty="0">
+                <a:solidFill>
+                  <a:srgbClr val="000000"/>
+                </a:solidFill>
+                <a:latin typeface="Calibri"/>
+              </a:rPr>
+              <a:t> 0.5931 → 0.6328 (+0.040).</a:t>
+            </a:r>
+            <a:r>
+              <a:rPr sz="1400" b="0" i="0" dirty="0">
                 <a:solidFill>
                   <a:srgbClr val="000000"/>
                 </a:solidFill>
@@ -8986,7 +9525,7 @@
               </a:spcAft>
             </a:pPr>
             <a:r>
-              <a:rPr sz="1400" b="0" i="0">
+              <a:rPr sz="1400" b="0" i="0" dirty="0">
                 <a:solidFill>
                   <a:srgbClr val="000000"/>
                 </a:solidFill>
@@ -8995,7 +9534,7 @@
               <a:t>Overfitting gap cut </a:t>
             </a:r>
             <a:r>
-              <a:rPr sz="1400" b="1" i="0">
+              <a:rPr sz="1400" b="1" i="0" dirty="0">
                 <a:solidFill>
                   <a:srgbClr val="000000"/>
                 </a:solidFill>
@@ -9004,7 +9543,7 @@
               <a:t>60%</a:t>
             </a:r>
             <a:r>
-              <a:rPr sz="1400" b="0" i="0">
+              <a:rPr sz="1400" b="0" i="0" dirty="0">
                 <a:solidFill>
                   <a:srgbClr val="000000"/>
                 </a:solidFill>
@@ -9013,7 +9552,7 @@
               <a:t>; Dice variance collapsed </a:t>
             </a:r>
             <a:r>
-              <a:rPr sz="1400" b="1" i="0">
+              <a:rPr sz="1400" b="1" i="0" dirty="0">
                 <a:solidFill>
                   <a:srgbClr val="000000"/>
                 </a:solidFill>
@@ -9022,7 +9561,7 @@
               <a:t>15×</a:t>
             </a:r>
             <a:r>
-              <a:rPr sz="1400" b="0" i="0">
+              <a:rPr sz="1400" b="0" i="0" dirty="0">
                 <a:solidFill>
                   <a:srgbClr val="000000"/>
                 </a:solidFill>
@@ -9038,7 +9577,7 @@
               </a:spcAft>
             </a:pPr>
             <a:r>
-              <a:rPr sz="1400" b="1" i="0">
+              <a:rPr sz="1400" b="1" i="0" dirty="0">
                 <a:solidFill>
                   <a:srgbClr val="000000"/>
                 </a:solidFill>
@@ -9047,7 +9586,7 @@
               <a:t>Honest caveat:</a:t>
             </a:r>
             <a:r>
-              <a:rPr sz="1400" b="0" i="0">
+              <a:rPr sz="1400" b="0" i="0" dirty="0">
                 <a:solidFill>
                   <a:srgbClr val="000000"/>
                 </a:solidFill>
@@ -9056,7 +9595,7 @@
               <a:t> at a *matched* 100-epoch budget augmentation gives no gain. It does not converge faster — it </a:t>
             </a:r>
             <a:r>
-              <a:rPr sz="1400" b="1" i="0">
+              <a:rPr sz="1400" b="1" i="0" dirty="0">
                 <a:solidFill>
                   <a:srgbClr val="000000"/>
                 </a:solidFill>
@@ -9065,7 +9604,7 @@
               <a:t>removes the ceiling</a:t>
             </a:r>
             <a:r>
-              <a:rPr sz="1400" b="0" i="0">
+              <a:rPr sz="1400" b="0" i="0" dirty="0">
                 <a:solidFill>
                   <a:srgbClr val="000000"/>
                 </a:solidFill>
@@ -9415,44 +9954,44 @@
         <a:sysClr val="window" lastClr="FFFFFF"/>
       </a:lt1>
       <a:dk2>
-        <a:srgbClr val="1F497D"/>
+        <a:srgbClr val="44546A"/>
       </a:dk2>
       <a:lt2>
-        <a:srgbClr val="EEECE1"/>
+        <a:srgbClr val="E7E6E6"/>
       </a:lt2>
       <a:accent1>
-        <a:srgbClr val="4F81BD"/>
+        <a:srgbClr val="4472C4"/>
       </a:accent1>
       <a:accent2>
-        <a:srgbClr val="C0504D"/>
+        <a:srgbClr val="ED7D31"/>
       </a:accent2>
       <a:accent3>
-        <a:srgbClr val="9BBB59"/>
+        <a:srgbClr val="A5A5A5"/>
       </a:accent3>
       <a:accent4>
-        <a:srgbClr val="8064A2"/>
+        <a:srgbClr val="FFC000"/>
       </a:accent4>
       <a:accent5>
-        <a:srgbClr val="4BACC6"/>
+        <a:srgbClr val="5B9BD5"/>
       </a:accent5>
       <a:accent6>
-        <a:srgbClr val="F79646"/>
+        <a:srgbClr val="70AD47"/>
       </a:accent6>
       <a:hlink>
-        <a:srgbClr val="0000FF"/>
+        <a:srgbClr val="0563C1"/>
       </a:hlink>
       <a:folHlink>
-        <a:srgbClr val="800080"/>
+        <a:srgbClr val="954F72"/>
       </a:folHlink>
     </a:clrScheme>
     <a:fontScheme name="Office">
       <a:majorFont>
-        <a:latin typeface="Calibri"/>
+        <a:latin typeface="Calibri Light" panose="020F0302020204030204"/>
         <a:ea typeface=""/>
         <a:cs typeface=""/>
-        <a:font script="Jpan" typeface="ＭＳ Ｐゴシック"/>
+        <a:font script="Jpan" typeface="游ゴシック Light"/>
         <a:font script="Hang" typeface="맑은 고딕"/>
-        <a:font script="Hans" typeface="宋体"/>
+        <a:font script="Hans" typeface="等线 Light"/>
         <a:font script="Hant" typeface="新細明體"/>
         <a:font script="Arab" typeface="Times New Roman"/>
         <a:font script="Hebr" typeface="Times New Roman"/>
@@ -9480,14 +10019,31 @@
         <a:font script="Viet" typeface="Times New Roman"/>
         <a:font script="Uigh" typeface="Microsoft Uighur"/>
         <a:font script="Geor" typeface="Sylfaen"/>
+        <a:font script="Armn" typeface="Arial"/>
+        <a:font script="Bugi" typeface="Leelawadee UI"/>
+        <a:font script="Bopo" typeface="Microsoft JhengHei"/>
+        <a:font script="Java" typeface="Javanese Text"/>
+        <a:font script="Lisu" typeface="Segoe UI"/>
+        <a:font script="Mymr" typeface="Myanmar Text"/>
+        <a:font script="Nkoo" typeface="Ebrima"/>
+        <a:font script="Olck" typeface="Nirmala UI"/>
+        <a:font script="Osma" typeface="Ebrima"/>
+        <a:font script="Phag" typeface="Phagspa"/>
+        <a:font script="Syrn" typeface="Estrangelo Edessa"/>
+        <a:font script="Syrj" typeface="Estrangelo Edessa"/>
+        <a:font script="Syre" typeface="Estrangelo Edessa"/>
+        <a:font script="Sora" typeface="Nirmala UI"/>
+        <a:font script="Tale" typeface="Microsoft Tai Le"/>
+        <a:font script="Talu" typeface="Microsoft New Tai Lue"/>
+        <a:font script="Tfng" typeface="Ebrima"/>
       </a:majorFont>
       <a:minorFont>
-        <a:latin typeface="Calibri"/>
+        <a:latin typeface="Calibri" panose="020F0502020204030204"/>
         <a:ea typeface=""/>
         <a:cs typeface=""/>
-        <a:font script="Jpan" typeface="ＭＳ Ｐゴシック"/>
+        <a:font script="Jpan" typeface="游ゴシック"/>
         <a:font script="Hang" typeface="맑은 고딕"/>
-        <a:font script="Hans" typeface="宋体"/>
+        <a:font script="Hans" typeface="等线"/>
         <a:font script="Hant" typeface="新細明體"/>
         <a:font script="Arab" typeface="Arial"/>
         <a:font script="Hebr" typeface="Arial"/>
@@ -9515,6 +10071,23 @@
         <a:font script="Viet" typeface="Arial"/>
         <a:font script="Uigh" typeface="Microsoft Uighur"/>
         <a:font script="Geor" typeface="Sylfaen"/>
+        <a:font script="Armn" typeface="Arial"/>
+        <a:font script="Bugi" typeface="Leelawadee UI"/>
+        <a:font script="Bopo" typeface="Microsoft JhengHei"/>
+        <a:font script="Java" typeface="Javanese Text"/>
+        <a:font script="Lisu" typeface="Segoe UI"/>
+        <a:font script="Mymr" typeface="Myanmar Text"/>
+        <a:font script="Nkoo" typeface="Ebrima"/>
+        <a:font script="Olck" typeface="Nirmala UI"/>
+        <a:font script="Osma" typeface="Ebrima"/>
+        <a:font script="Phag" typeface="Phagspa"/>
+        <a:font script="Syrn" typeface="Estrangelo Edessa"/>
+        <a:font script="Syrj" typeface="Estrangelo Edessa"/>
+        <a:font script="Syre" typeface="Estrangelo Edessa"/>
+        <a:font script="Sora" typeface="Nirmala UI"/>
+        <a:font script="Tale" typeface="Microsoft Tai Le"/>
+        <a:font script="Talu" typeface="Microsoft New Tai Lue"/>
+        <a:font script="Tfng" typeface="Ebrima"/>
       </a:minorFont>
     </a:fontScheme>
     <a:fmtScheme name="Office">
@@ -9526,200 +10099,141 @@
           <a:gsLst>
             <a:gs pos="0">
               <a:schemeClr val="phClr">
-                <a:tint val="50000"/>
-                <a:satMod val="300000"/>
+                <a:lumMod val="110000"/>
+                <a:satMod val="105000"/>
+                <a:tint val="67000"/>
               </a:schemeClr>
             </a:gs>
-            <a:gs pos="35000">
+            <a:gs pos="50000">
               <a:schemeClr val="phClr">
-                <a:tint val="37000"/>
-                <a:satMod val="300000"/>
+                <a:lumMod val="105000"/>
+                <a:satMod val="103000"/>
+                <a:tint val="73000"/>
               </a:schemeClr>
             </a:gs>
             <a:gs pos="100000">
               <a:schemeClr val="phClr">
-                <a:tint val="15000"/>
-                <a:satMod val="350000"/>
+                <a:lumMod val="105000"/>
+                <a:satMod val="109000"/>
+                <a:tint val="81000"/>
               </a:schemeClr>
             </a:gs>
           </a:gsLst>
-          <a:lin ang="16200000" scaled="1"/>
+          <a:lin ang="5400000" scaled="0"/>
         </a:gradFill>
         <a:gradFill rotWithShape="1">
           <a:gsLst>
             <a:gs pos="0">
               <a:schemeClr val="phClr">
-                <a:tint val="100000"/>
+                <a:satMod val="103000"/>
+                <a:lumMod val="102000"/>
+                <a:tint val="94000"/>
+              </a:schemeClr>
+            </a:gs>
+            <a:gs pos="50000">
+              <a:schemeClr val="phClr">
+                <a:satMod val="110000"/>
+                <a:lumMod val="100000"/>
                 <a:shade val="100000"/>
-                <a:satMod val="130000"/>
               </a:schemeClr>
             </a:gs>
             <a:gs pos="100000">
               <a:schemeClr val="phClr">
-                <a:tint val="50000"/>
-                <a:shade val="100000"/>
-                <a:satMod val="350000"/>
+                <a:lumMod val="99000"/>
+                <a:satMod val="120000"/>
+                <a:shade val="78000"/>
               </a:schemeClr>
             </a:gs>
           </a:gsLst>
-          <a:lin ang="16200000" scaled="0"/>
+          <a:lin ang="5400000" scaled="0"/>
         </a:gradFill>
       </a:fillStyleLst>
       <a:lnStyleLst>
-        <a:ln w="9525" cap="flat" cmpd="sng" algn="ctr">
-          <a:solidFill>
-            <a:schemeClr val="phClr">
-              <a:shade val="95000"/>
-              <a:satMod val="105000"/>
-            </a:schemeClr>
-          </a:solidFill>
-          <a:prstDash val="solid"/>
-        </a:ln>
-        <a:ln w="25400" cap="flat" cmpd="sng" algn="ctr">
+        <a:ln w="6350" cap="flat" cmpd="sng" algn="ctr">
           <a:solidFill>
             <a:schemeClr val="phClr"/>
           </a:solidFill>
           <a:prstDash val="solid"/>
+          <a:miter lim="800000"/>
         </a:ln>
-        <a:ln w="38100" cap="flat" cmpd="sng" algn="ctr">
+        <a:ln w="12700" cap="flat" cmpd="sng" algn="ctr">
           <a:solidFill>
             <a:schemeClr val="phClr"/>
           </a:solidFill>
           <a:prstDash val="solid"/>
+          <a:miter lim="800000"/>
+        </a:ln>
+        <a:ln w="19050" cap="flat" cmpd="sng" algn="ctr">
+          <a:solidFill>
+            <a:schemeClr val="phClr"/>
+          </a:solidFill>
+          <a:prstDash val="solid"/>
+          <a:miter lim="800000"/>
         </a:ln>
       </a:lnStyleLst>
       <a:effectStyleLst>
         <a:effectStyle>
+          <a:effectLst/>
+        </a:effectStyle>
+        <a:effectStyle>
+          <a:effectLst/>
+        </a:effectStyle>
+        <a:effectStyle>
           <a:effectLst>
-            <a:outerShdw blurRad="40000" dist="20000" dir="5400000" rotWithShape="0">
+            <a:outerShdw blurRad="57150" dist="19050" dir="5400000" algn="ctr" rotWithShape="0">
               <a:srgbClr val="000000">
-                <a:alpha val="38000"/>
+                <a:alpha val="63000"/>
               </a:srgbClr>
             </a:outerShdw>
           </a:effectLst>
-        </a:effectStyle>
-        <a:effectStyle>
-          <a:effectLst>
-            <a:outerShdw blurRad="40000" dist="23000" dir="5400000" rotWithShape="0">
-              <a:srgbClr val="000000">
-                <a:alpha val="35000"/>
-              </a:srgbClr>
-            </a:outerShdw>
-          </a:effectLst>
-        </a:effectStyle>
-        <a:effectStyle>
-          <a:effectLst>
-            <a:outerShdw blurRad="40000" dist="23000" dir="5400000" rotWithShape="0">
-              <a:srgbClr val="000000">
-                <a:alpha val="35000"/>
-              </a:srgbClr>
-            </a:outerShdw>
-          </a:effectLst>
-          <a:scene3d>
-            <a:camera prst="orthographicFront">
-              <a:rot lat="0" lon="0" rev="0"/>
-            </a:camera>
-            <a:lightRig rig="threePt" dir="t">
-              <a:rot lat="0" lon="0" rev="1200000"/>
-            </a:lightRig>
-          </a:scene3d>
-          <a:sp3d>
-            <a:bevelT w="63500" h="25400"/>
-          </a:sp3d>
         </a:effectStyle>
       </a:effectStyleLst>
       <a:bgFillStyleLst>
         <a:solidFill>
           <a:schemeClr val="phClr"/>
         </a:solidFill>
+        <a:solidFill>
+          <a:schemeClr val="phClr">
+            <a:tint val="95000"/>
+            <a:satMod val="170000"/>
+          </a:schemeClr>
+        </a:solidFill>
         <a:gradFill rotWithShape="1">
           <a:gsLst>
             <a:gs pos="0">
               <a:schemeClr val="phClr">
-                <a:tint val="40000"/>
-                <a:satMod val="350000"/>
+                <a:tint val="93000"/>
+                <a:satMod val="150000"/>
+                <a:shade val="98000"/>
+                <a:lumMod val="102000"/>
               </a:schemeClr>
             </a:gs>
-            <a:gs pos="40000">
+            <a:gs pos="50000">
               <a:schemeClr val="phClr">
-                <a:tint val="45000"/>
-                <a:shade val="99000"/>
-                <a:satMod val="350000"/>
+                <a:tint val="98000"/>
+                <a:satMod val="130000"/>
+                <a:shade val="90000"/>
+                <a:lumMod val="103000"/>
               </a:schemeClr>
             </a:gs>
             <a:gs pos="100000">
               <a:schemeClr val="phClr">
-                <a:shade val="20000"/>
-                <a:satMod val="255000"/>
+                <a:shade val="63000"/>
+                <a:satMod val="120000"/>
               </a:schemeClr>
             </a:gs>
           </a:gsLst>
-          <a:path path="circle">
-            <a:fillToRect l="50000" t="-80000" r="50000" b="180000"/>
-          </a:path>
-        </a:gradFill>
-        <a:gradFill rotWithShape="1">
-          <a:gsLst>
-            <a:gs pos="0">
-              <a:schemeClr val="phClr">
-                <a:tint val="80000"/>
-                <a:satMod val="300000"/>
-              </a:schemeClr>
-            </a:gs>
-            <a:gs pos="100000">
-              <a:schemeClr val="phClr">
-                <a:shade val="30000"/>
-                <a:satMod val="200000"/>
-              </a:schemeClr>
-            </a:gs>
-          </a:gsLst>
-          <a:path path="circle">
-            <a:fillToRect l="50000" t="50000" r="50000" b="50000"/>
-          </a:path>
+          <a:lin ang="5400000" scaled="0"/>
         </a:gradFill>
       </a:bgFillStyleLst>
     </a:fmtScheme>
   </a:themeElements>
-  <a:objectDefaults>
-    <a:spDef>
-      <a:spPr/>
-      <a:bodyPr/>
-      <a:lstStyle/>
-      <a:style>
-        <a:lnRef idx="1">
-          <a:schemeClr val="accent1"/>
-        </a:lnRef>
-        <a:fillRef idx="3">
-          <a:schemeClr val="accent1"/>
-        </a:fillRef>
-        <a:effectRef idx="2">
-          <a:schemeClr val="accent1"/>
-        </a:effectRef>
-        <a:fontRef idx="minor">
-          <a:schemeClr val="lt1"/>
-        </a:fontRef>
-      </a:style>
-    </a:spDef>
-    <a:lnDef>
-      <a:spPr/>
-      <a:bodyPr/>
-      <a:lstStyle/>
-      <a:style>
-        <a:lnRef idx="2">
-          <a:schemeClr val="accent1"/>
-        </a:lnRef>
-        <a:fillRef idx="0">
-          <a:schemeClr val="accent1"/>
-        </a:fillRef>
-        <a:effectRef idx="1">
-          <a:schemeClr val="accent1"/>
-        </a:effectRef>
-        <a:fontRef idx="minor">
-          <a:schemeClr val="tx1"/>
-        </a:fontRef>
-      </a:style>
-    </a:lnDef>
-  </a:objectDefaults>
+  <a:objectDefaults/>
   <a:extraClrSchemeLst/>
+  <a:extLst>
+    <a:ext uri="{05A4C25C-085E-4340-85A3-A5531E510DB2}">
+      <thm15:themeFamily xmlns:thm15="http://schemas.microsoft.com/office/thememl/2012/main" name="Office Theme" id="{62F939B6-93AF-4DB8-9C6B-D6C7DFDC589F}" vid="{4A3C46E8-61CC-4603-A589-7422A47A8E4A}"/>
+    </a:ext>
+  </a:extLst>
 </a:theme>
 </file>
</xml_diff>

<commit_message>
Add offline speaker script deck
Same 16 slides in the same order as the presentation, but each slide carries
what the presenter should say and point at rather than the audience content.
Built for reading at a lectern: large type, short lines, and one GOAL line per
slide stating what must land if nothing else does.

Structure per slide: GOAL, then SAY lines (spoken near-verbatim), POINT AT in
red for physical gestures, grey notes for background, and IF ASKED in purple
for prepared answers. The three presenters are colour-coded blue/orange/green
and handovers get an explicit bottom strip, so nobody misses their cue.

Condensed from the teaching notes already in the presentation, which are too
dense to read while speaking.
</commit_message>
<xml_diff>
--- a/UNeXt_presentation.pptx
+++ b/UNeXt_presentation.pptx
@@ -320,7 +320,7 @@
           <a:p>
             <a:fld id="{5BCAD085-E8A6-8845-BD4E-CB4CCA059FC4}" type="datetimeFigureOut">
               <a:rPr lang="en-US" smtClean="0"/>
-              <a:t>8/19/2026</a:t>
+              <a:t>8/25/2026</a:t>
             </a:fld>
             <a:endParaRPr lang="en-US"/>
           </a:p>
@@ -488,7 +488,7 @@
           <a:p>
             <a:fld id="{5BCAD085-E8A6-8845-BD4E-CB4CCA059FC4}" type="datetimeFigureOut">
               <a:rPr lang="en-US" smtClean="0"/>
-              <a:t>8/19/2026</a:t>
+              <a:t>8/25/2026</a:t>
             </a:fld>
             <a:endParaRPr lang="en-US"/>
           </a:p>
@@ -666,7 +666,7 @@
           <a:p>
             <a:fld id="{5BCAD085-E8A6-8845-BD4E-CB4CCA059FC4}" type="datetimeFigureOut">
               <a:rPr lang="en-US" smtClean="0"/>
-              <a:t>8/19/2026</a:t>
+              <a:t>8/25/2026</a:t>
             </a:fld>
             <a:endParaRPr lang="en-US"/>
           </a:p>
@@ -834,7 +834,7 @@
           <a:p>
             <a:fld id="{5BCAD085-E8A6-8845-BD4E-CB4CCA059FC4}" type="datetimeFigureOut">
               <a:rPr lang="en-US" smtClean="0"/>
-              <a:t>8/19/2026</a:t>
+              <a:t>8/25/2026</a:t>
             </a:fld>
             <a:endParaRPr lang="en-US"/>
           </a:p>
@@ -1079,7 +1079,7 @@
           <a:p>
             <a:fld id="{5BCAD085-E8A6-8845-BD4E-CB4CCA059FC4}" type="datetimeFigureOut">
               <a:rPr lang="en-US" smtClean="0"/>
-              <a:t>8/19/2026</a:t>
+              <a:t>8/25/2026</a:t>
             </a:fld>
             <a:endParaRPr lang="en-US"/>
           </a:p>
@@ -1364,7 +1364,7 @@
           <a:p>
             <a:fld id="{5BCAD085-E8A6-8845-BD4E-CB4CCA059FC4}" type="datetimeFigureOut">
               <a:rPr lang="en-US" smtClean="0"/>
-              <a:t>8/19/2026</a:t>
+              <a:t>8/25/2026</a:t>
             </a:fld>
             <a:endParaRPr lang="en-US"/>
           </a:p>
@@ -1783,7 +1783,7 @@
           <a:p>
             <a:fld id="{5BCAD085-E8A6-8845-BD4E-CB4CCA059FC4}" type="datetimeFigureOut">
               <a:rPr lang="en-US" smtClean="0"/>
-              <a:t>8/19/2026</a:t>
+              <a:t>8/25/2026</a:t>
             </a:fld>
             <a:endParaRPr lang="en-US"/>
           </a:p>
@@ -1900,7 +1900,7 @@
           <a:p>
             <a:fld id="{5BCAD085-E8A6-8845-BD4E-CB4CCA059FC4}" type="datetimeFigureOut">
               <a:rPr lang="en-US" smtClean="0"/>
-              <a:t>8/19/2026</a:t>
+              <a:t>8/25/2026</a:t>
             </a:fld>
             <a:endParaRPr lang="en-US"/>
           </a:p>
@@ -1995,7 +1995,7 @@
           <a:p>
             <a:fld id="{5BCAD085-E8A6-8845-BD4E-CB4CCA059FC4}" type="datetimeFigureOut">
               <a:rPr lang="en-US" smtClean="0"/>
-              <a:t>8/19/2026</a:t>
+              <a:t>8/25/2026</a:t>
             </a:fld>
             <a:endParaRPr lang="en-US"/>
           </a:p>
@@ -2270,7 +2270,7 @@
           <a:p>
             <a:fld id="{5BCAD085-E8A6-8845-BD4E-CB4CCA059FC4}" type="datetimeFigureOut">
               <a:rPr lang="en-US" smtClean="0"/>
-              <a:t>8/19/2026</a:t>
+              <a:t>8/25/2026</a:t>
             </a:fld>
             <a:endParaRPr lang="en-US"/>
           </a:p>
@@ -2522,7 +2522,7 @@
           <a:p>
             <a:fld id="{5BCAD085-E8A6-8845-BD4E-CB4CCA059FC4}" type="datetimeFigureOut">
               <a:rPr lang="en-US" smtClean="0"/>
-              <a:t>8/19/2026</a:t>
+              <a:t>8/25/2026</a:t>
             </a:fld>
             <a:endParaRPr lang="en-US"/>
           </a:p>
@@ -2733,7 +2733,7 @@
           <a:p>
             <a:fld id="{5BCAD085-E8A6-8845-BD4E-CB4CCA059FC4}" type="datetimeFigureOut">
               <a:rPr lang="en-US" smtClean="0"/>
-              <a:t>8/19/2026</a:t>
+              <a:t>8/25/2026</a:t>
             </a:fld>
             <a:endParaRPr lang="en-US"/>
           </a:p>
@@ -3437,7 +3437,7 @@
         <p:spPr>
           <a:xfrm>
             <a:off x="6766560" y="2834640"/>
-            <a:ext cx="4846320" cy="2011680"/>
+            <a:ext cx="4846320" cy="979755"/>
           </a:xfrm>
           <a:prstGeom prst="rect">
             <a:avLst/>
@@ -3450,7 +3450,7 @@
           </a:bodyPr>
           <a:lstStyle/>
           <a:p>
-            <a:endParaRPr/>
+            <a:endParaRPr dirty="0"/>
           </a:p>
           <a:p>
             <a:pPr>
@@ -3459,7 +3459,7 @@
               </a:spcAft>
             </a:pPr>
             <a:r>
-              <a:rPr sz="1400" b="1" i="0">
+              <a:rPr sz="1400" b="1" i="0" dirty="0">
                 <a:solidFill>
                   <a:srgbClr val="000000"/>
                 </a:solidFill>
@@ -3468,14 +3468,19 @@
               <a:t>Code: </a:t>
             </a:r>
             <a:r>
-              <a:rPr sz="1400" b="0" i="0">
+              <a:rPr lang="en-US" sz="1400" dirty="0">
                 <a:solidFill>
                   <a:srgbClr val="555555"/>
                 </a:solidFill>
-                <a:latin typeface="Calibri"/>
-              </a:rPr>
-              <a:t>&lt;GITHUB / DRIVE LINK&gt;</a:t>
-            </a:r>
+              </a:rPr>
+              <a:t>https://github.com/DavidShenzi/unext-project</a:t>
+            </a:r>
+            <a:endParaRPr sz="1400" b="0" i="0" dirty="0">
+              <a:solidFill>
+                <a:srgbClr val="555555"/>
+              </a:solidFill>
+              <a:latin typeface="Calibri"/>
+            </a:endParaRPr>
           </a:p>
           <a:p>
             <a:pPr>
@@ -3484,7 +3489,7 @@
               </a:spcAft>
             </a:pPr>
             <a:r>
-              <a:rPr sz="1400" b="1" i="0">
+              <a:rPr sz="1400" b="1" i="0" dirty="0">
                 <a:solidFill>
                   <a:srgbClr val="000000"/>
                 </a:solidFill>
@@ -3493,7 +3498,7 @@
               <a:t>Video: </a:t>
             </a:r>
             <a:r>
-              <a:rPr sz="1400" b="0" i="0">
+              <a:rPr sz="1400" b="0" i="0" dirty="0">
                 <a:solidFill>
                   <a:srgbClr val="555555"/>
                 </a:solidFill>
@@ -3513,7 +3518,7 @@
         <p:spPr>
           <a:xfrm>
             <a:off x="548640" y="6199632"/>
-            <a:ext cx="11094415" cy="457200"/>
+            <a:ext cx="11094415" cy="276999"/>
           </a:xfrm>
           <a:prstGeom prst="rect">
             <a:avLst/>
@@ -3526,33 +3531,12 @@
           </a:bodyPr>
           <a:lstStyle/>
           <a:p>
-            <a:r>
-              <a:rPr sz="1200" b="0" i="1">
-                <a:solidFill>
-                  <a:srgbClr val="555555"/>
-                </a:solidFill>
-                <a:latin typeface="Calibri"/>
-              </a:rPr>
-              <a:t>Fill in all placeholders before submitting — missing items are </a:t>
-            </a:r>
-            <a:r>
-              <a:rPr sz="1200" b="0" i="1" dirty="0" err="1">
-                <a:solidFill>
-                  <a:srgbClr val="555555"/>
-                </a:solidFill>
-                <a:latin typeface="Calibri"/>
-              </a:rPr>
-              <a:t>penalised</a:t>
-            </a:r>
-            <a:r>
-              <a:rPr sz="1200" b="0" i="1" dirty="0">
-                <a:solidFill>
-                  <a:srgbClr val="555555"/>
-                </a:solidFill>
-                <a:latin typeface="Calibri"/>
-              </a:rPr>
-              <a:t>. Paste the video link in this slide's comment section as well.</a:t>
-            </a:r>
+            <a:endParaRPr sz="1200" b="0" i="1" dirty="0">
+              <a:solidFill>
+                <a:srgbClr val="555555"/>
+              </a:solidFill>
+              <a:latin typeface="Calibri"/>
+            </a:endParaRPr>
           </a:p>
         </p:txBody>
       </p:sp>

</xml_diff>

<commit_message>
Rebuild the deck without speaker notes
The committed presentation is now the stripped copy: 17 slides, zero notesSlide
parts, nothing in the package to recover. The presenting copy with notes lives in
UNeXt_presentation_NOTES.pptx, which is gitignored.

Co-Authored-By: Claude Opus 5 <noreply@anthropic.com>
</commit_message>
<xml_diff>
--- a/UNeXt_presentation.pptx
+++ b/UNeXt_presentation.pptx
@@ -121,6 +121,356 @@
     </a:lvl9pPr>
   </p:defaultTextStyle>
 </p:presentation>
+</file>
+
+<file path=ppt/notesMasters/notesMaster1.xml><?xml version="1.0" encoding="utf-8"?>
+<p:notesMaster xmlns:a="http://schemas.openxmlformats.org/drawingml/2006/main" xmlns:p="http://schemas.openxmlformats.org/presentationml/2006/main" xmlns:r="http://schemas.openxmlformats.org/officeDocument/2006/relationships">
+  <p:cSld>
+    <p:bg>
+      <p:bgRef idx="1001">
+        <a:schemeClr val="bg1"/>
+      </p:bgRef>
+    </p:bg>
+    <p:spTree>
+      <p:nvGrpSpPr>
+        <p:cNvPr id="1" name=""/>
+        <p:cNvGrpSpPr/>
+        <p:nvPr/>
+      </p:nvGrpSpPr>
+      <p:grpSpPr>
+        <a:xfrm>
+          <a:off x="0" y="0"/>
+          <a:ext cx="0" cy="0"/>
+          <a:chOff x="0" y="0"/>
+          <a:chExt cx="0" cy="0"/>
+        </a:xfrm>
+      </p:grpSpPr>
+      <p:sp>
+        <p:nvSpPr>
+          <p:cNvPr id="2" name="Header Placeholder 1"/>
+          <p:cNvSpPr>
+            <a:spLocks noGrp="1"/>
+          </p:cNvSpPr>
+          <p:nvPr>
+            <p:ph type="hdr" sz="quarter"/>
+          </p:nvPr>
+        </p:nvSpPr>
+        <p:spPr>
+          <a:xfrm>
+            <a:off x="0" y="0"/>
+            <a:ext cx="2971800" cy="457200"/>
+          </a:xfrm>
+          <a:prstGeom prst="rect">
+            <a:avLst/>
+          </a:prstGeom>
+        </p:spPr>
+        <p:txBody>
+          <a:bodyPr vert="horz" lIns="91440" tIns="45720" rIns="91440" bIns="45720" rtlCol="0"/>
+          <a:lstStyle>
+            <a:lvl1pPr algn="l">
+              <a:defRPr sz="1200"/>
+            </a:lvl1pPr>
+          </a:lstStyle>
+          <a:p>
+            <a:endParaRPr lang="en-US"/>
+          </a:p>
+        </p:txBody>
+      </p:sp>
+      <p:sp>
+        <p:nvSpPr>
+          <p:cNvPr id="3" name="Date Placeholder 2"/>
+          <p:cNvSpPr>
+            <a:spLocks noGrp="1"/>
+          </p:cNvSpPr>
+          <p:nvPr>
+            <p:ph type="dt" idx="1"/>
+          </p:nvPr>
+        </p:nvSpPr>
+        <p:spPr>
+          <a:xfrm>
+            <a:off x="3884613" y="0"/>
+            <a:ext cx="2971800" cy="457200"/>
+          </a:xfrm>
+          <a:prstGeom prst="rect">
+            <a:avLst/>
+          </a:prstGeom>
+        </p:spPr>
+        <p:txBody>
+          <a:bodyPr vert="horz" lIns="91440" tIns="45720" rIns="91440" bIns="45720" rtlCol="0"/>
+          <a:lstStyle>
+            <a:lvl1pPr algn="r">
+              <a:defRPr sz="1200"/>
+            </a:lvl1pPr>
+          </a:lstStyle>
+          <a:p>
+            <a:fld id="{0F89C1C7-3DCD-1040-A9CF-14679D8B5DDD}" type="datetimeFigureOut">
+              <a:rPr lang="en-US" smtClean="0"/>
+              <a:t>10/17/16</a:t>
+            </a:fld>
+            <a:endParaRPr lang="en-US"/>
+          </a:p>
+        </p:txBody>
+      </p:sp>
+      <p:sp>
+        <p:nvSpPr>
+          <p:cNvPr id="4" name="Slide Image Placeholder 3"/>
+          <p:cNvSpPr>
+            <a:spLocks noGrp="1" noRot="1" noChangeAspect="1"/>
+          </p:cNvSpPr>
+          <p:nvPr>
+            <p:ph type="sldImg" idx="2"/>
+          </p:nvPr>
+        </p:nvSpPr>
+        <p:spPr>
+          <a:xfrm>
+            <a:off x="1143000" y="685800"/>
+            <a:ext cx="4572000" cy="3429000"/>
+          </a:xfrm>
+          <a:prstGeom prst="rect">
+            <a:avLst/>
+          </a:prstGeom>
+          <a:noFill/>
+          <a:ln w="12700">
+            <a:solidFill>
+              <a:prstClr val="black"/>
+            </a:solidFill>
+          </a:ln>
+        </p:spPr>
+        <p:txBody>
+          <a:bodyPr vert="horz" lIns="91440" tIns="45720" rIns="91440" bIns="45720" rtlCol="0" anchor="ctr"/>
+          <a:lstStyle/>
+          <a:p>
+            <a:endParaRPr lang="en-US"/>
+          </a:p>
+        </p:txBody>
+      </p:sp>
+      <p:sp>
+        <p:nvSpPr>
+          <p:cNvPr id="5" name="Notes Placeholder 4"/>
+          <p:cNvSpPr>
+            <a:spLocks noGrp="1"/>
+          </p:cNvSpPr>
+          <p:nvPr>
+            <p:ph type="body" sz="quarter" idx="3"/>
+          </p:nvPr>
+        </p:nvSpPr>
+        <p:spPr>
+          <a:xfrm>
+            <a:off x="685800" y="4343400"/>
+            <a:ext cx="5486400" cy="4114800"/>
+          </a:xfrm>
+          <a:prstGeom prst="rect">
+            <a:avLst/>
+          </a:prstGeom>
+        </p:spPr>
+        <p:txBody>
+          <a:bodyPr vert="horz" lIns="91440" tIns="45720" rIns="91440" bIns="45720" rtlCol="0"/>
+          <a:lstStyle/>
+          <a:p>
+            <a:pPr lvl="0"/>
+            <a:r>
+              <a:rPr lang="en-US" smtClean="0"/>
+              <a:t>Click to edit Master text styles</a:t>
+            </a:r>
+          </a:p>
+          <a:p>
+            <a:pPr lvl="1"/>
+            <a:r>
+              <a:rPr lang="en-US" smtClean="0"/>
+              <a:t>Second level</a:t>
+            </a:r>
+          </a:p>
+          <a:p>
+            <a:pPr lvl="2"/>
+            <a:r>
+              <a:rPr lang="en-US" smtClean="0"/>
+              <a:t>Third level</a:t>
+            </a:r>
+          </a:p>
+          <a:p>
+            <a:pPr lvl="3"/>
+            <a:r>
+              <a:rPr lang="en-US" smtClean="0"/>
+              <a:t>Fourth level</a:t>
+            </a:r>
+          </a:p>
+          <a:p>
+            <a:pPr lvl="4"/>
+            <a:r>
+              <a:rPr lang="en-US" smtClean="0"/>
+              <a:t>Fifth level</a:t>
+            </a:r>
+            <a:endParaRPr lang="en-US"/>
+          </a:p>
+        </p:txBody>
+      </p:sp>
+      <p:sp>
+        <p:nvSpPr>
+          <p:cNvPr id="6" name="Footer Placeholder 5"/>
+          <p:cNvSpPr>
+            <a:spLocks noGrp="1"/>
+          </p:cNvSpPr>
+          <p:nvPr>
+            <p:ph type="ftr" sz="quarter" idx="4"/>
+          </p:nvPr>
+        </p:nvSpPr>
+        <p:spPr>
+          <a:xfrm>
+            <a:off x="0" y="8685213"/>
+            <a:ext cx="2971800" cy="457200"/>
+          </a:xfrm>
+          <a:prstGeom prst="rect">
+            <a:avLst/>
+          </a:prstGeom>
+        </p:spPr>
+        <p:txBody>
+          <a:bodyPr vert="horz" lIns="91440" tIns="45720" rIns="91440" bIns="45720" rtlCol="0" anchor="b"/>
+          <a:lstStyle>
+            <a:lvl1pPr algn="l">
+              <a:defRPr sz="1200"/>
+            </a:lvl1pPr>
+          </a:lstStyle>
+          <a:p>
+            <a:endParaRPr lang="en-US"/>
+          </a:p>
+        </p:txBody>
+      </p:sp>
+      <p:sp>
+        <p:nvSpPr>
+          <p:cNvPr id="7" name="Slide Number Placeholder 6"/>
+          <p:cNvSpPr>
+            <a:spLocks noGrp="1"/>
+          </p:cNvSpPr>
+          <p:nvPr>
+            <p:ph type="sldNum" sz="quarter" idx="5"/>
+          </p:nvPr>
+        </p:nvSpPr>
+        <p:spPr>
+          <a:xfrm>
+            <a:off x="3884613" y="8685213"/>
+            <a:ext cx="2971800" cy="457200"/>
+          </a:xfrm>
+          <a:prstGeom prst="rect">
+            <a:avLst/>
+          </a:prstGeom>
+        </p:spPr>
+        <p:txBody>
+          <a:bodyPr vert="horz" lIns="91440" tIns="45720" rIns="91440" bIns="45720" rtlCol="0" anchor="b"/>
+          <a:lstStyle>
+            <a:lvl1pPr algn="r">
+              <a:defRPr sz="1200"/>
+            </a:lvl1pPr>
+          </a:lstStyle>
+          <a:p>
+            <a:fld id="{BB5E49A5-4136-284D-997B-48E1D791AD67}" type="slidenum">
+              <a:rPr lang="en-US" smtClean="0"/>
+              <a:t>‹#›</a:t>
+            </a:fld>
+            <a:endParaRPr lang="en-US"/>
+          </a:p>
+        </p:txBody>
+      </p:sp>
+    </p:spTree>
+    <p:extLst>
+      <p:ext uri="{BB962C8B-B14F-4D97-AF65-F5344CB8AC3E}">
+        <p14:creationId xmlns:p14="http://schemas.microsoft.com/office/powerpoint/2010/main" val="2623252185"/>
+      </p:ext>
+    </p:extLst>
+  </p:cSld>
+  <p:clrMap bg1="lt1" tx1="dk1" bg2="lt2" tx2="dk2" accent1="accent1" accent2="accent2" accent3="accent3" accent4="accent4" accent5="accent5" accent6="accent6" hlink="hlink" folHlink="folHlink"/>
+  <p:notesStyle>
+    <a:lvl1pPr marL="0" algn="l" defTabSz="457200" rtl="0" eaLnBrk="1" latinLnBrk="0" hangingPunct="1">
+      <a:defRPr sz="1200" kern="1200">
+        <a:solidFill>
+          <a:schemeClr val="tx1"/>
+        </a:solidFill>
+        <a:latin typeface="+mn-lt"/>
+        <a:ea typeface="+mn-ea"/>
+        <a:cs typeface="+mn-cs"/>
+      </a:defRPr>
+    </a:lvl1pPr>
+    <a:lvl2pPr marL="457200" algn="l" defTabSz="457200" rtl="0" eaLnBrk="1" latinLnBrk="0" hangingPunct="1">
+      <a:defRPr sz="1200" kern="1200">
+        <a:solidFill>
+          <a:schemeClr val="tx1"/>
+        </a:solidFill>
+        <a:latin typeface="+mn-lt"/>
+        <a:ea typeface="+mn-ea"/>
+        <a:cs typeface="+mn-cs"/>
+      </a:defRPr>
+    </a:lvl2pPr>
+    <a:lvl3pPr marL="914400" algn="l" defTabSz="457200" rtl="0" eaLnBrk="1" latinLnBrk="0" hangingPunct="1">
+      <a:defRPr sz="1200" kern="1200">
+        <a:solidFill>
+          <a:schemeClr val="tx1"/>
+        </a:solidFill>
+        <a:latin typeface="+mn-lt"/>
+        <a:ea typeface="+mn-ea"/>
+        <a:cs typeface="+mn-cs"/>
+      </a:defRPr>
+    </a:lvl3pPr>
+    <a:lvl4pPr marL="1371600" algn="l" defTabSz="457200" rtl="0" eaLnBrk="1" latinLnBrk="0" hangingPunct="1">
+      <a:defRPr sz="1200" kern="1200">
+        <a:solidFill>
+          <a:schemeClr val="tx1"/>
+        </a:solidFill>
+        <a:latin typeface="+mn-lt"/>
+        <a:ea typeface="+mn-ea"/>
+        <a:cs typeface="+mn-cs"/>
+      </a:defRPr>
+    </a:lvl4pPr>
+    <a:lvl5pPr marL="1828800" algn="l" defTabSz="457200" rtl="0" eaLnBrk="1" latinLnBrk="0" hangingPunct="1">
+      <a:defRPr sz="1200" kern="1200">
+        <a:solidFill>
+          <a:schemeClr val="tx1"/>
+        </a:solidFill>
+        <a:latin typeface="+mn-lt"/>
+        <a:ea typeface="+mn-ea"/>
+        <a:cs typeface="+mn-cs"/>
+      </a:defRPr>
+    </a:lvl5pPr>
+    <a:lvl6pPr marL="2286000" algn="l" defTabSz="457200" rtl="0" eaLnBrk="1" latinLnBrk="0" hangingPunct="1">
+      <a:defRPr sz="1200" kern="1200">
+        <a:solidFill>
+          <a:schemeClr val="tx1"/>
+        </a:solidFill>
+        <a:latin typeface="+mn-lt"/>
+        <a:ea typeface="+mn-ea"/>
+        <a:cs typeface="+mn-cs"/>
+      </a:defRPr>
+    </a:lvl6pPr>
+    <a:lvl7pPr marL="2743200" algn="l" defTabSz="457200" rtl="0" eaLnBrk="1" latinLnBrk="0" hangingPunct="1">
+      <a:defRPr sz="1200" kern="1200">
+        <a:solidFill>
+          <a:schemeClr val="tx1"/>
+        </a:solidFill>
+        <a:latin typeface="+mn-lt"/>
+        <a:ea typeface="+mn-ea"/>
+        <a:cs typeface="+mn-cs"/>
+      </a:defRPr>
+    </a:lvl7pPr>
+    <a:lvl8pPr marL="3200400" algn="l" defTabSz="457200" rtl="0" eaLnBrk="1" latinLnBrk="0" hangingPunct="1">
+      <a:defRPr sz="1200" kern="1200">
+        <a:solidFill>
+          <a:schemeClr val="tx1"/>
+        </a:solidFill>
+        <a:latin typeface="+mn-lt"/>
+        <a:ea typeface="+mn-ea"/>
+        <a:cs typeface="+mn-cs"/>
+      </a:defRPr>
+    </a:lvl8pPr>
+    <a:lvl9pPr marL="3657600" algn="l" defTabSz="457200" rtl="0" eaLnBrk="1" latinLnBrk="0" hangingPunct="1">
+      <a:defRPr sz="1200" kern="1200">
+        <a:solidFill>
+          <a:schemeClr val="tx1"/>
+        </a:solidFill>
+        <a:latin typeface="+mn-lt"/>
+        <a:ea typeface="+mn-ea"/>
+        <a:cs typeface="+mn-cs"/>
+      </a:defRPr>
+    </a:lvl9pPr>
+  </p:notesStyle>
+</p:notesMaster>
 </file>
 
 <file path=ppt/slideLayouts/slideLayout1.xml><?xml version="1.0" encoding="utf-8"?>
@@ -6055,7 +6405,7 @@
                 </a:solidFill>
                 <a:latin typeface="Calibri"/>
               </a:rPr>
-              <a:t>The loss shifts the model toward finding tumour, at some cost in false alarms</a:t>
+              <a:t>A small shift toward recall — but only one split shows it clearly</a:t>
             </a:r>
           </a:p>
         </p:txBody>
@@ -6076,8 +6426,8 @@
         </p:blipFill>
         <p:spPr>
           <a:xfrm>
-            <a:off x="2804007" y="1371600"/>
-            <a:ext cx="6583680" cy="3931920"/>
+            <a:off x="2255367" y="1371600"/>
+            <a:ext cx="7680960" cy="3931920"/>
           </a:xfrm>
           <a:prstGeom prst="rect">
             <a:avLst/>
@@ -6113,7 +6463,7 @@
                 </a:solidFill>
                 <a:latin typeface="Calibri"/>
               </a:rPr>
-              <a:t>Recall +0.065, precision −0.042 — the asymmetry the Tversky β&gt;α weighting was chosen to produce. Clinically the right direction: a missed tumour costs more than a second look.</a:t>
+              <a:t>Averaged over six paired runs: recall +0.017, precision −0.012. The direction matches what the loss was designed to do, but the size is small and one split (43) accounts for most of it.</a:t>
             </a:r>
           </a:p>
         </p:txBody>

</xml_diff>